<commit_message>
docs: update documentation, deck, evidence and CI for the new features
Twelve-step demo and evidence, technical documentation (sections 2.10 to 2.12), security matrix and
risk R18, blueprint addendum, README, video script, deck slides, screenshots and a CI
dependency-audit job (pip-audit and npm audit, both clean).
</commit_message>
<xml_diff>
--- a/submission/StudyRoute_Deck.pptx
+++ b/submission/StudyRoute_Deck.pptx
@@ -116,32 +116,32 @@
   <p:extLst>
     <p:ext uri="{521415D9-36F7-43E2-AB2F-B90AF26B5E84}">
       <p14:sectionLst xmlns:p14="http://schemas.microsoft.com/office/powerpoint/2010/main">
-        <p14:section name="Opening" id="{5fe96e16-0efc-7a3c-7182-c3a674d91c23}">
+        <p14:section name="Opening" id="{7f63dde5-eded-e319-570a-1d1a19fcbcc3}">
           <p14:sldIdLst>
             <p14:sldId id="256"/>
             <p14:sldId id="257"/>
           </p14:sldIdLst>
         </p14:section>
-        <p14:section name="The problem" id="{335d41aa-3549-e481-1f83-8500560ec38b}">
+        <p14:section name="The problem" id="{1fe8b8c4-49d3-9951-ad74-dd1bb36836c1}">
           <p14:sldIdLst>
             <p14:sldId id="258"/>
             <p14:sldId id="259"/>
           </p14:sldIdLst>
         </p14:section>
-        <p14:section name="The solution" id="{dbed8712-8882-3747-9354-23d2f1b9f005}">
+        <p14:section name="The solution" id="{a5ed70e0-0173-14dc-dbea-a4b1c8f43e1b}">
           <p14:sldIdLst>
             <p14:sldId id="260"/>
             <p14:sldId id="261"/>
           </p14:sldIdLst>
         </p14:section>
-        <p14:section name="Trust" id="{3fcd2050-f4e2-29ee-a9ba-2281ac9889f3}">
+        <p14:section name="Trust" id="{55ada93e-5a7f-0f7e-592f-4ad9ef56964f}">
           <p14:sldIdLst>
             <p14:sldId id="262"/>
             <p14:sldId id="263"/>
             <p14:sldId id="264"/>
           </p14:sldIdLst>
         </p14:section>
-        <p14:section name="Close" id="{3c886b98-ab1c-8308-b204-a91d82604b35}">
+        <p14:section name="Close" id="{da641730-c6d4-3dda-cde9-118e3700f2b3}">
           <p14:sldIdLst>
             <p14:sldId id="265"/>
           </p14:sldIdLst>
@@ -1287,7 +1287,7 @@
           <a:p>
             <a:r>
               <a:rPr lang="en-US" dirty="0"/>
-              <a:t>This is task completion. On the left is the compare screen. On the right, the agent and the person share the work. The agent ranks providers by true cost, plans the deadline and the document list, and then blocks the payment until KYC, the recipient allowlist and the sandbox caps all pass. The person creates the draft, chooses the recipient and approves with a fresh MFA code. The agent then tracks the payment to settled and every step is logged. The assistant can propose a draft or an approval request, but a person always clicks.</a:t>
+              <a:t>This is task completion. On the left, the parent typed one sentence into the chat: I need to pay ten thousand pounds of tuition by 28 October. The agent read it, made the quote, ranked the providers, planned the deadline and checked KYC, the recipient and the documents, and it built this plan card from the engine's output. On the right, the agent and the person share the work. The person creates the draft, chooses the recipient and approves with a fresh MFA code. The agent blocks the payment until KYC, the allowlist and the sandbox caps pass, then tracks it to settled and seals a compliance report. Look at what the agent did not do: it created no payment. It can propose a draft, but a person always clicks.</a:t>
             </a:r>
             <a:endParaRPr lang="en-US" dirty="0"/>
           </a:p>
@@ -1375,7 +1375,7 @@
           <a:p>
             <a:r>
               <a:rPr lang="en-US" dirty="0"/>
-              <a:t>Every number comes from a deterministic engine: integer minor units, decimal rates, no floats. For one provider, total cost is the FX margin plus the fixed fee, the SWIFT fee, any fees the sender pays under OUR, plus a shortfall when fees are deducted from the amount. We rank by that percentage. In our synthetic example, Provider B is first at 1.58 percent, Provider C looks cheap but it is quoted as SHA, so the university would receive 35 pounds less, and Provider A is third at 2.16 percent. On the right is where Provider B's 25,300 taka goes: 16,000 is the margin, 3,000 the fixed fee, 1,500 the SWIFT fee and 4,800 the fees we pay under OUR.</a:t>
+              <a:t>Every number comes from a deterministic engine: integer minor units, decimal rates, no floats. For one provider, total cost is the FX margin plus the fixed fee, the SWIFT fee, any fees the sender pays under OUR, plus a shortfall when fees are deducted from the amount. We rank by that percentage. In our synthetic example, Provider B is first at 1.58 percent, Provider C looks cheap but it is quoted as SHA, so the university would receive 35 pounds less, and Provider A is third at 2.16 percent. On the right is where Provider B's 25,300 taka goes: 16,000 is the margin, 3,000 the fixed fee, 1,500 the SWIFT fee and 4,800 the fees we pay under OUR. The same engine powers the smart send plan: fixed fees are paid on every transfer, so sending 12,000 pounds of living costs all at once costs 28,500 taka against 68,400 monthly. It does not predict exchange rates, and says so.</a:t>
             </a:r>
             <a:endParaRPr lang="en-US" dirty="0"/>
           </a:p>
@@ -1551,7 +1551,7 @@
           <a:p>
             <a:r>
               <a:rPr lang="en-US" dirty="0"/>
-              <a:t>Security and compliance is thirty percent of the score, so we made it checkable. On the left are the permission tiers, enforced in the domain layer, not just in the screens. Public, read, prepare, decide, and administer. Deciding, meaning approving a payment, is only for a human parent with a fresh MFA proof bound to that payment and to the hash of the summary they saw. The AI has no approve, cancel, limit or config permission at all. On the right, the numbers: 483 backend and 52 frontend tests, all 24 blueprint scenarios mapped to tests, and 17 known risks that we list openly in the self-assessment. The audit log is hash-chained: Verify passes, we edit one row behind the application's back, and Verify fails at exactly that event. The threat matrix with a proof for each row is in the repository.</a:t>
+              <a:t>Security and compliance is thirty percent of the score, so we made it checkable. On the left are the permission tiers, enforced in the domain layer, not just in the screens. Public, read, prepare, decide, and administer. Deciding, meaning approving a payment, is only for a human parent with a fresh MFA proof bound to that payment and to the hash of the summary they saw. The AI has no approve, cancel, limit or config permission at all. On the right, the numbers: 565 backend and 75 frontend tests, all 24 blueprint scenarios mapped to tests, and 18 known risks that we list openly in the self-assessment. The audit log is hash-chained: Verify passes, we edit one row behind the application's back, and Verify fails at exactly that event. Each payment also gets a compliance report whose hash your browser can recompute. The threat matrix with a proof for each row is in the repository.</a:t>
             </a:r>
             <a:endParaRPr lang="en-US" dirty="0"/>
           </a:p>
@@ -1639,7 +1639,7 @@
           <a:p>
             <a:r>
               <a:rPr lang="en-US" dirty="0"/>
-              <a:t>Honesty is a feature. A banner on every screen and an X-Sandbox header on every API response say this is a sandbox. The Sandbox screen on the left lists everything that is simulated and how to trigger the edge cases, such as a recipient named FAIL_TEST. Any rule that has not been checked against an official source carries a yellow Not verified badge and the sentence: indicative, confirm with your AD bank. On the right is the audit log with the hash chain verified. The sandbox operation logs from a real run, including the tamper demo, are in the repository under submission slash evidence.</a:t>
+              <a:t>Honesty is a feature. A banner on every screen and an X-Sandbox header on every API response say this is a sandbox. The Sandbox screen on the left lists everything that is simulated and how to trigger the edge cases, such as a recipient named FAIL_TEST. Any rule that has not been checked against an official source carries a yellow Not verified badge and the sentence: indicative, confirm with your AD bank. On the right is a payment's compliance report: the parties, ten controls with their evidence, the approval proof and the audit trail, sealed with a hash that the browser recomputes. Change a copy and it says does not match. The sandbox operation logs from a real run, including the tamper demo, are in the repository under submission slash evidence.</a:t>
             </a:r>
             <a:endParaRPr lang="en-US" dirty="0"/>
           </a:p>
@@ -5338,7 +5338,7 @@
       </p:sp>
       <p:pic>
         <p:nvPicPr>
-          <p:cNvPr id="4" name="content-5-image-2" descr="Compare screen ranking providers with a shortfall warning">    </p:cNvPr>
+          <p:cNvPr id="4" name="content-5-image-2" descr="The assistant's payment plan built from one sentence">    </p:cNvPr>
           <p:cNvPicPr>
             <a:picLocks noChangeAspect="1"/>
           </p:cNvPicPr>
@@ -5390,7 +5390,7 @@
                   <a:schemeClr val="tx2"/>
                 </a:solidFill>
               </a:rPr>
-              <a:t>Compare screen. Synthetic data.</a:t>
+              <a:t>One sentence in the chat. Synthetic data.</a:t>
             </a:r>
             <a:endParaRPr lang="en-US" sz="1100" dirty="0"/>
           </a:p>
@@ -5484,7 +5484,7 @@
                   <a:schemeClr val="tx1"/>
                 </a:solidFill>
               </a:rPr>
-              <a:t>Ranks providers by true cost</a:t>
+              <a:t>Reads one sentence, makes the quote</a:t>
             </a:r>
             <a:endParaRPr lang="en-US" sz="1400" dirty="0"/>
           </a:p>
@@ -5578,7 +5578,7 @@
                   <a:schemeClr val="tx1"/>
                 </a:solidFill>
               </a:rPr>
-              <a:t>Plans deadline and documents</a:t>
+              <a:t>Ranks, plans deadline, checks KYC</a:t>
             </a:r>
             <a:endParaRPr lang="en-US" sz="1400" dirty="0"/>
           </a:p>
@@ -5954,7 +5954,7 @@
                   <a:schemeClr val="tx1"/>
                 </a:solidFill>
               </a:rPr>
-              <a:t>Tracks to SETTLED, logs it all</a:t>
+              <a:t>Tracks to SETTLED, seals a report</a:t>
             </a:r>
             <a:endParaRPr lang="en-US" sz="1400" dirty="0"/>
           </a:p>
@@ -7354,12 +7354,12 @@
               <a:buNone/>
             </a:pPr>
             <a:r>
-              <a:rPr lang="en-US" sz="1200" dirty="0">
-                <a:solidFill>
-                  <a:schemeClr val="tx2"/>
-                </a:solidFill>
-              </a:rPr>
-              <a:t>Example: GBP 10,000 at a mid rate of 160.00 BDT per GBP. Synthetic rates and fees.</a:t>
+              <a:rPr lang="en-US" sz="1200" b="1" dirty="0">
+                <a:solidFill>
+                  <a:schemeClr val="tx1"/>
+                </a:solidFill>
+              </a:rPr>
+              <a:t>Smart send plan: the same GBP 12,000 costs BDT 68,400 sent monthly and BDT 28,500 sent at once. Synthetic rates.</a:t>
             </a:r>
             <a:endParaRPr lang="en-US" sz="1200" dirty="0"/>
           </a:p>
@@ -8367,7 +8367,7 @@
                   <a:schemeClr val="tx2"/>
                 </a:solidFill>
               </a:rPr>
-              <a:t>No tool can approve, submit, cancel or change limits. A human approves with MFA.</a:t>
+              <a:t>It may make a quote. It cannot create a payment, approve, submit or cancel. A human approves with MFA.</a:t>
             </a:r>
             <a:endParaRPr lang="en-US" sz="1400" dirty="0"/>
           </a:p>
@@ -9002,7 +9002,7 @@
                 <a:ea typeface="+mj-lt" pitchFamily="34" charset="-122"/>
                 <a:cs typeface="+mj-lt" pitchFamily="34" charset="-120"/>
               </a:rPr>
-              <a:t>483</a:t>
+              <a:t>565</a:t>
             </a:r>
             <a:endParaRPr lang="en-US" sz="3200" dirty="0"/>
           </a:p>
@@ -9099,7 +9099,7 @@
                 <a:ea typeface="+mj-lt" pitchFamily="34" charset="-122"/>
                 <a:cs typeface="+mj-lt" pitchFamily="34" charset="-120"/>
               </a:rPr>
-              <a:t>52</a:t>
+              <a:t>75</a:t>
             </a:r>
             <a:endParaRPr lang="en-US" sz="3200" dirty="0"/>
           </a:p>
@@ -9293,7 +9293,7 @@
                 <a:ea typeface="+mj-lt" pitchFamily="34" charset="-122"/>
                 <a:cs typeface="+mj-lt" pitchFamily="34" charset="-120"/>
               </a:rPr>
-              <a:t>17</a:t>
+              <a:t>18</a:t>
             </a:r>
             <a:endParaRPr lang="en-US" sz="3200" dirty="0"/>
           </a:p>
@@ -9365,7 +9365,7 @@
                   <a:schemeClr val="tx2"/>
                 </a:solidFill>
               </a:rPr>
-              <a:t>Audit chain: Verify PASS, edit one row, Verify FAIL at that event. Every threat has a test: docs/SECURITY.md</a:t>
+              <a:t>Each payment has a compliance report with a hash your browser can check. Every threat has a test: docs/SECURITY.md</a:t>
             </a:r>
             <a:endParaRPr lang="en-US" sz="1200" dirty="0"/>
           </a:p>
@@ -9567,7 +9567,7 @@
       </p:sp>
       <p:pic>
         <p:nvPicPr>
-          <p:cNvPr id="7" name="content-9-image-5" descr="Audit log with Verify showing PASS">    </p:cNvPr>
+          <p:cNvPr id="7" name="content-9-image-5" descr="Compliance report whose hash verifies in the browser">    </p:cNvPr>
           <p:cNvPicPr>
             <a:picLocks noChangeAspect="1"/>
           </p:cNvPicPr>
@@ -9655,7 +9655,7 @@
                   <a:schemeClr val="tx2"/>
                 </a:solidFill>
               </a:rPr>
-              <a:t>Audit log: the hash chain verifies</a:t>
+              <a:t>Compliance report: the hash verifies in the browser</a:t>
             </a:r>
             <a:endParaRPr lang="en-US" sz="1100" dirty="0"/>
           </a:p>

</xml_diff>

<commit_message>
docs: regenerate test cases and rebuild the deck for 601 backend tests
</commit_message>
<xml_diff>
--- a/submission/StudyRoute_Deck.pptx
+++ b/submission/StudyRoute_Deck.pptx
@@ -116,32 +116,32 @@
   <p:extLst>
     <p:ext uri="{521415D9-36F7-43E2-AB2F-B90AF26B5E84}">
       <p14:sectionLst xmlns:p14="http://schemas.microsoft.com/office/powerpoint/2010/main">
-        <p14:section name="Opening" id="{7f63dde5-eded-e319-570a-1d1a19fcbcc3}">
+        <p14:section name="Opening" id="{2b1353e0-a432-3556-d824-ea20d787e8c1}">
           <p14:sldIdLst>
             <p14:sldId id="256"/>
             <p14:sldId id="257"/>
           </p14:sldIdLst>
         </p14:section>
-        <p14:section name="The problem" id="{1fe8b8c4-49d3-9951-ad74-dd1bb36836c1}">
+        <p14:section name="The problem" id="{5d143097-ae83-9559-e8de-7e81526cf57f}">
           <p14:sldIdLst>
             <p14:sldId id="258"/>
             <p14:sldId id="259"/>
           </p14:sldIdLst>
         </p14:section>
-        <p14:section name="The solution" id="{a5ed70e0-0173-14dc-dbea-a4b1c8f43e1b}">
+        <p14:section name="The solution" id="{0c624ef0-a17c-861f-9969-4218105457d3}">
           <p14:sldIdLst>
             <p14:sldId id="260"/>
             <p14:sldId id="261"/>
           </p14:sldIdLst>
         </p14:section>
-        <p14:section name="Trust" id="{55ada93e-5a7f-0f7e-592f-4ad9ef56964f}">
+        <p14:section name="Trust" id="{147f3bea-18c2-5dfb-04b9-88548ae260fa}">
           <p14:sldIdLst>
             <p14:sldId id="262"/>
             <p14:sldId id="263"/>
             <p14:sldId id="264"/>
           </p14:sldIdLst>
         </p14:section>
-        <p14:section name="Close" id="{da641730-c6d4-3dda-cde9-118e3700f2b3}">
+        <p14:section name="Close" id="{5567e6e9-e95d-01bd-0308-72ff0c12117f}">
           <p14:sldIdLst>
             <p14:sldId id="265"/>
           </p14:sldIdLst>
@@ -1551,7 +1551,7 @@
           <a:p>
             <a:r>
               <a:rPr lang="en-US" dirty="0"/>
-              <a:t>Security and compliance is thirty percent of the score, so we made it checkable. On the left are the permission tiers, enforced in the domain layer, not just in the screens. Public, read, prepare, decide, and administer. Deciding, meaning approving a payment, is only for a human parent with a fresh MFA proof bound to that payment and to the hash of the summary they saw. The AI has no approve, cancel, limit or config permission at all. On the right, the numbers: 565 backend and 75 frontend tests, all 24 blueprint scenarios mapped to tests, and 18 known risks that we list openly in the self-assessment. The audit log is hash-chained: Verify passes, we edit one row behind the application's back, and Verify fails at exactly that event. Each payment also gets a compliance report whose hash your browser can recompute. The threat matrix with a proof for each row is in the repository.</a:t>
+              <a:t>Security and compliance is thirty percent of the score, so we made it checkable. On the left are the permission tiers, enforced in the domain layer, not just in the screens. Public, read, prepare, decide, and administer. Deciding, meaning approving a payment, is only for a human parent with a fresh MFA proof bound to that payment and to the hash of the summary they saw. The AI has no approve, cancel, limit or config permission at all. On the right, the numbers: 601 backend and 75 frontend tests, all 24 blueprint scenarios mapped to tests, and 18 known risks that we list openly in the self-assessment. The audit log is hash-chained: Verify passes, we edit one row behind the application's back, and Verify fails at exactly that event. Each payment also gets a compliance report whose hash your browser can recompute. The threat matrix with a proof for each row is in the repository.</a:t>
             </a:r>
             <a:endParaRPr lang="en-US" dirty="0"/>
           </a:p>
@@ -9002,7 +9002,7 @@
                 <a:ea typeface="+mj-lt" pitchFamily="34" charset="-122"/>
                 <a:cs typeface="+mj-lt" pitchFamily="34" charset="-120"/>
               </a:rPr>
-              <a:t>565</a:t>
+              <a:t>601</a:t>
             </a:r>
             <a:endParaRPr lang="en-US" sz="3200" dirty="0"/>
           </a:p>

</xml_diff>

<commit_message>
docs: bank network guide, security and blueprint updates, regenerated evidence, test cases and deck
Adds docs/BANK_NETWORK.md, risks R19 to R21, the bank controls in the threat matrix, the thirteen-step
demo, the bank ledger as execution evidence, and a mention on the deck's money-flow slide. Backend
709 tests, frontend 89.
</commit_message>
<xml_diff>
--- a/submission/StudyRoute_Deck.pptx
+++ b/submission/StudyRoute_Deck.pptx
@@ -116,32 +116,32 @@
   <p:extLst>
     <p:ext uri="{521415D9-36F7-43E2-AB2F-B90AF26B5E84}">
       <p14:sectionLst xmlns:p14="http://schemas.microsoft.com/office/powerpoint/2010/main">
-        <p14:section name="Opening" id="{2b1353e0-a432-3556-d824-ea20d787e8c1}">
+        <p14:section name="Opening" id="{74b84ad7-be87-3f38-e84d-66c73ce80a77}">
           <p14:sldIdLst>
             <p14:sldId id="256"/>
             <p14:sldId id="257"/>
           </p14:sldIdLst>
         </p14:section>
-        <p14:section name="The problem" id="{5d143097-ae83-9559-e8de-7e81526cf57f}">
+        <p14:section name="The problem" id="{c65efd78-683f-3a31-e67c-b98a33479af1}">
           <p14:sldIdLst>
             <p14:sldId id="258"/>
             <p14:sldId id="259"/>
           </p14:sldIdLst>
         </p14:section>
-        <p14:section name="The solution" id="{0c624ef0-a17c-861f-9969-4218105457d3}">
+        <p14:section name="The solution" id="{42318c76-641b-b2fe-2ef9-af44e38f8edf}">
           <p14:sldIdLst>
             <p14:sldId id="260"/>
             <p14:sldId id="261"/>
           </p14:sldIdLst>
         </p14:section>
-        <p14:section name="Trust" id="{147f3bea-18c2-5dfb-04b9-88548ae260fa}">
+        <p14:section name="Trust" id="{61219f83-cd16-2e92-0de2-642393dcb993}">
           <p14:sldIdLst>
             <p14:sldId id="262"/>
             <p14:sldId id="263"/>
             <p14:sldId id="264"/>
           </p14:sldIdLst>
         </p14:section>
-        <p14:section name="Close" id="{5567e6e9-e95d-01bd-0308-72ff0c12117f}">
+        <p14:section name="Close" id="{c4f75d66-98d9-f681-e33e-52df4bd76b4a}">
           <p14:sldIdLst>
             <p14:sldId id="265"/>
           </p14:sldIdLst>
@@ -1199,7 +1199,7 @@
           <a:p>
             <a:r>
               <a:rPr lang="en-US" dirty="0"/>
-              <a:t>This is the real chain. The parent pays in taka to an authorised dealer bank, which sells foreign currency and sends a SWIFT instruction carrying a UETR and a charge code. A correspondent bank may take a lifting fee, the receiving bank may take another, and the university matches the payment by reference. Each step has a typical failure, shown in red. SWIFT only carries the instruction; banks settle between their own accounts. StudyRoute simulates this chain end to end, and it never moves real money.</a:t>
+              <a:t>This is the real chain. The parent pays in taka to an authorised dealer bank, which sells foreign currency and sends a SWIFT instruction carrying a UETR and a charge code. A correspondent bank may take a lifting fee, the receiving bank may take another, and the university matches the payment by reference. Each step has a typical failure, shown in red. SWIFT only carries the instruction; banks settle between their own accounts. StudyRoute simulates this chain end to end with invented banks, a correspondent and a double-entry ledger where debits equal credits, and a failed payment is returned in full. It never moves real money.</a:t>
             </a:r>
             <a:endParaRPr lang="en-US" dirty="0"/>
           </a:p>
@@ -1551,7 +1551,7 @@
           <a:p>
             <a:r>
               <a:rPr lang="en-US" dirty="0"/>
-              <a:t>Security and compliance is thirty percent of the score, so we made it checkable. On the left are the permission tiers, enforced in the domain layer, not just in the screens. Public, read, prepare, decide, and administer. Deciding, meaning approving a payment, is only for a human parent with a fresh MFA proof bound to that payment and to the hash of the summary they saw. The AI has no approve, cancel, limit or config permission at all. On the right, the numbers: 601 backend and 75 frontend tests, all 24 blueprint scenarios mapped to tests, and 18 known risks that we list openly in the self-assessment. The audit log is hash-chained: Verify passes, we edit one row behind the application's back, and Verify fails at exactly that event. Each payment also gets a compliance report whose hash your browser can recompute. The threat matrix with a proof for each row is in the repository.</a:t>
+              <a:t>Security and compliance is thirty percent of the score, so we made it checkable. On the left are the permission tiers, enforced in the domain layer, not just in the screens. Public, read, prepare, decide, and administer. Deciding, meaning approving a payment, is only for a human parent with a fresh MFA proof bound to that payment and to the hash of the summary they saw. The AI has no approve, cancel, limit or config permission at all. On the right, the numbers: 709 backend and 89 frontend tests, all 24 blueprint scenarios mapped to tests, and 21 known risks that we list openly in the self-assessment. The audit log is hash-chained: Verify passes, we edit one row behind the application's back, and Verify fails at exactly that event. Each payment also gets a compliance report whose hash your browser can recompute. The threat matrix with a proof for each row is in the repository.</a:t>
             </a:r>
             <a:endParaRPr lang="en-US" dirty="0"/>
           </a:p>
@@ -5230,7 +5230,7 @@
                   <a:schemeClr val="accent1"/>
                 </a:solidFill>
               </a:rPr>
-              <a:t>StudyRoute simulates this chain. It never moves real money.</a:t>
+              <a:t>StudyRoute simulates this chain with invented banks. It moves no real money.</a:t>
             </a:r>
             <a:endParaRPr lang="en-US" sz="1400" dirty="0"/>
           </a:p>
@@ -9002,7 +9002,7 @@
                 <a:ea typeface="+mj-lt" pitchFamily="34" charset="-122"/>
                 <a:cs typeface="+mj-lt" pitchFamily="34" charset="-120"/>
               </a:rPr>
-              <a:t>601</a:t>
+              <a:t>709</a:t>
             </a:r>
             <a:endParaRPr lang="en-US" sz="3200" dirty="0"/>
           </a:p>
@@ -9099,7 +9099,7 @@
                 <a:ea typeface="+mj-lt" pitchFamily="34" charset="-122"/>
                 <a:cs typeface="+mj-lt" pitchFamily="34" charset="-120"/>
               </a:rPr>
-              <a:t>75</a:t>
+              <a:t>89</a:t>
             </a:r>
             <a:endParaRPr lang="en-US" sz="3200" dirty="0"/>
           </a:p>
@@ -9293,7 +9293,7 @@
                 <a:ea typeface="+mj-lt" pitchFamily="34" charset="-122"/>
                 <a:cs typeface="+mj-lt" pitchFamily="34" charset="-120"/>
               </a:rPr>
-              <a:t>18</a:t>
+              <a:t>21</a:t>
             </a:r>
             <a:endParaRPr lang="en-US" sz="3200" dirty="0"/>
           </a:p>

</xml_diff>

<commit_message>
feat: multi-currency household view, identity check on the bank screen, preflight and personalize helpers
Adds household totals in every currency (indicative BDT, synthetic rates), the KYC card on the Bank
screen, a worker guard so a hop a reviewer already ran is never run early, a seeded random sweep of
the interbank engine, bank screenshots, scripts/preflight.py (OK, FAIL, OPEN for the submission) and
scripts/personalize.py (team name and repository link into the documents and the deck).
Backend 760 tests, frontend 93.
</commit_message>
<xml_diff>
--- a/submission/StudyRoute_Deck.pptx
+++ b/submission/StudyRoute_Deck.pptx
@@ -116,32 +116,32 @@
   <p:extLst>
     <p:ext uri="{521415D9-36F7-43E2-AB2F-B90AF26B5E84}">
       <p14:sectionLst xmlns:p14="http://schemas.microsoft.com/office/powerpoint/2010/main">
-        <p14:section name="Opening" id="{74b84ad7-be87-3f38-e84d-66c73ce80a77}">
+        <p14:section name="Opening" id="{a5025290-ca18-7c34-6d8c-e25ca3ef9357}">
           <p14:sldIdLst>
             <p14:sldId id="256"/>
             <p14:sldId id="257"/>
           </p14:sldIdLst>
         </p14:section>
-        <p14:section name="The problem" id="{c65efd78-683f-3a31-e67c-b98a33479af1}">
+        <p14:section name="The problem" id="{ac47a9c9-3714-8f0e-b677-c0631f917d31}">
           <p14:sldIdLst>
             <p14:sldId id="258"/>
             <p14:sldId id="259"/>
           </p14:sldIdLst>
         </p14:section>
-        <p14:section name="The solution" id="{42318c76-641b-b2fe-2ef9-af44e38f8edf}">
+        <p14:section name="The solution" id="{2a9bbd95-4f7d-e707-845d-ffc6de58b9d3}">
           <p14:sldIdLst>
             <p14:sldId id="260"/>
             <p14:sldId id="261"/>
           </p14:sldIdLst>
         </p14:section>
-        <p14:section name="Trust" id="{61219f83-cd16-2e92-0de2-642393dcb993}">
+        <p14:section name="Trust" id="{9395864e-c9f2-b035-1148-f873a05bdbe4}">
           <p14:sldIdLst>
             <p14:sldId id="262"/>
             <p14:sldId id="263"/>
             <p14:sldId id="264"/>
           </p14:sldIdLst>
         </p14:section>
-        <p14:section name="Close" id="{c4f75d66-98d9-f681-e33e-52df4bd76b4a}">
+        <p14:section name="Close" id="{17e5a3e9-d64f-bbf2-f7b4-040c3ae1b9ef}">
           <p14:sldIdLst>
             <p14:sldId id="265"/>
           </p14:sldIdLst>
@@ -847,7 +847,7 @@
           <a:p>
             <a:r>
               <a:rPr lang="en-US" dirty="0"/>
-              <a:t>Good morning. We are team [team name], and this is StudyRoute, our entry for Topic C, the cross-border and student finance assistant. StudyRoute is a sandbox AI agent that helps a parent in Bangladesh pay a student's tuition abroad. Everything you will see is synthetic and no real money moves. Our design rule is on the slide, and the rest of the talk shows how we make each of those four sentences true and testable: the engine calculates, the AI explains, the human approves, and every step is logged.</a:t>
+              <a:t>Good morning. We are team [Team name], and this is StudyRoute, our entry for Topic C, the cross-border and student finance assistant. StudyRoute is a sandbox AI agent that helps a parent in Bangladesh pay a student's tuition abroad. Everything you will see is synthetic and no real money moves. Our design rule is on the slide, and the rest of the talk shows how we make each of those four sentences true and testable: the engine calculates, the AI explains, the human approves, and every step is logged.</a:t>
             </a:r>
             <a:endParaRPr lang="en-US" dirty="0"/>
           </a:p>
@@ -1551,7 +1551,7 @@
           <a:p>
             <a:r>
               <a:rPr lang="en-US" dirty="0"/>
-              <a:t>Security and compliance is thirty percent of the score, so we made it checkable. On the left are the permission tiers, enforced in the domain layer, not just in the screens. Public, read, prepare, decide, and administer. Deciding, meaning approving a payment, is only for a human parent with a fresh MFA proof bound to that payment and to the hash of the summary they saw. The AI has no approve, cancel, limit or config permission at all. On the right, the numbers: 709 backend and 89 frontend tests, all 24 blueprint scenarios mapped to tests, and 21 known risks that we list openly in the self-assessment. The audit log is hash-chained: Verify passes, we edit one row behind the application's back, and Verify fails at exactly that event. Each payment also gets a compliance report whose hash your browser can recompute. The threat matrix with a proof for each row is in the repository.</a:t>
+              <a:t>Security and compliance is thirty percent of the score, so we made it checkable. On the left are the permission tiers, enforced in the domain layer, not just in the screens. Public, read, prepare, decide, and administer. Deciding, meaning approving a payment, is only for a human parent with a fresh MFA proof bound to that payment and to the hash of the summary they saw. The AI has no approve, cancel, limit or config permission at all. On the right, the numbers: 760 backend and 93 frontend tests, all 24 blueprint scenarios mapped to tests, and 21 known risks that we list openly in the self-assessment. The audit log is hash-chained: Verify passes, we edit one row behind the application's back, and Verify fails at exactly that event. Each payment also gets a compliance report whose hash your browser can recompute. The threat matrix with a proof for each row is in the repository.</a:t>
             </a:r>
             <a:endParaRPr lang="en-US" dirty="0"/>
           </a:p>
@@ -9002,7 +9002,7 @@
                 <a:ea typeface="+mj-lt" pitchFamily="34" charset="-122"/>
                 <a:cs typeface="+mj-lt" pitchFamily="34" charset="-120"/>
               </a:rPr>
-              <a:t>709</a:t>
+              <a:t>760</a:t>
             </a:r>
             <a:endParaRPr lang="en-US" sz="3200" dirty="0"/>
           </a:p>
@@ -9099,7 +9099,7 @@
                 <a:ea typeface="+mj-lt" pitchFamily="34" charset="-122"/>
                 <a:cs typeface="+mj-lt" pitchFamily="34" charset="-120"/>
               </a:rPr>
-              <a:t>89</a:t>
+              <a:t>93</a:t>
             </a:r>
             <a:endParaRPr lang="en-US" sz="3200" dirty="0"/>
           </a:p>

</xml_diff>

<commit_message>
docs: diagrams and a full screenshot gallery in the README
Seven Mermaid diagrams (architecture, payment lifecycle, safe approval, AI pipeline, audit chain,
international and national bank flows) with PNG exports in docs/diagrams, also used in the technical
documentation. All 26 screenshots regenerated from the final UI (the old ones had no Bank tab, and
the two sandbox shots were identical and described the host rails as not simulated). The README now
has an At a glance row, the bank network section and a captioned gallery. Deck rebuilt.
</commit_message>
<xml_diff>
--- a/submission/StudyRoute_Deck.pptx
+++ b/submission/StudyRoute_Deck.pptx
@@ -116,32 +116,32 @@
   <p:extLst>
     <p:ext uri="{521415D9-36F7-43E2-AB2F-B90AF26B5E84}">
       <p14:sectionLst xmlns:p14="http://schemas.microsoft.com/office/powerpoint/2010/main">
-        <p14:section name="Opening" id="{a5025290-ca18-7c34-6d8c-e25ca3ef9357}">
+        <p14:section name="Opening" id="{97f48a61-4743-e911-9f9b-00170eb8219d}">
           <p14:sldIdLst>
             <p14:sldId id="256"/>
             <p14:sldId id="257"/>
           </p14:sldIdLst>
         </p14:section>
-        <p14:section name="The problem" id="{ac47a9c9-3714-8f0e-b677-c0631f917d31}">
+        <p14:section name="The problem" id="{3ce6ef94-3e4f-e424-8f5c-9a3862a6b235}">
           <p14:sldIdLst>
             <p14:sldId id="258"/>
             <p14:sldId id="259"/>
           </p14:sldIdLst>
         </p14:section>
-        <p14:section name="The solution" id="{2a9bbd95-4f7d-e707-845d-ffc6de58b9d3}">
+        <p14:section name="The solution" id="{241160b3-fa9e-3b71-b760-acf5cb2c29c4}">
           <p14:sldIdLst>
             <p14:sldId id="260"/>
             <p14:sldId id="261"/>
           </p14:sldIdLst>
         </p14:section>
-        <p14:section name="Trust" id="{9395864e-c9f2-b035-1148-f873a05bdbe4}">
+        <p14:section name="Trust" id="{fc57ecf6-17b2-cef4-d74d-bc5ba7387a1e}">
           <p14:sldIdLst>
             <p14:sldId id="262"/>
             <p14:sldId id="263"/>
             <p14:sldId id="264"/>
           </p14:sldIdLst>
         </p14:section>
-        <p14:section name="Close" id="{17e5a3e9-d64f-bbf2-f7b4-040c3ae1b9ef}">
+        <p14:section name="Close" id="{6a0ee387-aa1b-cbfd-48be-6c4519868c24}">
           <p14:sldIdLst>
             <p14:sldId id="265"/>
           </p14:sldIdLst>

</xml_diff>

<commit_message>
docs: real Docker run with the trained reader, the telemetry finding, risk R38
- docs/DOCKER.md, SECURITY_TESTING.md, SECURITY_SELF_ASSESSMENT.md (R38), OPEN_QUESTIONS.md
- submission/evidence/docker_telemetry_capture.txt: the packet capture before and after the fix
- the stack was rebuilt from the archive and the full demo passed with the reader on, also under the
  read-only overlay; the fallback to rules was exercised on a CPU without SSE4.2
- deck, test cases (1043 backend tests) and third-party notices regenerated
</commit_message>
<xml_diff>
--- a/submission/StudyRoute_Deck.pptx
+++ b/submission/StudyRoute_Deck.pptx
@@ -118,26 +118,26 @@
   <p:extLst>
     <p:ext uri="{521415D9-36F7-43E2-AB2F-B90AF26B5E84}">
       <p14:sectionLst xmlns:p14="http://schemas.microsoft.com/office/powerpoint/2010/main">
-        <p14:section name="Opening" id="{8f6a7cd2-70c4-350e-9924-854036d52042}">
+        <p14:section name="Opening" id="{b8849ef0-d384-9aac-207f-8239189deb38}">
           <p14:sldIdLst>
             <p14:sldId id="256"/>
             <p14:sldId id="257"/>
           </p14:sldIdLst>
         </p14:section>
-        <p14:section name="The problem" id="{43005f60-b882-30b3-a560-8157e69fa7f6}">
+        <p14:section name="The problem" id="{888f1308-67e3-30bc-9bc1-25e3a64486d2}">
           <p14:sldIdLst>
             <p14:sldId id="258"/>
             <p14:sldId id="259"/>
           </p14:sldIdLst>
         </p14:section>
-        <p14:section name="The solution" id="{43ad35d3-fe50-63ff-5e7e-5a739d8338fc}">
+        <p14:section name="The solution" id="{f75df6a3-7d26-61fc-a649-bbb27864e513}">
           <p14:sldIdLst>
             <p14:sldId id="260"/>
             <p14:sldId id="261"/>
             <p14:sldId id="262"/>
           </p14:sldIdLst>
         </p14:section>
-        <p14:section name="Trust" id="{774c281b-b571-e099-1a59-21f1af5e227c}">
+        <p14:section name="Trust" id="{6021900e-8c7b-7d66-8c09-d26b89a8561d}">
           <p14:sldIdLst>
             <p14:sldId id="263"/>
             <p14:sldId id="264"/>
@@ -145,7 +145,7 @@
             <p14:sldId id="266"/>
           </p14:sldIdLst>
         </p14:section>
-        <p14:section name="Close" id="{c6a16924-4fb5-be79-a393-d14675917a89}">
+        <p14:section name="Close" id="{1fa45d36-0841-7015-2e64-0fde905e705a}">
           <p14:sldIdLst>
             <p14:sldId id="267"/>
           </p14:sldIdLst>
@@ -939,7 +939,7 @@
           <a:p>
             <a:r>
               <a:rPr lang="en-US" dirty="0"/>
-              <a:t>Security and compliance is thirty percent of the score, so we made it checkable. On the left are the permission tiers, enforced in the domain layer, not just in the screens. Public, read, prepare, decide, and administer. Deciding, meaning approving a payment, is only for a human parent with a fresh MFA proof bound to that payment and to the hash of the summary they saw. The AI has no approve, cancel, limit or config permission at all. On the right, the numbers: 897 backend and 126 frontend tests, all 24 blueprint scenarios mapped to tests, and 37 known risks that we list openly in the self-assessment. The audit log is hash-chained: Verify passes, we edit one row behind the application's back, and Verify fails at exactly that event.</a:t>
+              <a:t>Security and compliance is thirty percent of the score, so we made it checkable. On the left are the permission tiers, enforced in the domain layer, not just in the screens. Public, read, prepare, decide, and administer. Deciding, meaning approving a payment, is only for a human parent with a fresh MFA proof bound to that payment and to the hash of the summary they saw. The AI has no approve, cancel, limit or config permission at all. On the right, the numbers: 1043 backend and 128 frontend tests, all 24 blueprint scenarios mapped to tests, and 38 known risks that we list openly in the self-assessment. The audit log is hash-chained: Verify passes, we edit one row behind the application's back, and Verify fails at exactly that event.</a:t>
             </a:r>
             <a:endParaRPr lang="en-US" dirty="0"/>
           </a:p>
@@ -3246,7 +3246,7 @@
                 <a:ea typeface="+mj-lt" pitchFamily="34" charset="-122"/>
                 <a:cs typeface="+mj-lt" pitchFamily="34" charset="-120"/>
               </a:rPr>
-              <a:t>897</a:t>
+              <a:t>1043</a:t>
             </a:r>
             <a:endParaRPr lang="en-US" sz="3200" dirty="0"/>
           </a:p>
@@ -3343,7 +3343,7 @@
                 <a:ea typeface="+mj-lt" pitchFamily="34" charset="-122"/>
                 <a:cs typeface="+mj-lt" pitchFamily="34" charset="-120"/>
               </a:rPr>
-              <a:t>126</a:t>
+              <a:t>128</a:t>
             </a:r>
             <a:endParaRPr lang="en-US" sz="3200" dirty="0"/>
           </a:p>
@@ -3537,7 +3537,7 @@
                 <a:ea typeface="+mj-lt" pitchFamily="34" charset="-122"/>
                 <a:cs typeface="+mj-lt" pitchFamily="34" charset="-120"/>
               </a:rPr>
-              <a:t>37</a:t>
+              <a:t>38</a:t>
             </a:r>
             <a:endParaRPr lang="en-US" sz="3200" dirty="0"/>
           </a:p>

</xml_diff>

<commit_message>
docs: refresh the test counts, the deck and the execution evidence against the final code
</commit_message>
<xml_diff>
--- a/submission/StudyRoute_Deck.pptx
+++ b/submission/StudyRoute_Deck.pptx
@@ -118,26 +118,26 @@
   <p:extLst>
     <p:ext uri="{521415D9-36F7-43E2-AB2F-B90AF26B5E84}">
       <p14:sectionLst xmlns:p14="http://schemas.microsoft.com/office/powerpoint/2010/main">
-        <p14:section name="Opening" id="{f3c41b52-66d4-40b4-1653-8b3425c442c0}">
+        <p14:section name="Opening" id="{8554ba38-81da-7b51-5a47-74b33a14eaa2}">
           <p14:sldIdLst>
             <p14:sldId id="256"/>
             <p14:sldId id="257"/>
           </p14:sldIdLst>
         </p14:section>
-        <p14:section name="The problem" id="{4f461096-a365-ec45-8259-18ee9ba9d5a6}">
+        <p14:section name="The problem" id="{5f7f7138-7f2f-34f9-4e27-122c72f46470}">
           <p14:sldIdLst>
             <p14:sldId id="258"/>
             <p14:sldId id="259"/>
           </p14:sldIdLst>
         </p14:section>
-        <p14:section name="The solution" id="{40f2088c-d6a8-2c90-d49d-aacfa1e55274}">
+        <p14:section name="The solution" id="{f0370852-cd1e-d889-8875-19f2f1d7b33c}">
           <p14:sldIdLst>
             <p14:sldId id="260"/>
             <p14:sldId id="261"/>
             <p14:sldId id="262"/>
           </p14:sldIdLst>
         </p14:section>
-        <p14:section name="Trust" id="{a75fb253-75d9-c23c-f526-ebd13a53b2a9}">
+        <p14:section name="Trust" id="{14235634-10cb-12f2-3b3c-0caa9fb5b5f4}">
           <p14:sldIdLst>
             <p14:sldId id="263"/>
             <p14:sldId id="264"/>
@@ -145,7 +145,7 @@
             <p14:sldId id="266"/>
           </p14:sldIdLst>
         </p14:section>
-        <p14:section name="Close" id="{aa809496-c44f-efbb-eac1-740b6c01d5d5}">
+        <p14:section name="Close" id="{6d2fdd1d-3ebb-526f-792e-7227df826fa1}">
           <p14:sldIdLst>
             <p14:sldId id="267"/>
           </p14:sldIdLst>
@@ -939,7 +939,7 @@
           <a:p>
             <a:r>
               <a:rPr lang="en-US" dirty="0"/>
-              <a:t>Security and compliance is thirty percent of the score, so we made it checkable. On the left are the permission tiers, enforced in the domain layer, not just in the screens. Public, read, prepare, decide, and administer. Deciding, meaning approving a payment, is only for a human parent with a fresh MFA proof bound to that payment and to the hash of the summary they saw. The AI has no approve, cancel, limit or config permission at all. On the right, the numbers: 1129 backend and 139 frontend tests, all 24 blueprint scenarios mapped to tests, and 41 known risks that we list openly in the self-assessment. The audit log is hash-chained: Verify passes, we edit one row behind the application's back, and Verify fails at exactly that event.</a:t>
+              <a:t>Security and compliance is thirty percent of the score, so we made it checkable. On the left are the permission tiers, enforced in the domain layer, not just in the screens. Public, read, prepare, decide, and administer. Deciding, meaning approving a payment, is only for a human parent with a fresh MFA proof bound to that payment and to the hash of the summary they saw. The AI has no approve, cancel, limit or config permission at all. On the right, the numbers: 1130 backend and 139 frontend tests, all 24 blueprint scenarios mapped to tests, and 41 known risks that we list openly in the self-assessment. The audit log is hash-chained: Verify passes, we edit one row behind the application's back, and Verify fails at exactly that event.</a:t>
             </a:r>
             <a:endParaRPr lang="en-US" dirty="0"/>
           </a:p>
@@ -3246,7 +3246,7 @@
                 <a:ea typeface="+mj-lt" pitchFamily="34" charset="-122"/>
                 <a:cs typeface="+mj-lt" pitchFamily="34" charset="-120"/>
               </a:rPr>
-              <a:t>1129</a:t>
+              <a:t>1130</a:t>
             </a:r>
             <a:endParaRPr lang="en-US" sz="3200" dirty="0"/>
           </a:p>

</xml_diff>

<commit_message>
docs: refresh test counts, deck and evidence for the web UI
</commit_message>
<xml_diff>
--- a/submission/StudyRoute_Deck.pptx
+++ b/submission/StudyRoute_Deck.pptx
@@ -118,26 +118,26 @@
   <p:extLst>
     <p:ext uri="{521415D9-36F7-43E2-AB2F-B90AF26B5E84}">
       <p14:sectionLst xmlns:p14="http://schemas.microsoft.com/office/powerpoint/2010/main">
-        <p14:section name="Opening" id="{8554ba38-81da-7b51-5a47-74b33a14eaa2}">
+        <p14:section name="Opening" id="{18c8c211-b6f8-ac24-88f1-a6e889d25e0f}">
           <p14:sldIdLst>
             <p14:sldId id="256"/>
             <p14:sldId id="257"/>
           </p14:sldIdLst>
         </p14:section>
-        <p14:section name="The problem" id="{5f7f7138-7f2f-34f9-4e27-122c72f46470}">
+        <p14:section name="The problem" id="{6736a316-488a-6457-d845-bb02a5887701}">
           <p14:sldIdLst>
             <p14:sldId id="258"/>
             <p14:sldId id="259"/>
           </p14:sldIdLst>
         </p14:section>
-        <p14:section name="The solution" id="{f0370852-cd1e-d889-8875-19f2f1d7b33c}">
+        <p14:section name="The solution" id="{7211c3e0-69c0-9b3d-7554-9e523d595a4f}">
           <p14:sldIdLst>
             <p14:sldId id="260"/>
             <p14:sldId id="261"/>
             <p14:sldId id="262"/>
           </p14:sldIdLst>
         </p14:section>
-        <p14:section name="Trust" id="{14235634-10cb-12f2-3b3c-0caa9fb5b5f4}">
+        <p14:section name="Trust" id="{d6521bd4-000c-decd-7b58-e32cf313b3ed}">
           <p14:sldIdLst>
             <p14:sldId id="263"/>
             <p14:sldId id="264"/>
@@ -145,7 +145,7 @@
             <p14:sldId id="266"/>
           </p14:sldIdLst>
         </p14:section>
-        <p14:section name="Close" id="{6d2fdd1d-3ebb-526f-792e-7227df826fa1}">
+        <p14:section name="Close" id="{67eae655-fb72-c88a-3bcb-49c96da15be6}">
           <p14:sldIdLst>
             <p14:sldId id="267"/>
           </p14:sldIdLst>
@@ -939,7 +939,7 @@
           <a:p>
             <a:r>
               <a:rPr lang="en-US" dirty="0"/>
-              <a:t>Security and compliance is thirty percent of the score, so we made it checkable. On the left are the permission tiers, enforced in the domain layer, not just in the screens. Public, read, prepare, decide, and administer. Deciding, meaning approving a payment, is only for a human parent with a fresh MFA proof bound to that payment and to the hash of the summary they saw. The AI has no approve, cancel, limit or config permission at all. On the right, the numbers: 1130 backend and 139 frontend tests, all 24 blueprint scenarios mapped to tests, and 41 known risks that we list openly in the self-assessment. The audit log is hash-chained: Verify passes, we edit one row behind the application's back, and Verify fails at exactly that event.</a:t>
+              <a:t>Security and compliance is thirty percent of the score, so we made it checkable. On the left are the permission tiers, enforced in the domain layer, not just in the screens. Public, read, prepare, decide, and administer. Deciding, meaning approving a payment, is only for a human parent with a fresh MFA proof bound to that payment and to the hash of the summary they saw. The AI has no approve, cancel, limit or config permission at all. On the right, the numbers: 1135 backend and 360 frontend tests, all 24 blueprint scenarios mapped to tests, and 42 known risks that we list openly in the self-assessment. The audit log is hash-chained: Verify passes, we edit one row behind the application's back, and Verify fails at exactly that event.</a:t>
             </a:r>
             <a:endParaRPr lang="en-US" dirty="0"/>
           </a:p>
@@ -3246,7 +3246,7 @@
                 <a:ea typeface="+mj-lt" pitchFamily="34" charset="-122"/>
                 <a:cs typeface="+mj-lt" pitchFamily="34" charset="-120"/>
               </a:rPr>
-              <a:t>1130</a:t>
+              <a:t>1135</a:t>
             </a:r>
             <a:endParaRPr lang="en-US" sz="3200" dirty="0"/>
           </a:p>
@@ -3343,7 +3343,7 @@
                 <a:ea typeface="+mj-lt" pitchFamily="34" charset="-122"/>
                 <a:cs typeface="+mj-lt" pitchFamily="34" charset="-120"/>
               </a:rPr>
-              <a:t>139</a:t>
+              <a:t>360</a:t>
             </a:r>
             <a:endParaRPr lang="en-US" sz="3200" dirty="0"/>
           </a:p>
@@ -3537,7 +3537,7 @@
                 <a:ea typeface="+mj-lt" pitchFamily="34" charset="-122"/>
                 <a:cs typeface="+mj-lt" pitchFamily="34" charset="-120"/>
               </a:rPr>
-              <a:t>41</a:t>
+              <a:t>42</a:t>
             </a:r>
             <a:endParaRPr lang="en-US" sz="3200" dirty="0"/>
           </a:p>

</xml_diff>

<commit_message>
docs: student guide, risks R43 and R44, screenshots 35 to 38, refreshed evidence
README features F21 to F23, blueprint 6.8, open questions for the new config keys,
the deck, the video script and the project description. All 38 screenshots are
retaken from the web UI with the new sidebar item. Test cases, deck and the
execution evidence are regenerated against this code.
</commit_message>
<xml_diff>
--- a/submission/StudyRoute_Deck.pptx
+++ b/submission/StudyRoute_Deck.pptx
@@ -118,26 +118,26 @@
   <p:extLst>
     <p:ext uri="{521415D9-36F7-43E2-AB2F-B90AF26B5E84}">
       <p14:sectionLst xmlns:p14="http://schemas.microsoft.com/office/powerpoint/2010/main">
-        <p14:section name="Opening" id="{18c8c211-b6f8-ac24-88f1-a6e889d25e0f}">
+        <p14:section name="Opening" id="{65d2d77c-ee0b-9fc4-de1c-787d5f1b0452}">
           <p14:sldIdLst>
             <p14:sldId id="256"/>
             <p14:sldId id="257"/>
           </p14:sldIdLst>
         </p14:section>
-        <p14:section name="The problem" id="{6736a316-488a-6457-d845-bb02a5887701}">
+        <p14:section name="The problem" id="{58271b31-3f41-f8e0-0acc-fe7f2e95b9b1}">
           <p14:sldIdLst>
             <p14:sldId id="258"/>
             <p14:sldId id="259"/>
           </p14:sldIdLst>
         </p14:section>
-        <p14:section name="The solution" id="{7211c3e0-69c0-9b3d-7554-9e523d595a4f}">
+        <p14:section name="The solution" id="{23ccd0dc-f3e8-6940-e517-98846ffe7797}">
           <p14:sldIdLst>
             <p14:sldId id="260"/>
             <p14:sldId id="261"/>
             <p14:sldId id="262"/>
           </p14:sldIdLst>
         </p14:section>
-        <p14:section name="Trust" id="{d6521bd4-000c-decd-7b58-e32cf313b3ed}">
+        <p14:section name="Trust" id="{639e2041-e73a-ef4f-b420-e3483d49ca79}">
           <p14:sldIdLst>
             <p14:sldId id="263"/>
             <p14:sldId id="264"/>
@@ -145,7 +145,7 @@
             <p14:sldId id="266"/>
           </p14:sldIdLst>
         </p14:section>
-        <p14:section name="Close" id="{67eae655-fb72-c88a-3bcb-49c96da15be6}">
+        <p14:section name="Close" id="{8322b838-9098-0420-9d71-745deba1143d}">
           <p14:sldIdLst>
             <p14:sldId id="267"/>
           </p14:sldIdLst>
@@ -939,7 +939,7 @@
           <a:p>
             <a:r>
               <a:rPr lang="en-US" dirty="0"/>
-              <a:t>Security and compliance is thirty percent of the score, so we made it checkable. On the left are the permission tiers, enforced in the domain layer, not just in the screens. Public, read, prepare, decide, and administer. Deciding, meaning approving a payment, is only for a human parent with a fresh MFA proof bound to that payment and to the hash of the summary they saw. The AI has no approve, cancel, limit or config permission at all. On the right, the numbers: 1135 backend and 360 frontend tests, all 24 blueprint scenarios mapped to tests, and 42 known risks that we list openly in the self-assessment. The audit log is hash-chained: Verify passes, we edit one row behind the application's back, and Verify fails at exactly that event.</a:t>
+              <a:t>Security and compliance is thirty percent of the score, so we made it checkable. On the left are the permission tiers, enforced in the domain layer, not just in the screens. Public, read, prepare, decide, and administer. Deciding, meaning approving a payment, is only for a human parent with a fresh MFA proof bound to that payment and to the hash of the summary they saw. The AI has no approve, cancel, limit or config permission at all. On the right, the numbers: 1223 backend and 406 frontend tests, all 24 blueprint scenarios mapped to tests, and 44 known risks that we list openly in the self-assessment. The audit log is hash-chained: Verify passes, we edit one row behind the application's back, and Verify fails at exactly that event.</a:t>
             </a:r>
             <a:endParaRPr lang="en-US" dirty="0"/>
           </a:p>
@@ -1555,7 +1555,7 @@
           <a:p>
             <a:r>
               <a:rPr lang="en-US" dirty="0"/>
-              <a:t>Every number comes from a deterministic engine: integer minor units, decimal rates, no floats. For one provider, total cost is the FX margin plus the fixed fee, the SWIFT fee, any fees the sender pays under OUR, plus a shortfall when fees are deducted from the amount. We rank by that percentage. In our synthetic example, Provider B is first at 1.58 percent, Provider C looks cheap but it is quoted as SHA, so the university would receive 35 pounds less, and Provider A is third at 2.16 percent. On the right is where Provider B's 25,300 taka goes: most of it is the margin. The same engine powers the smart send plan, names the cheapest provider that arrives before the due date, and can stress-test a quote if the taka weakens. It does not predict exchange rates, and says so.</a:t>
+              <a:t>Every number comes from a deterministic engine: integer minor units, decimal rates, no floats. For one provider, total cost is the FX margin plus the fixed fee, the SWIFT fee, any fees the sender pays under OUR, plus a shortfall when fees are deducted from the amount. We rank by that percentage. In our synthetic example, Provider B is first at 1.58 percent, Provider C looks cheap but it is quoted as SHA, so the university would receive 35 pounds less, and Provider A is third at 2.16 percent. On the right is where Provider B's 25,300 taka goes: most of it is the margin. The same engine powers the smart send plan, names the cheapest provider that arrives before the due date, and can stress-test a quote if the taka weakens. A student guide shows which student cities a monthly budget covers, with invented figures marked not verified. It does not predict exchange rates, and says so.</a:t>
             </a:r>
             <a:endParaRPr lang="en-US" dirty="0"/>
           </a:p>
@@ -3246,7 +3246,7 @@
                 <a:ea typeface="+mj-lt" pitchFamily="34" charset="-122"/>
                 <a:cs typeface="+mj-lt" pitchFamily="34" charset="-120"/>
               </a:rPr>
-              <a:t>1135</a:t>
+              <a:t>1223</a:t>
             </a:r>
             <a:endParaRPr lang="en-US" sz="3200" dirty="0"/>
           </a:p>
@@ -3343,7 +3343,7 @@
                 <a:ea typeface="+mj-lt" pitchFamily="34" charset="-122"/>
                 <a:cs typeface="+mj-lt" pitchFamily="34" charset="-120"/>
               </a:rPr>
-              <a:t>360</a:t>
+              <a:t>406</a:t>
             </a:r>
             <a:endParaRPr lang="en-US" sz="3200" dirty="0"/>
           </a:p>
@@ -3537,7 +3537,7 @@
                 <a:ea typeface="+mj-lt" pitchFamily="34" charset="-122"/>
                 <a:cs typeface="+mj-lt" pitchFamily="34" charset="-120"/>
               </a:rPr>
-              <a:t>42</a:t>
+              <a:t>44</a:t>
             </a:r>
             <a:endParaRPr lang="en-US" sz="3200" dirty="0"/>
           </a:p>
@@ -11505,7 +11505,7 @@
                   <a:schemeClr val="tx1"/>
                 </a:solidFill>
               </a:rPr>
-              <a:t>Reads the intent and marks the words that carry an amount, a currency or a date. It proposes; plain code checks; the engine calculates. A GPU run of a few minutes on 35,588 messages; 34 MB, 7 ms on a CPU.</a:t>
+              <a:t>Reads the intent and marks the words that carry an amount, a currency or a date. It proposes; plain code checks; the engine calculates. A GPU run of a few minutes on 35,588 messages; 34 MB, 6 ms on a CPU.</a:t>
             </a:r>
             <a:endParaRPr lang="en-US" sz="1100" dirty="0"/>
           </a:p>

</xml_diff>

<commit_message>
docs: judge-review fixes, team details, Q&A prep and a shorter pitch
- Deck: the smart-escrow slide becomes "Proven, and not proven yet"; escrow keeps one
  sentence on the closing slide. Still 12 slides, notes about 8.9 minutes.
- Video script trimmed to about 4:25 (bank network and escrow in one short scene, plus a
  spoken limits line).
- New submission/QA_PREP.md: the ten hard questions with honest answers and gaps.
- Eligibility: draft e-mail 1b to the organiser, checklist and open-questions rows for the
  60% rule, the country list and the Shenzhen visa; a bullet on the missing real-quote
  calibration, real users and outside review.
- personalize.py run: team name, members and repository link filled in.
- test_preflight: the personalize tests use their own templates, so personalising the real
  files no longer breaks the suite.
</commit_message>
<xml_diff>
--- a/submission/StudyRoute_Deck.pptx
+++ b/submission/StudyRoute_Deck.pptx
@@ -118,34 +118,34 @@
   <p:extLst>
     <p:ext uri="{521415D9-36F7-43E2-AB2F-B90AF26B5E84}">
       <p14:sectionLst xmlns:p14="http://schemas.microsoft.com/office/powerpoint/2010/main">
-        <p14:section name="Opening" id="{65d2d77c-ee0b-9fc4-de1c-787d5f1b0452}">
+        <p14:section name="Opening" id="{7e613686-ad98-1f2f-8a67-16f3241feea5}">
           <p14:sldIdLst>
             <p14:sldId id="256"/>
             <p14:sldId id="257"/>
           </p14:sldIdLst>
         </p14:section>
-        <p14:section name="The problem" id="{58271b31-3f41-f8e0-0acc-fe7f2e95b9b1}">
+        <p14:section name="The problem" id="{e7d54294-e2e1-f1fc-d841-cb5910919810}">
           <p14:sldIdLst>
             <p14:sldId id="258"/>
             <p14:sldId id="259"/>
           </p14:sldIdLst>
         </p14:section>
-        <p14:section name="The solution" id="{23ccd0dc-f3e8-6940-e517-98846ffe7797}">
+        <p14:section name="The solution" id="{44e8819d-7d64-590a-8c57-0e72d00129ed}">
           <p14:sldIdLst>
             <p14:sldId id="260"/>
             <p14:sldId id="261"/>
-            <p14:sldId id="262"/>
           </p14:sldIdLst>
         </p14:section>
-        <p14:section name="Trust" id="{639e2041-e73a-ef4f-b420-e3483d49ca79}">
+        <p14:section name="Trust" id="{6cc4700c-ca03-a99c-c2ca-f04f4ca0c4bb}">
           <p14:sldIdLst>
+            <p14:sldId id="262"/>
             <p14:sldId id="263"/>
             <p14:sldId id="264"/>
             <p14:sldId id="265"/>
             <p14:sldId id="266"/>
           </p14:sldIdLst>
         </p14:section>
-        <p14:section name="Close" id="{8322b838-9098-0420-9d71-745deba1143d}">
+        <p14:section name="Close" id="{0939555f-555d-763a-0a3b-19c2722f4bc3}">
           <p14:sldIdLst>
             <p14:sldId id="267"/>
           </p14:sldIdLst>
@@ -851,7 +851,7 @@
           <a:p>
             <a:r>
               <a:rPr lang="en-US" dirty="0"/>
-              <a:t>Good morning. We are team [Team name], and this is StudyRoute, our entry for Topic C, the cross-border and student finance assistant. StudyRoute is a sandbox AI agent that helps a parent in Bangladesh pay a student's tuition abroad. Everything you will see is synthetic and no real money moves. Our design rule is on the slide, and the rest of the talk shows how we make each of those four sentences true and testable: the engine calculates, the AI explains, the human approves, and every step is logged.</a:t>
+              <a:t>Good morning. We are team TeamEkxin, and this is StudyRoute, our entry for Topic C, the cross-border and student finance assistant. StudyRoute is a sandbox AI agent that helps a parent in Bangladesh pay a student's tuition abroad. Everything you will see is synthetic and no real money moves. Our design rule is on the slide, and the rest of the talk shows how we make each of those four sentences true and testable: the engine calculates, the AI explains, the human approves, and every step is logged.</a:t>
             </a:r>
             <a:endParaRPr lang="en-US" dirty="0"/>
           </a:p>
@@ -1115,7 +1115,7 @@
           <a:p>
             <a:r>
               <a:rPr lang="en-US" dirty="0"/>
-              <a:t>Next steps. First, replace every placeholder rule with an official Bangladesh Bank source and add the moon-dependent holidays. Second, a partnership with an authorised dealer bank for real quotes and real KYC, and regulator-ready reports from the audit log. Third, the escrow contracts would move from our simulated chain to a permissioned one with a deposit token issued by a bank. Topic C also mentions credit building. We have not built it, and we would rather say so than pretend. We do show a household's money in every currency, but those are simulated accounts, not real ones. To close: StudyRoute is clear, cheap and safe, because the engine calculates, the AI explains, the human approves, and every step is logged. Thank you.</a:t>
+              <a:t>Next steps. First, replace every placeholder rule with an official Bangladesh Bank source and add the moon-dependent holidays. Second, a partnership with an authorised dealer bank for real quotes and real KYC, and regulator-ready reports from the audit log. Third, beyond tuition, the sandbox already has a smart escrow for living costs and a bank-network simulation; the escrow contracts would move from our simulated chain to a permissioned one with a deposit token issued by a bank. Topic C also mentions credit building. We have not built it, and we would rather say so than pretend. We do show a household's money in every currency, but those are simulated accounts, not real ones. To close: StudyRoute is clear, cheap and safe, because the engine calculates, the AI explains, the human approves, and every step is logged. Thank you.</a:t>
             </a:r>
             <a:endParaRPr lang="en-US" dirty="0"/>
           </a:p>
@@ -1643,7 +1643,7 @@
           <a:p>
             <a:r>
               <a:rPr lang="en-US" dirty="0"/>
-              <a:t>Living costs are different from tuition: they are a payment every month. Smart escrow lets the parent lock the money in a smart contract that pays on the dates they choose. Planning locks nothing, the schedule is shown first. Locking needs a fresh MFA proof from the parent, and then each payment is released on its date. A bank reviewer can freeze an escrow with a written reason but can never move the funds. Only amounts, dates and hashes go on the chain, never a name or an account number, and the AI has no permission here at all. The chain is simulated: an in-memory EVM running real Solidity contracts, and the tokens are not money. We also anchor the head of the audit log on it, so rewriting history leaves a trace that someone editing the database cannot reach.</a:t>
+              <a:t>Before the details, here is what we have shown and what we have not. What we have shown: every number comes from one deterministic engine, with 1223 backend tests covering all 24 scenarios. Only a human with a fresh MFA code can approve, and the AI has no such permission. Change one audit row and Verify fails at that event. And the stack starts from the zipped archive with one command. What we have not shown: the rates, fees and city costs are invented, and we have not yet compared them with real quotes. No real parent has used it. No outsider has reviewed its security. The Bangladesh Bank limits are placeholders, marked Not verified. Both lists are in the repository, because we would rather you hear the limits from us.</a:t>
             </a:r>
             <a:endParaRPr lang="en-US" dirty="0"/>
           </a:p>
@@ -2589,7 +2589,7 @@
                   <a:schemeClr val="accent5"/>
                 </a:solidFill>
               </a:rPr>
-              <a:t>[Team name]  ·  Sandbox: synthetic data, no real money moves</a:t>
+              <a:t>TeamEkxin  ·  Sandbox: synthetic data, no real money moves</a:t>
             </a:r>
             <a:endParaRPr lang="en-US" sz="1200" dirty="0"/>
           </a:p>
@@ -4341,7 +4341,7 @@
                   <a:schemeClr val="bg2"/>
                 </a:solidFill>
               </a:rPr>
-              <a:t>Run the escrow contracts on a permissioned chain with a bank-issued deposit token.</a:t>
+              <a:t>Escrow already runs in the sandbox. Next: a permissioned chain and a bank-issued token.</a:t>
             </a:r>
             <a:endParaRPr lang="en-US" sz="1400" dirty="0"/>
           </a:p>
@@ -4416,7 +4416,7 @@
                   <a:schemeClr val="accent5"/>
                 </a:solidFill>
               </a:rPr>
-              <a:t>[Team name]  ·  [repository link]  ·  Sandbox: no real money moves</a:t>
+              <a:t>TeamEkxin  ·  https://github.com/NoobCrow/StudyRoute  ·  Sandbox: no real money moves</a:t>
             </a:r>
             <a:endParaRPr lang="en-US" sz="1200" dirty="0"/>
           </a:p>
@@ -9111,7 +9111,7 @@
                 <a:ea typeface="+mj-lt" pitchFamily="34" charset="-122"/>
                 <a:cs typeface="+mj-lt" pitchFamily="34" charset="-120"/>
               </a:rPr>
-              <a:t>Smart escrow for living costs</a:t>
+              <a:t>Proven, and not proven yet</a:t>
             </a:r>
             <a:endParaRPr lang="en-US" sz="3600" dirty="0"/>
           </a:p>
@@ -9126,105 +9126,11 @@
         <p:spPr>
           <a:xfrm>
             <a:off x="457200" y="1234440"/>
-            <a:ext cx="4718304" cy="3218688"/>
+            <a:ext cx="4023360" cy="3154680"/>
           </a:xfrm>
           <a:prstGeom prst="roundRect">
             <a:avLst>
-              <a:gd name="adj" fmla="val 1705"/>
-            </a:avLst>
-          </a:prstGeom>
-          <a:solidFill>
-            <a:schemeClr val="bg1"/>
-          </a:solidFill>
-          <a:ln w="9525">
-            <a:solidFill>
-              <a:schemeClr val="accent5"/>
-            </a:solidFill>
-            <a:prstDash val="solid"/>
-          </a:ln>
-          <a:effectLst>
-            <a:outerShdw sx="100000" sy="100000" kx="0" ky="0" algn="bl" rotWithShape="0" blurRad="101600" dist="25400" dir="5400000">
-              <a:srgbClr val="0B2545">
-                <a:alpha val="18000"/>
-              </a:srgbClr>
-            </a:outerShdw>
-          </a:effectLst>
-        </p:spPr>
-      </p:sp>
-      <p:pic>
-        <p:nvPicPr>
-          <p:cNvPr id="4" name="content-7-image-2" descr="An escrow with three monthly payments and its on-chain proof">    </p:cNvPr>
-          <p:cNvPicPr>
-            <a:picLocks noChangeAspect="1"/>
-          </p:cNvPicPr>
-          <p:nvPr/>
-        </p:nvPicPr>
-        <p:blipFill>
-          <a:blip r:embed="rId1"/>
-          <a:stretch>
-            <a:fillRect/>
-          </a:stretch>
-        </p:blipFill>
-        <p:spPr>
-          <a:xfrm>
-            <a:off x="530352" y="1307592"/>
-            <a:ext cx="4572000" cy="3072384"/>
-          </a:xfrm>
-          <a:prstGeom prst="rect">
-            <a:avLst/>
-          </a:prstGeom>
-        </p:spPr>
-      </p:pic>
-      <p:sp>
-        <p:nvSpPr>
-          <p:cNvPr id="5" name="content-7-text-3"/>
-          <p:cNvSpPr txBox="1"/>
-          <p:nvPr/>
-        </p:nvSpPr>
-        <p:spPr>
-          <a:xfrm>
-            <a:off x="457200" y="4526280"/>
-            <a:ext cx="4754880" cy="274320"/>
-          </a:xfrm>
-          <a:prstGeom prst="rect">
-            <a:avLst/>
-          </a:prstGeom>
-          <a:noFill/>
-          <a:ln/>
-        </p:spPr>
-        <p:txBody>
-          <a:bodyPr wrap="square" lIns="0" tIns="0" rIns="0" bIns="0" rtlCol="0" anchor="t"/>
-          <a:lstStyle/>
-          <a:p>
-            <a:pPr algn="l" indent="0" marL="0">
-              <a:buNone/>
-            </a:pPr>
-            <a:r>
-              <a:rPr lang="en-US" sz="1100" dirty="0">
-                <a:solidFill>
-                  <a:schemeClr val="tx2"/>
-                </a:solidFill>
-              </a:rPr>
-              <a:t>Simulated chain: the tokens are not money. Synthetic data.</a:t>
-            </a:r>
-            <a:endParaRPr lang="en-US" sz="1100" dirty="0"/>
-          </a:p>
-        </p:txBody>
-      </p:sp>
-      <p:sp>
-        <p:nvSpPr>
-          <p:cNvPr id="6" name="content-7-rect-4"/>
-          <p:cNvSpPr/>
-          <p:nvPr/>
-        </p:nvSpPr>
-        <p:spPr>
-          <a:xfrm>
-            <a:off x="5486400" y="1280160"/>
-            <a:ext cx="3200400" cy="731520"/>
-          </a:xfrm>
-          <a:prstGeom prst="roundRect">
-            <a:avLst>
-              <a:gd name="adj" fmla="val 10000"/>
+              <a:gd name="adj" fmla="val 2319"/>
             </a:avLst>
           </a:prstGeom>
           <a:solidFill>
@@ -9235,14 +9141,70 @@
       </p:sp>
       <p:sp>
         <p:nvSpPr>
-          <p:cNvPr id="7" name="content-7-text-5"/>
+          <p:cNvPr id="4" name="content-7-rect-2"/>
+          <p:cNvSpPr/>
+          <p:nvPr/>
+        </p:nvSpPr>
+        <p:spPr>
+          <a:xfrm>
+            <a:off x="640080" y="1371600"/>
+            <a:ext cx="109728" cy="365760"/>
+          </a:xfrm>
+          <a:prstGeom prst="rect">
+            <a:avLst/>
+          </a:prstGeom>
+          <a:solidFill>
+            <a:schemeClr val="accent1"/>
+          </a:solidFill>
+          <a:ln/>
+        </p:spPr>
+      </p:sp>
+      <p:sp>
+        <p:nvSpPr>
+          <p:cNvPr id="5" name="content-7-text-3"/>
           <p:cNvSpPr txBox="1"/>
           <p:nvPr/>
         </p:nvSpPr>
         <p:spPr>
           <a:xfrm>
-            <a:off x="5623560" y="1316736"/>
-            <a:ext cx="2926080" cy="256032"/>
+            <a:off x="841248" y="1325880"/>
+            <a:ext cx="3474720" cy="457200"/>
+          </a:xfrm>
+          <a:prstGeom prst="rect">
+            <a:avLst/>
+          </a:prstGeom>
+          <a:noFill/>
+          <a:ln/>
+        </p:spPr>
+        <p:txBody>
+          <a:bodyPr wrap="square" lIns="0" tIns="0" rIns="0" bIns="0" rtlCol="0" anchor="ctr"/>
+          <a:lstStyle/>
+          <a:p>
+            <a:pPr algn="l" indent="0" marL="0">
+              <a:buNone/>
+            </a:pPr>
+            <a:r>
+              <a:rPr lang="en-US" sz="1800" b="1" dirty="0">
+                <a:solidFill>
+                  <a:schemeClr val="accent1"/>
+                </a:solidFill>
+              </a:rPr>
+              <a:t>Proven by tests and logs</a:t>
+            </a:r>
+            <a:endParaRPr lang="en-US" sz="1800" dirty="0"/>
+          </a:p>
+        </p:txBody>
+      </p:sp>
+      <p:sp>
+        <p:nvSpPr>
+          <p:cNvPr id="6" name="content-7-text-4"/>
+          <p:cNvSpPr txBox="1"/>
+          <p:nvPr/>
+        </p:nvSpPr>
+        <p:spPr>
+          <a:xfrm>
+            <a:off x="640080" y="1920240"/>
+            <a:ext cx="3657600" cy="2377440"/>
           </a:xfrm>
           <a:prstGeom prst="rect">
             <a:avLst/>
@@ -9254,71 +9216,93 @@
           <a:bodyPr wrap="square" lIns="0" tIns="0" rIns="0" bIns="0" rtlCol="0" anchor="t"/>
           <a:lstStyle/>
           <a:p>
-            <a:pPr algn="l" indent="0" marL="0">
-              <a:buNone/>
-            </a:pPr>
-            <a:r>
-              <a:rPr lang="en-US" sz="1400" b="1" dirty="0">
-                <a:solidFill>
-                  <a:schemeClr val="accent1"/>
-                </a:solidFill>
-              </a:rPr>
-              <a:t>Plan</a:t>
-            </a:r>
-            <a:endParaRPr lang="en-US" sz="1400" dirty="0"/>
-          </a:p>
-        </p:txBody>
-      </p:sp>
-      <p:sp>
-        <p:nvSpPr>
-          <p:cNvPr id="8" name="content-7-text-6"/>
-          <p:cNvSpPr txBox="1"/>
-          <p:nvPr/>
-        </p:nvSpPr>
-        <p:spPr>
-          <a:xfrm>
-            <a:off x="5623560" y="1572768"/>
-            <a:ext cx="2971800" cy="420624"/>
-          </a:xfrm>
-          <a:prstGeom prst="rect">
-            <a:avLst/>
-          </a:prstGeom>
-          <a:noFill/>
-          <a:ln/>
-        </p:spPr>
-        <p:txBody>
-          <a:bodyPr wrap="square" lIns="0" tIns="0" rIns="0" bIns="0" rtlCol="0" anchor="t"/>
-          <a:lstStyle/>
-          <a:p>
-            <a:pPr algn="l" indent="0" marL="0">
-              <a:buNone/>
-            </a:pPr>
-            <a:r>
-              <a:rPr lang="en-US" sz="1100" dirty="0">
+            <a:pPr algn="l" marL="342900" indent="-342900">
+              <a:spcAft>
+                <a:spcPts val="600"/>
+              </a:spcAft>
+              <a:buSzPct val="100000"/>
+              <a:buChar char="•"/>
+            </a:pPr>
+            <a:r>
+              <a:rPr lang="en-US" sz="1200" dirty="0">
                 <a:solidFill>
                   <a:schemeClr val="tx1"/>
                 </a:solidFill>
               </a:rPr>
-              <a:t>The schedule is shown first. Nothing is locked.</a:t>
-            </a:r>
-            <a:endParaRPr lang="en-US" sz="1100" dirty="0"/>
-          </a:p>
-        </p:txBody>
-      </p:sp>
-      <p:sp>
-        <p:nvSpPr>
-          <p:cNvPr id="9" name="content-7-rect-7"/>
+              <a:t>Every number comes from one engine, in integer money. 1223 backend tests cover all 24 scenarios.</a:t>
+            </a:r>
+            <a:endParaRPr lang="en-US" sz="1200" dirty="0"/>
+          </a:p>
+          <a:p>
+            <a:pPr algn="l" marL="342900" indent="-342900">
+              <a:spcAft>
+                <a:spcPts val="600"/>
+              </a:spcAft>
+              <a:buSzPct val="100000"/>
+              <a:buChar char="•"/>
+            </a:pPr>
+            <a:r>
+              <a:rPr lang="en-US" sz="1200" dirty="0">
+                <a:solidFill>
+                  <a:schemeClr val="tx1"/>
+                </a:solidFill>
+              </a:rPr>
+              <a:t>Only a human with a fresh MFA code can approve. The AI has no such permission, and a test enforces the table.</a:t>
+            </a:r>
+            <a:endParaRPr lang="en-US" sz="1200" dirty="0"/>
+          </a:p>
+          <a:p>
+            <a:pPr algn="l" marL="342900" indent="-342900">
+              <a:spcAft>
+                <a:spcPts val="600"/>
+              </a:spcAft>
+              <a:buSzPct val="100000"/>
+              <a:buChar char="•"/>
+            </a:pPr>
+            <a:r>
+              <a:rPr lang="en-US" sz="1200" dirty="0">
+                <a:solidFill>
+                  <a:schemeClr val="tx1"/>
+                </a:solidFill>
+              </a:rPr>
+              <a:t>Edit one audit row and Verify fails at that event. A rewritten chain is caught by the anchor.</a:t>
+            </a:r>
+            <a:endParaRPr lang="en-US" sz="1200" dirty="0"/>
+          </a:p>
+          <a:p>
+            <a:pPr algn="l" marL="342900" indent="-342900">
+              <a:spcAft>
+                <a:spcPts val="600"/>
+              </a:spcAft>
+              <a:buSzPct val="100000"/>
+              <a:buChar char="•"/>
+            </a:pPr>
+            <a:r>
+              <a:rPr lang="en-US" sz="1200" dirty="0">
+                <a:solidFill>
+                  <a:schemeClr val="tx1"/>
+                </a:solidFill>
+              </a:rPr>
+              <a:t>The whole stack starts from the zipped archive with docker compose, run for real on 15 and 17 October.</a:t>
+            </a:r>
+            <a:endParaRPr lang="en-US" sz="1200" dirty="0"/>
+          </a:p>
+        </p:txBody>
+      </p:sp>
+      <p:sp>
+        <p:nvSpPr>
+          <p:cNvPr id="7" name="content-7-rect-5"/>
           <p:cNvSpPr/>
           <p:nvPr/>
         </p:nvSpPr>
         <p:spPr>
           <a:xfrm>
-            <a:off x="5486400" y="2103120"/>
-            <a:ext cx="3200400" cy="731520"/>
+            <a:off x="4663440" y="1234440"/>
+            <a:ext cx="4023360" cy="3154680"/>
           </a:xfrm>
           <a:prstGeom prst="roundRect">
             <a:avLst>
-              <a:gd name="adj" fmla="val 10000"/>
+              <a:gd name="adj" fmla="val 2319"/>
             </a:avLst>
           </a:prstGeom>
           <a:solidFill>
@@ -9329,14 +9313,70 @@
       </p:sp>
       <p:sp>
         <p:nvSpPr>
+          <p:cNvPr id="8" name="content-7-rect-6"/>
+          <p:cNvSpPr/>
+          <p:nvPr/>
+        </p:nvSpPr>
+        <p:spPr>
+          <a:xfrm>
+            <a:off x="4846320" y="1371600"/>
+            <a:ext cx="109728" cy="365760"/>
+          </a:xfrm>
+          <a:prstGeom prst="rect">
+            <a:avLst/>
+          </a:prstGeom>
+          <a:solidFill>
+            <a:schemeClr val="accent3"/>
+          </a:solidFill>
+          <a:ln/>
+        </p:spPr>
+      </p:sp>
+      <p:sp>
+        <p:nvSpPr>
+          <p:cNvPr id="9" name="content-7-text-7"/>
+          <p:cNvSpPr txBox="1"/>
+          <p:nvPr/>
+        </p:nvSpPr>
+        <p:spPr>
+          <a:xfrm>
+            <a:off x="5047488" y="1325880"/>
+            <a:ext cx="3474720" cy="457200"/>
+          </a:xfrm>
+          <a:prstGeom prst="rect">
+            <a:avLst/>
+          </a:prstGeom>
+          <a:noFill/>
+          <a:ln/>
+        </p:spPr>
+        <p:txBody>
+          <a:bodyPr wrap="square" lIns="0" tIns="0" rIns="0" bIns="0" rtlCol="0" anchor="ctr"/>
+          <a:lstStyle/>
+          <a:p>
+            <a:pPr algn="l" indent="0" marL="0">
+              <a:buNone/>
+            </a:pPr>
+            <a:r>
+              <a:rPr lang="en-US" sz="1800" b="1" dirty="0">
+                <a:solidFill>
+                  <a:schemeClr val="accent3"/>
+                </a:solidFill>
+              </a:rPr>
+              <a:t>Not proven, and we say so</a:t>
+            </a:r>
+            <a:endParaRPr lang="en-US" sz="1800" dirty="0"/>
+          </a:p>
+        </p:txBody>
+      </p:sp>
+      <p:sp>
+        <p:nvSpPr>
           <p:cNvPr id="10" name="content-7-text-8"/>
           <p:cNvSpPr txBox="1"/>
           <p:nvPr/>
         </p:nvSpPr>
         <p:spPr>
           <a:xfrm>
-            <a:off x="5623560" y="2139696"/>
-            <a:ext cx="2926080" cy="256032"/>
+            <a:off x="4846320" y="1920240"/>
+            <a:ext cx="3657600" cy="2377440"/>
           </a:xfrm>
           <a:prstGeom prst="rect">
             <a:avLst/>
@@ -9348,18 +9388,76 @@
           <a:bodyPr wrap="square" lIns="0" tIns="0" rIns="0" bIns="0" rtlCol="0" anchor="t"/>
           <a:lstStyle/>
           <a:p>
-            <a:pPr algn="l" indent="0" marL="0">
-              <a:buNone/>
-            </a:pPr>
-            <a:r>
-              <a:rPr lang="en-US" sz="1400" b="1" dirty="0">
-                <a:solidFill>
-                  <a:schemeClr val="accent1"/>
-                </a:solidFill>
-              </a:rPr>
-              <a:t>Lock</a:t>
-            </a:r>
-            <a:endParaRPr lang="en-US" sz="1400" dirty="0"/>
+            <a:pPr algn="l" marL="342900" indent="-342900">
+              <a:spcAft>
+                <a:spcPts val="600"/>
+              </a:spcAft>
+              <a:buSzPct val="100000"/>
+              <a:buChar char="•"/>
+            </a:pPr>
+            <a:r>
+              <a:rPr lang="en-US" sz="1200" dirty="0">
+                <a:solidFill>
+                  <a:schemeClr val="tx1"/>
+                </a:solidFill>
+              </a:rPr>
+              <a:t>Rates, fees and city costs are invented. We have not compared them with real quotes yet.</a:t>
+            </a:r>
+            <a:endParaRPr lang="en-US" sz="1200" dirty="0"/>
+          </a:p>
+          <a:p>
+            <a:pPr algn="l" marL="342900" indent="-342900">
+              <a:spcAft>
+                <a:spcPts val="600"/>
+              </a:spcAft>
+              <a:buSzPct val="100000"/>
+              <a:buChar char="•"/>
+            </a:pPr>
+            <a:r>
+              <a:rPr lang="en-US" sz="1200" dirty="0">
+                <a:solidFill>
+                  <a:schemeClr val="tx1"/>
+                </a:solidFill>
+              </a:rPr>
+              <a:t>No real parent has used it. The trained models saw synthetic data.</a:t>
+            </a:r>
+            <a:endParaRPr lang="en-US" sz="1200" dirty="0"/>
+          </a:p>
+          <a:p>
+            <a:pPr algn="l" marL="342900" indent="-342900">
+              <a:spcAft>
+                <a:spcPts val="600"/>
+              </a:spcAft>
+              <a:buSzPct val="100000"/>
+              <a:buChar char="•"/>
+            </a:pPr>
+            <a:r>
+              <a:rPr lang="en-US" sz="1200" dirty="0">
+                <a:solidFill>
+                  <a:schemeClr val="tx1"/>
+                </a:solidFill>
+              </a:rPr>
+              <a:t>No outside security review or penetration test.</a:t>
+            </a:r>
+            <a:endParaRPr lang="en-US" sz="1200" dirty="0"/>
+          </a:p>
+          <a:p>
+            <a:pPr algn="l" marL="342900" indent="-342900">
+              <a:spcAft>
+                <a:spcPts val="600"/>
+              </a:spcAft>
+              <a:buSzPct val="100000"/>
+              <a:buChar char="•"/>
+            </a:pPr>
+            <a:r>
+              <a:rPr lang="en-US" sz="1200" dirty="0">
+                <a:solidFill>
+                  <a:schemeClr val="tx1"/>
+                </a:solidFill>
+              </a:rPr>
+              <a:t>Bangladesh Bank limits are placeholders, marked Not verified.</a:t>
+            </a:r>
+            <a:endParaRPr lang="en-US" sz="1200" dirty="0"/>
           </a:p>
         </p:txBody>
       </p:sp>
@@ -9371,8 +9469,8 @@
         </p:nvSpPr>
         <p:spPr>
           <a:xfrm>
-            <a:off x="5623560" y="2395728"/>
-            <a:ext cx="2971800" cy="420624"/>
+            <a:off x="457200" y="4526280"/>
+            <a:ext cx="8229600" cy="320040"/>
           </a:xfrm>
           <a:prstGeom prst="rect">
             <a:avLst/>
@@ -9388,202 +9486,14 @@
               <a:buNone/>
             </a:pPr>
             <a:r>
-              <a:rPr lang="en-US" sz="1100" dirty="0">
-                <a:solidFill>
-                  <a:schemeClr val="tx1"/>
-                </a:solidFill>
-              </a:rPr>
-              <a:t>A fresh MFA proof from the parent. The funds wait in the contract.</a:t>
-            </a:r>
-            <a:endParaRPr lang="en-US" sz="1100" dirty="0"/>
-          </a:p>
-        </p:txBody>
-      </p:sp>
-      <p:sp>
-        <p:nvSpPr>
-          <p:cNvPr id="12" name="content-7-rect-10"/>
-          <p:cNvSpPr/>
-          <p:nvPr/>
-        </p:nvSpPr>
-        <p:spPr>
-          <a:xfrm>
-            <a:off x="5486400" y="2926080"/>
-            <a:ext cx="3200400" cy="731520"/>
-          </a:xfrm>
-          <a:prstGeom prst="roundRect">
-            <a:avLst>
-              <a:gd name="adj" fmla="val 10000"/>
-            </a:avLst>
-          </a:prstGeom>
-          <a:solidFill>
-            <a:schemeClr val="bg2"/>
-          </a:solidFill>
-          <a:ln/>
-        </p:spPr>
-      </p:sp>
-      <p:sp>
-        <p:nvSpPr>
-          <p:cNvPr id="13" name="content-7-text-11"/>
-          <p:cNvSpPr txBox="1"/>
-          <p:nvPr/>
-        </p:nvSpPr>
-        <p:spPr>
-          <a:xfrm>
-            <a:off x="5623560" y="2962656"/>
-            <a:ext cx="2926080" cy="256032"/>
-          </a:xfrm>
-          <a:prstGeom prst="rect">
-            <a:avLst/>
-          </a:prstGeom>
-          <a:noFill/>
-          <a:ln/>
-        </p:spPr>
-        <p:txBody>
-          <a:bodyPr wrap="square" lIns="0" tIns="0" rIns="0" bIns="0" rtlCol="0" anchor="t"/>
-          <a:lstStyle/>
-          <a:p>
-            <a:pPr algn="l" indent="0" marL="0">
-              <a:buNone/>
-            </a:pPr>
-            <a:r>
-              <a:rPr lang="en-US" sz="1400" b="1" dirty="0">
-                <a:solidFill>
-                  <a:schemeClr val="accent1"/>
-                </a:solidFill>
-              </a:rPr>
-              <a:t>Release</a:t>
-            </a:r>
-            <a:endParaRPr lang="en-US" sz="1400" dirty="0"/>
-          </a:p>
-        </p:txBody>
-      </p:sp>
-      <p:sp>
-        <p:nvSpPr>
-          <p:cNvPr id="14" name="content-7-text-12"/>
-          <p:cNvSpPr txBox="1"/>
-          <p:nvPr/>
-        </p:nvSpPr>
-        <p:spPr>
-          <a:xfrm>
-            <a:off x="5623560" y="3218688"/>
-            <a:ext cx="2971800" cy="420624"/>
-          </a:xfrm>
-          <a:prstGeom prst="rect">
-            <a:avLst/>
-          </a:prstGeom>
-          <a:noFill/>
-          <a:ln/>
-        </p:spPr>
-        <p:txBody>
-          <a:bodyPr wrap="square" lIns="0" tIns="0" rIns="0" bIns="0" rtlCol="0" anchor="t"/>
-          <a:lstStyle/>
-          <a:p>
-            <a:pPr algn="l" indent="0" marL="0">
-              <a:buNone/>
-            </a:pPr>
-            <a:r>
-              <a:rPr lang="en-US" sz="1100" dirty="0">
-                <a:solidFill>
-                  <a:schemeClr val="tx1"/>
-                </a:solidFill>
-              </a:rPr>
-              <a:t>On the dates chosen. A reviewer can freeze it with a reason, never move the funds.</a:t>
-            </a:r>
-            <a:endParaRPr lang="en-US" sz="1100" dirty="0"/>
-          </a:p>
-        </p:txBody>
-      </p:sp>
-      <p:sp>
-        <p:nvSpPr>
-          <p:cNvPr id="15" name="content-7-rect-13"/>
-          <p:cNvSpPr/>
-          <p:nvPr/>
-        </p:nvSpPr>
-        <p:spPr>
-          <a:xfrm>
-            <a:off x="5486400" y="3749040"/>
-            <a:ext cx="3200400" cy="731520"/>
-          </a:xfrm>
-          <a:prstGeom prst="roundRect">
-            <a:avLst>
-              <a:gd name="adj" fmla="val 10000"/>
-            </a:avLst>
-          </a:prstGeom>
-          <a:solidFill>
-            <a:schemeClr val="bg2"/>
-          </a:solidFill>
-          <a:ln/>
-        </p:spPr>
-      </p:sp>
-      <p:sp>
-        <p:nvSpPr>
-          <p:cNvPr id="16" name="content-7-text-14"/>
-          <p:cNvSpPr txBox="1"/>
-          <p:nvPr/>
-        </p:nvSpPr>
-        <p:spPr>
-          <a:xfrm>
-            <a:off x="5623560" y="3785616"/>
-            <a:ext cx="2926080" cy="256032"/>
-          </a:xfrm>
-          <a:prstGeom prst="rect">
-            <a:avLst/>
-          </a:prstGeom>
-          <a:noFill/>
-          <a:ln/>
-        </p:spPr>
-        <p:txBody>
-          <a:bodyPr wrap="square" lIns="0" tIns="0" rIns="0" bIns="0" rtlCol="0" anchor="t"/>
-          <a:lstStyle/>
-          <a:p>
-            <a:pPr algn="l" indent="0" marL="0">
-              <a:buNone/>
-            </a:pPr>
-            <a:r>
-              <a:rPr lang="en-US" sz="1400" b="1" dirty="0">
-                <a:solidFill>
-                  <a:schemeClr val="accent1"/>
-                </a:solidFill>
-              </a:rPr>
-              <a:t>Privacy</a:t>
-            </a:r>
-            <a:endParaRPr lang="en-US" sz="1400" dirty="0"/>
-          </a:p>
-        </p:txBody>
-      </p:sp>
-      <p:sp>
-        <p:nvSpPr>
-          <p:cNvPr id="17" name="content-7-text-15"/>
-          <p:cNvSpPr txBox="1"/>
-          <p:nvPr/>
-        </p:nvSpPr>
-        <p:spPr>
-          <a:xfrm>
-            <a:off x="5623560" y="4041648"/>
-            <a:ext cx="2971800" cy="420624"/>
-          </a:xfrm>
-          <a:prstGeom prst="rect">
-            <a:avLst/>
-          </a:prstGeom>
-          <a:noFill/>
-          <a:ln/>
-        </p:spPr>
-        <p:txBody>
-          <a:bodyPr wrap="square" lIns="0" tIns="0" rIns="0" bIns="0" rtlCol="0" anchor="t"/>
-          <a:lstStyle/>
-          <a:p>
-            <a:pPr algn="l" indent="0" marL="0">
-              <a:buNone/>
-            </a:pPr>
-            <a:r>
-              <a:rPr lang="en-US" sz="1100" dirty="0">
-                <a:solidFill>
-                  <a:schemeClr val="tx1"/>
-                </a:solidFill>
-              </a:rPr>
-              <a:t>Only amounts, dates and hashes go on the chain. The AI has no access.</a:t>
-            </a:r>
-            <a:endParaRPr lang="en-US" sz="1100" dirty="0"/>
+              <a:rPr lang="en-US" sz="1200" dirty="0">
+                <a:solidFill>
+                  <a:schemeClr val="tx2"/>
+                </a:solidFill>
+              </a:rPr>
+              <a:t>Both lists are in the repository: docs/OPEN_QUESTIONS.md and docs/SECURITY_SELF_ASSESSMENT.md</a:t>
+            </a:r>
+            <a:endParaRPr lang="en-US" sz="1200" dirty="0"/>
           </a:p>
         </p:txBody>
       </p:sp>

</xml_diff>

<commit_message>
feat: harden payment routes, agent safety and release verification
- Enforce institution-specific tuition payment route restrictions
- Preserve recipient policy bindings across renames
- Strengthen agent confirmation and audit trust-boundary handling
- Add regression tests, security checks and reproducible evaluation
- Include updated demos, verification evidence and deployment guidance
- Sanitize source packaging and exclude private runtime files
</commit_message>
<xml_diff>
--- a/submission/StudyRoute_Deck.pptx
+++ b/submission/StudyRoute_Deck.pptx
@@ -1774,91 +1774,91 @@
 </file>
 
 <file path=ppt/notesSlides/notesSlide9.xml><?xml version="1.0" encoding="utf-8"?>
-<p:notes xmlns:a="http://schemas.openxmlformats.org/drawingml/2006/main" xmlns:r="http://schemas.openxmlformats.org/officeDocument/2006/relationships" xmlns:p="http://schemas.openxmlformats.org/presentationml/2006/main">
-  <p:cSld>
-    <p:spTree>
-      <p:nvGrpSpPr>
-        <p:cNvPr id="1" name=""/>
-        <p:cNvGrpSpPr/>
-        <p:nvPr/>
-      </p:nvGrpSpPr>
-      <p:grpSpPr>
-        <a:xfrm>
-          <a:off x="0" y="0"/>
-          <a:ext cx="0" cy="0"/>
-          <a:chOff x="0" y="0"/>
-          <a:chExt cx="0" cy="0"/>
-        </a:xfrm>
-      </p:grpSpPr>
-      <p:sp>
-        <p:nvSpPr>
-          <p:cNvPr id="2" name="Slide Image Placeholder 1"/>
-          <p:cNvSpPr>
-            <a:spLocks noGrp="1" noRot="1" noChangeAspect="1"/>
-          </p:cNvSpPr>
-          <p:nvPr>
-            <p:ph type="sldImg"/>
-          </p:nvPr>
-        </p:nvSpPr>
-        <p:spPr/>
-      </p:sp>
-      <p:sp>
-        <p:nvSpPr>
-          <p:cNvPr id="3" name="Notes Placeholder 2"/>
-          <p:cNvSpPr>
-            <a:spLocks noGrp="1"/>
-          </p:cNvSpPr>
-          <p:nvPr>
-            <p:ph type="body" idx="1"/>
-          </p:nvPr>
-        </p:nvSpPr>
-        <p:spPr/>
-        <p:txBody>
-          <a:bodyPr/>
-          <a:lstStyle/>
-          <a:p>
-            <a:r>
-              <a:rPr lang="en-US" dirty="0"/>
-              <a:t>The assistant has a trained component, and we measured it. A small language model, fine-tuned on a gaming-class GPU in a few minutes, reads what a parent types: the intent, and the exact words that carry an amount, a currency or a date. It never produces a number; plain code turns those words into values, and when the old rules and the model disagree, the assistant asks. On messages we wrote by hand after the model was frozen, it chose the right intent 88.5% of the time against 61.1% for the old rules, read a plan request exactly 100% against 57.6%, and blocked 92.9% of attacks against 28.6%. The sample is small and the data is synthetic. A second small policy, trained with reinforcement learning, chooses whether to ask, read back or plan: on simulated parents, wrong plans fell from 2.8% to 0.8%. Plain code limits its legal moves, and the parents are our assumption.</a:t>
-            </a:r>
-            <a:endParaRPr lang="en-US" dirty="0"/>
-          </a:p>
-        </p:txBody>
-      </p:sp>
-      <p:sp>
-        <p:nvSpPr>
-          <p:cNvPr id="4" name="Slide Number Placeholder 3"/>
-          <p:cNvSpPr>
-            <a:spLocks noGrp="1"/>
-          </p:cNvSpPr>
-          <p:nvPr>
-            <p:ph type="sldNum" sz="quarter" idx="10"/>
-          </p:nvPr>
-        </p:nvSpPr>
-        <p:spPr/>
-        <p:txBody>
-          <a:bodyPr/>
-          <a:lstStyle/>
-          <a:p>
-            <a:fld id="{F7021451-1387-4CA6-816F-3879F97B5CBC}" type="slidenum">
-              <a:rPr lang="en-US"/>
-              <a:t>9</a:t>
-            </a:fld>
-            <a:endParaRPr lang="en-US"/>
-          </a:p>
-        </p:txBody>
-      </p:sp>
-    </p:spTree>
-    <p:extLst>
-      <p:ext uri="{BB962C8B-B14F-4D97-AF65-F5344CB8AC3E}">
-        <p14:creationId xmlns:p14="http://schemas.microsoft.com/office/powerpoint/2010/main" val="1024086991"/>
-      </p:ext>
-    </p:extLst>
-  </p:cSld>
-  <p:clrMapOvr>
-    <a:masterClrMapping/>
-  </p:clrMapOvr>
-</p:notes>
+<ns0:notes xmlns:ns0="http://schemas.openxmlformats.org/presentationml/2006/main" xmlns:ns1="http://schemas.openxmlformats.org/drawingml/2006/main" xmlns:ns2="http://schemas.microsoft.com/office/powerpoint/2010/main">
+  <ns0:cSld>
+    <ns0:spTree>
+      <ns0:nvGrpSpPr>
+        <ns0:cNvPr id="1" name=""/>
+        <ns0:cNvGrpSpPr/>
+        <ns0:nvPr/>
+      </ns0:nvGrpSpPr>
+      <ns0:grpSpPr>
+        <ns1:xfrm>
+          <ns1:off x="0" y="0"/>
+          <ns1:ext cx="0" cy="0"/>
+          <ns1:chOff x="0" y="0"/>
+          <ns1:chExt cx="0" cy="0"/>
+        </ns1:xfrm>
+      </ns0:grpSpPr>
+      <ns0:sp>
+        <ns0:nvSpPr>
+          <ns0:cNvPr id="2" name="Slide Image Placeholder 1"/>
+          <ns0:cNvSpPr>
+            <ns1:spLocks noGrp="1" noRot="1" noChangeAspect="1"/>
+          </ns0:cNvSpPr>
+          <ns0:nvPr>
+            <ns0:ph type="sldImg"/>
+          </ns0:nvPr>
+        </ns0:nvSpPr>
+        <ns0:spPr/>
+      </ns0:sp>
+      <ns0:sp>
+        <ns0:nvSpPr>
+          <ns0:cNvPr id="3" name="Notes Placeholder 2"/>
+          <ns0:cNvSpPr>
+            <ns1:spLocks noGrp="1"/>
+          </ns0:cNvSpPr>
+          <ns0:nvPr>
+            <ns0:ph type="body" idx="1"/>
+          </ns0:nvPr>
+        </ns0:nvSpPr>
+        <ns0:spPr/>
+        <ns0:txBody>
+          <ns1:bodyPr/>
+          <ns1:lstStyle/>
+          <ns1:p>
+            <ns1:r>
+              <ns1:rPr lang="en-US" dirty="0"/>
+              <ns1:t>The assistant has a trained component, and we measured it. A small language model, fine-tuned on a gaming-class GPU in a few minutes, reads what a parent types: the intent, and the exact words that carry an amount, a currency or a date. It never produces a number; plain code turns those words into values, and when the old rules and the model disagree, the assistant asks. On messages we wrote by hand after the model was frozen, it chose the right intent 88.5% of the time against 61.1% for the old rules, read a plan request exactly 100% against 57.6%, and blocked 92.9% of attacks against 28.6%. The sample is small and the data is synthetic. A second small policy, trained with reinforcement learning, chooses whether to ask, read back or plan: on simulated parents, wrong plans fell from 2.8% to 0.8%. Plain code limits its legal moves, and the parents are our assumption. Repair-release qualification: this frozen holdout has now been reused for reproduction, not a new blind study. These RL numbers describe the raw simulator policy, not the runtime review envelope. The default API now requires deterministic missing/conflicting-slot clarification and completed-value confirmation before planning, regardless of turn budget.</ns1:t>
+            </ns1:r>
+            <ns1:endParaRPr lang="en-US" dirty="0"/>
+          </ns1:p>
+        </ns0:txBody>
+      </ns0:sp>
+      <ns0:sp>
+        <ns0:nvSpPr>
+          <ns0:cNvPr id="4" name="Slide Number Placeholder 3"/>
+          <ns0:cNvSpPr>
+            <ns1:spLocks noGrp="1"/>
+          </ns0:cNvSpPr>
+          <ns0:nvPr>
+            <ns0:ph type="sldNum" sz="quarter" idx="10"/>
+          </ns0:nvPr>
+        </ns0:nvSpPr>
+        <ns0:spPr/>
+        <ns0:txBody>
+          <ns1:bodyPr/>
+          <ns1:lstStyle/>
+          <ns1:p>
+            <ns1:fld id="{F7021451-1387-4CA6-816F-3879F97B5CBC}" type="slidenum">
+              <ns1:rPr lang="en-US"/>
+              <ns1:t>9</ns1:t>
+            </ns1:fld>
+            <ns1:endParaRPr lang="en-US"/>
+          </ns1:p>
+        </ns0:txBody>
+      </ns0:sp>
+    </ns0:spTree>
+    <ns0:extLst>
+      <ns0:ext uri="{BB962C8B-B14F-4D97-AF65-F5344CB8AC3E}">
+        <ns2:creationId val="1024086991"/>
+      </ns0:ext>
+    </ns0:extLst>
+  </ns0:cSld>
+  <ns0:clrMapOvr>
+    <ns1:masterClrMapping/>
+  </ns0:clrMapOvr>
+</ns0:notes>
 </file>
 
 <file path=ppt/slideLayouts/slideLayout1.xml><?xml version="1.0" encoding="utf-8"?>
@@ -3246,7 +3246,7 @@
                 <a:ea typeface="+mj-lt" pitchFamily="34" charset="-122"/>
                 <a:cs typeface="+mj-lt" pitchFamily="34" charset="-120"/>
               </a:rPr>
-              <a:t>1534</a:t>
+              <a:t>See logs</a:t>
             </a:r>
             <a:endParaRPr lang="en-US" sz="3200" dirty="0"/>
           </a:p>
@@ -3282,7 +3282,7 @@
                   <a:schemeClr val="tx2"/>
                 </a:solidFill>
               </a:rPr>
-              <a:t>backend tests, all passing</a:t>
+              <a:t>current backend verification</a:t>
             </a:r>
             <a:endParaRPr lang="en-US" sz="1200" dirty="0"/>
           </a:p>
@@ -3609,7 +3609,7 @@
                   <a:schemeClr val="tx2"/>
                 </a:solidFill>
               </a:rPr>
-              <a:t>Each payment has a compliance report with a hash your browser can check. Every threat has a test: docs/SECURITY.md</a:t>
+              <a:t>Report hashes detect changes against a trusted hash, not provenance. Known gaps: docs/RELEASE_FIXES.md</a:t>
             </a:r>
             <a:endParaRPr lang="en-US" sz="1200" dirty="0"/>
           </a:p>
@@ -4380,7 +4380,7 @@
                 <a:ea typeface="+mj-lt" pitchFamily="34" charset="-122"/>
                 <a:cs typeface="+mj-lt" pitchFamily="34" charset="-120"/>
               </a:rPr>
-              <a:t>Clear, cheap and safe.</a:t>
+              <a:t>Clear costs. Human control.</a:t>
             </a:r>
             <a:endParaRPr lang="en-US" sz="2400" dirty="0"/>
           </a:p>
@@ -4416,7 +4416,7 @@
                   <a:schemeClr val="accent5"/>
                 </a:solidFill>
               </a:rPr>
-              <a:t>TeamEkxin  ·  https://github.com/NoobCrow/StudyRoute  ·  Sandbox: no real money moves</a:t>
+              <a:t>TeamEkxin  ·  https://github.com/redwan786/StudyRoute  ·  Sandbox: no real money moves</a:t>
             </a:r>
             <a:endParaRPr lang="en-US" sz="1200" dirty="0"/>
           </a:p>
@@ -9229,7 +9229,7 @@
                   <a:schemeClr val="tx1"/>
                 </a:solidFill>
               </a:rPr>
-              <a:t>Every number comes from one engine, in integer money. 1534 backend tests cover all 24 scenarios.</a:t>
+              <a:t>Money uses one deterministic integer engine. See release evidence for current tests and all 24 mapped scenarios.</a:t>
             </a:r>
             <a:endParaRPr lang="en-US" sz="1200" dirty="0"/>
           </a:p>
@@ -9265,7 +9265,7 @@
                   <a:schemeClr val="tx1"/>
                 </a:solidFill>
               </a:rPr>
-              <a:t>Edit one audit row and Verify fails at that event. A rewritten chain is caught by the anchor.</a:t>
+              <a:t>Local anchors detect audit-only rewrites, not a DB owner rewriting both logs. Checkpoints need separate protection.</a:t>
             </a:r>
             <a:endParaRPr lang="en-US" sz="1200" dirty="0"/>
           </a:p>
@@ -9283,7 +9283,7 @@
                   <a:schemeClr val="tx1"/>
                 </a:solidFill>
               </a:rPr>
-              <a:t>The whole stack starts from the zipped archive with docker compose, run for real on 15 and 17 October.</a:t>
+              <a:t>Fresh local API and UI checks are in release evidence. Docker logs are inherited, not rerun for this repair.</a:t>
             </a:r>
             <a:endParaRPr lang="en-US" sz="1200" dirty="0"/>
           </a:p>
@@ -9437,7 +9437,7 @@
                   <a:schemeClr val="tx1"/>
                 </a:solidFill>
               </a:rPr>
-              <a:t>No outside security review or penetration test.</a:t>
+              <a:t>Local code review and regression tests; no external penetration test.</a:t>
             </a:r>
             <a:endParaRPr lang="en-US" sz="1200" dirty="0"/>
           </a:p>
@@ -10395,7 +10395,7 @@
                             <a:schemeClr val="bg1"/>
                           </a:solidFill>
                         </a:rPr>
-                        <a:t>On 113 new messages</a:t>
+                        <a:t>On 113 frozen messages</a:t>
                       </a:r>
                       <a:endParaRPr lang="en-US" sz="1400" dirty="0"/>
                     </a:p>
@@ -11321,7 +11321,7 @@
                   <a:schemeClr val="tx2"/>
                 </a:solidFill>
               </a:rPr>
-              <a:t>Written by hand after the model was frozen, scored once. A small sample: about plus or minus 7 points. Real bank questions: rules 40.1%, agent 95.1%.</a:t>
+              <a:t>Frozen holdout, now re-evaluated; not a new blind study. Small sample. Banking77 routing: rules 40.1%, agent 95.1%.</a:t>
             </a:r>
             <a:endParaRPr lang="en-US" sz="1200" dirty="0"/>
           </a:p>
@@ -11509,7 +11509,7 @@
                   <a:schemeClr val="tx1"/>
                 </a:solidFill>
               </a:rPr>
-              <a:t>A policy trained by Double DQN decides when to ask, read back or plan. On simulated parents: wrong plans 0.8% against 2.8%, 1.17 questions against 0.44. Code limits its legal moves.</a:t>
+              <a:t>Raw DQN simulator: wrong plans 0.8% vs 2.8%. API now adds mandatory clarification and read-back; those simulator figures exclude it.</a:t>
             </a:r>
             <a:endParaRPr lang="en-US" sz="1100" dirty="0"/>
           </a:p>

</xml_diff>

<commit_message>
feat: trained explainer, AI risk score with bank review desk, model comparison
- Trained explainer: FLAN-T5-small distilled from verified teacher rewrites, int8 ONNX,
  every rewrite checked in code, engine draft shown on any failure.
- AI risk score (amount, frequency, timeline, person) on every payment: a warning only
  when medium or high; every payment still needs a person's MFA authorization.
- Bank review desk: reviewer queue, one-page brief, yes / no / ask for more with MFA,
  clock and reminder, plain-language page for parents; optional bank-authorizes-all setting.
- Risk model trained on IBM synthetic AML data; channel, currency, time of day and round
  amounts removed after ablation showed they were generator habits; all model families
  compared on one time split (docs/AI_RISK_MODELS.md).
- Tests: backend 1,652 passed, web 462, browser 24. Docs, deck, video script and Q&A updated.
</commit_message>
<xml_diff>
--- a/submission/StudyRoute_Deck.pptx
+++ b/submission/StudyRoute_Deck.pptx
@@ -118,25 +118,25 @@
   <p:extLst>
     <p:ext uri="{521415D9-36F7-43E2-AB2F-B90AF26B5E84}">
       <p14:sectionLst xmlns:p14="http://schemas.microsoft.com/office/powerpoint/2010/main">
-        <p14:section name="Opening" id="{f86be450-ab88-73b1-c0d8-21b2b3123181}">
+        <p14:section name="Opening" id="{beef7f08-c5cb-bfca-ce2c-5b8bc06536d7}">
           <p14:sldIdLst>
             <p14:sldId id="256"/>
             <p14:sldId id="257"/>
           </p14:sldIdLst>
         </p14:section>
-        <p14:section name="The problem" id="{ad24fab0-93e7-0a1b-c64f-6700cdd586ca}">
+        <p14:section name="The problem" id="{b9061e67-4539-7806-b6e5-516f1d97ee74}">
           <p14:sldIdLst>
             <p14:sldId id="258"/>
             <p14:sldId id="259"/>
           </p14:sldIdLst>
         </p14:section>
-        <p14:section name="The solution" id="{13ad92fb-9fbe-8f21-092c-2575e2f41e88}">
+        <p14:section name="The solution" id="{f004a257-5e64-d913-37ba-0d805ac41ec8}">
           <p14:sldIdLst>
             <p14:sldId id="260"/>
             <p14:sldId id="261"/>
           </p14:sldIdLst>
         </p14:section>
-        <p14:section name="Trust" id="{96142a7a-868c-c77a-f6fa-91dbf6c72eee}">
+        <p14:section name="Trust" id="{0fa2022f-10a3-b8d1-11ac-ba28fecc79c8}">
           <p14:sldIdLst>
             <p14:sldId id="262"/>
             <p14:sldId id="263"/>
@@ -145,7 +145,7 @@
             <p14:sldId id="266"/>
           </p14:sldIdLst>
         </p14:section>
-        <p14:section name="Close" id="{4d501253-3d1a-8409-96a5-a156a5f116bd}">
+        <p14:section name="Close" id="{3ccf4cc8-c141-0bb0-d40d-cbdb178a7242}">
           <p14:sldIdLst>
             <p14:sldId id="267"/>
           </p14:sldIdLst>
@@ -851,7 +851,7 @@
           <a:p>
             <a:r>
               <a:rPr lang="en-US" dirty="0"/>
-              <a:t>Good morning. We are team TeamEkxin, and this is StudyRoute, our entry for Topic C, the cross-border and student finance assistant. StudyRoute is a sandbox AI agent that helps a parent in Bangladesh pay a student's tuition abroad. Everything you will see is synthetic and no real money moves. Our design rule is on the slide, and the rest of the talk shows how we make each of those four sentences true and testable: the engine calculates, the AI explains, the human approves, and every step is logged.</a:t>
+              <a:t>Good morning. We are team [Team name], and this is StudyRoute, our entry for Topic C, the cross-border and student finance assistant. StudyRoute is a sandbox AI agent that helps a parent in Bangladesh pay a student's tuition abroad. Everything you will see is synthetic and no real money moves. Our design rule is on the slide, and the rest of the talk shows how we make each of those four sentences true and testable: the engine calculates, the AI explains, the human approves, and every step is logged.</a:t>
             </a:r>
             <a:endParaRPr lang="en-US" dirty="0"/>
           </a:p>
@@ -939,7 +939,7 @@
           <a:p>
             <a:r>
               <a:rPr lang="en-US" dirty="0"/>
-              <a:t>Security and compliance is thirty percent of the score, so we made it checkable. On the left are the permission tiers, enforced in the domain layer, not just in the screens. Public, read, prepare, decide, and administer. Deciding, meaning approving a payment, is only for a human parent with a fresh MFA proof bound to that payment and to the hash of the summary they saw. The AI has no approve, cancel, limit or config permission at all. On the right, the numbers: 1534 backend and 439 frontend tests, all 24 blueprint scenarios mapped to tests, and 50 known risks that we list openly in the self-assessment. The audit log is hash-chained: Verify passes, we edit one row behind the application's back, and Verify fails at exactly that event.</a:t>
+              <a:t>Security and compliance is thirty percent of the score, so we made it checkable. On the left are the permission tiers, enforced in the domain layer, not just in the screens. Public, read, prepare, decide, and administer. Deciding, meaning approving a payment, is only for a human parent with a fresh MFA proof bound to that payment and to the hash of the summary they saw. The AI has no approve, cancel, limit or config permission at all. On the right, the numbers: 1652 backend and 462 frontend tests, all 24 blueprint scenarios mapped to tests, and 55 known risks that we list openly in the self-assessment. The audit log is hash-chained: Verify passes, we edit one row behind the application's back, and Verify fails at exactly that event.</a:t>
             </a:r>
             <a:endParaRPr lang="en-US" dirty="0"/>
           </a:p>
@@ -1643,7 +1643,7 @@
           <a:p>
             <a:r>
               <a:rPr lang="en-US" dirty="0"/>
-              <a:t>Before the details, here is what we have shown and what we have not. What we have shown: every number comes from one deterministic engine, with 1534 backend tests covering all 24 scenarios. Only a human with a fresh MFA code can approve, and the AI has no such permission. Change one audit row and Verify fails at that event. And the stack starts from the zipped archive with one command. What we have not shown: the rates, fees and city costs are invented, and we have not yet compared them with real quotes. No real parent has used it. No outsider has reviewed its security. The Bangladesh Bank limits are placeholders, marked Not verified. Both lists are in the repository, because we would rather you hear the limits from us.</a:t>
+              <a:t>Before the details, here is what we have shown and what we have not. What we have shown: every number comes from one deterministic engine, with 1652 backend tests covering all 24 scenarios. Only a human with a fresh MFA code can approve, and the AI has no such permission. Change one audit row and Verify fails at that event. And the stack starts from the zipped archive with one command. What we have not shown: the rates, fees and city costs are invented, and we have not yet compared them with real quotes. No real parent has used it. No outsider has reviewed its security. The Bangladesh Bank limits are placeholders, marked Not verified. Both lists are in the repository, because we would rather you hear the limits from us.</a:t>
             </a:r>
             <a:endParaRPr lang="en-US" dirty="0"/>
           </a:p>
@@ -1819,7 +1819,7 @@
           <a:p>
             <a:r>
               <a:rPr lang="en-US" dirty="0"/>
-              <a:t>The assistant has a trained component, and we measured it. A small language model, fine-tuned on a gaming-class GPU in a few minutes, reads what a parent types: the intent, and the exact words that carry an amount, a currency or a date. It never produces a number; plain code turns those words into values, and when the old rules and the model disagree, the assistant asks. On messages we wrote by hand after the model was frozen, it chose the right intent 88.5% of the time against 61.1% for the old rules, read a plan request exactly 100% against 57.6%, and blocked 92.9% of attacks against 28.6%. The sample is small and the data is synthetic. A second small policy, trained with reinforcement learning, chooses whether to ask, read back or plan: on simulated parents, wrong plans fell from 2.8% to 0.8%. Plain code limits its legal moves, and the parents are our assumption.</a:t>
+              <a:t>The assistant has a trained component, and we measured it. A small language model, fine-tuned on a gaming-class GPU in a few minutes, reads what a parent types: the intent, and the exact words that carry an amount, a currency or a date. It never produces a number; plain code turns those words into values, and when the old rules and the model disagree, the assistant asks. On messages we wrote by hand after the model was frozen, it chose the right intent 88.5% of the time against 61.1% for the old rules, read a plan request exactly 100% against 57.6%, and blocked 92.9% of attacks against 28.6%. The sample is small and the data is synthetic. A second small policy, trained with reinforcement learning, chooses whether to ask, read back or plan: on simulated parents, wrong plans fell from 2.8% to 0.8%. Plain code limits its legal moves, and the parents are our assumption. Two more small models are trained on the same GPU. A language model rewords the engine's answer on the user's own machine: on 700 held-out questions 80.9% of its answers pass every code check and the rest show the engine's own text; 99.8% of the figures it writes are the engine's. It mostly rewords. A risk model, trained on IBM's public synthetic transactions, gives each payment a score from four factors, amount, frequency, timeline and person: a low score shows no warning, a high one shows a warning and sends the payment to a person at the sandbox bank, and every payment needs a person's authorization whatever its score; on a later period it caught 56.5% of the flagged payments with 29.2% precision, and the data cannot support both above ninety. It routes; a person decides.</a:t>
             </a:r>
             <a:endParaRPr lang="en-US" dirty="0"/>
           </a:p>
@@ -2589,7 +2589,7 @@
                   <a:schemeClr val="accent5"/>
                 </a:solidFill>
               </a:rPr>
-              <a:t>TeamEkxin  ·  Sandbox: synthetic data, no real money moves</a:t>
+              <a:t>[Team name]  ·  Sandbox: synthetic data, no real money moves</a:t>
             </a:r>
             <a:endParaRPr lang="en-US" sz="1200" dirty="0"/>
           </a:p>
@@ -3246,7 +3246,7 @@
                 <a:ea typeface="+mj-lt" pitchFamily="34" charset="-122"/>
                 <a:cs typeface="+mj-lt" pitchFamily="34" charset="-120"/>
               </a:rPr>
-              <a:t>1534</a:t>
+              <a:t>1652</a:t>
             </a:r>
             <a:endParaRPr lang="en-US" sz="3200" dirty="0"/>
           </a:p>
@@ -3343,7 +3343,7 @@
                 <a:ea typeface="+mj-lt" pitchFamily="34" charset="-122"/>
                 <a:cs typeface="+mj-lt" pitchFamily="34" charset="-120"/>
               </a:rPr>
-              <a:t>439</a:t>
+              <a:t>462</a:t>
             </a:r>
             <a:endParaRPr lang="en-US" sz="3200" dirty="0"/>
           </a:p>
@@ -3537,7 +3537,7 @@
                 <a:ea typeface="+mj-lt" pitchFamily="34" charset="-122"/>
                 <a:cs typeface="+mj-lt" pitchFamily="34" charset="-120"/>
               </a:rPr>
-              <a:t>50</a:t>
+              <a:t>55</a:t>
             </a:r>
             <a:endParaRPr lang="en-US" sz="3200" dirty="0"/>
           </a:p>
@@ -4416,7 +4416,7 @@
                   <a:schemeClr val="accent5"/>
                 </a:solidFill>
               </a:rPr>
-              <a:t>TeamEkxin  ·  https://github.com/NoobCrow/StudyRoute  ·  Sandbox: no real money moves</a:t>
+              <a:t>[Team name]  ·  [repository link]  ·  Sandbox: no real money moves</a:t>
             </a:r>
             <a:endParaRPr lang="en-US" sz="1200" dirty="0"/>
           </a:p>
@@ -9229,7 +9229,7 @@
                   <a:schemeClr val="tx1"/>
                 </a:solidFill>
               </a:rPr>
-              <a:t>Every number comes from one engine, in integer money. 1534 backend tests cover all 24 scenarios.</a:t>
+              <a:t>Every number comes from one engine, in integer money. 1652 backend tests cover all 24 scenarios.</a:t>
             </a:r>
             <a:endParaRPr lang="en-US" sz="1200" dirty="0"/>
           </a:p>
@@ -10347,7 +10347,7 @@
                 <a:ea typeface="+mj-lt" pitchFamily="34" charset="-122"/>
                 <a:cs typeface="+mj-lt" pitchFamily="34" charset="-120"/>
               </a:rPr>
-              <a:t>A trained agent, measured</a:t>
+              <a:t>Trained agents, measured</a:t>
             </a:r>
             <a:endParaRPr lang="en-US" sz="3600" dirty="0"/>
           </a:p>
@@ -11567,7 +11567,7 @@
                   <a:schemeClr val="accent1"/>
                 </a:solidFill>
               </a:rPr>
-              <a:t>Honest limits</a:t>
+              <a:t>Also trained, and the limits</a:t>
             </a:r>
             <a:endParaRPr lang="en-US" sz="1400" dirty="0"/>
           </a:p>
@@ -11603,7 +11603,7 @@
                   <a:schemeClr val="tx1"/>
                 </a:solidFill>
               </a:rPr>
-              <a:t>Synthetic data, English, no real users yet. The simulated parents and rewards are our assumptions. About 1 attack in 14 still slips past; permissions and MFA remain the real defence.</a:t>
+              <a:t>A language model rewords answers (99.8% of its figures are the engine's; a failed check shows the engine's text). A risk model scores every payment (amount, frequency, timeline, person) and warns on a high one: precision 29.2%, recall 56.5%. Every payment needs a person's authorization anyway. Synthetic data, no real users.</a:t>
             </a:r>
             <a:endParaRPr lang="en-US" sz="1100" dirty="0"/>
           </a:p>

</xml_diff>

<commit_message>
docs: screenshots and execution evidence for the AI risk score, team details, clearer factor wording
- README gallery: the parent's risk score page, the reviewer's brief and queue.
- submission/evidence/review_demo_run.txt: the whole risk-score and bank-review story run live,
  every step checked.
- Team name and repository link filled into the deck; competition-rules self-check, checklist
  and video status updated (the team records the voiced pitch and makes the repository public).
- Factor sentences now say only what is true (ordinary or unusual) instead of implying a count.
- Release manifest refreshed.
</commit_message>
<xml_diff>
--- a/submission/StudyRoute_Deck.pptx
+++ b/submission/StudyRoute_Deck.pptx
@@ -118,25 +118,25 @@
   <p:extLst>
     <p:ext uri="{521415D9-36F7-43E2-AB2F-B90AF26B5E84}">
       <p14:sectionLst xmlns:p14="http://schemas.microsoft.com/office/powerpoint/2010/main">
-        <p14:section name="Opening" id="{8974faef-f38d-1118-cd70-6730b27bc152}">
+        <p14:section name="Opening" id="{acbe1e68-e342-1e8c-7df1-ccd258501cf1}">
           <p14:sldIdLst>
             <p14:sldId id="256"/>
             <p14:sldId id="257"/>
           </p14:sldIdLst>
         </p14:section>
-        <p14:section name="The problem" id="{e78b3180-e749-b805-8d52-c39897146366}">
+        <p14:section name="The problem" id="{b8a6905f-8da1-0600-1cda-e0a52aabc88f}">
           <p14:sldIdLst>
             <p14:sldId id="258"/>
             <p14:sldId id="259"/>
           </p14:sldIdLst>
         </p14:section>
-        <p14:section name="The solution" id="{13eaa297-9187-69aa-48ea-f00fce52adc8}">
+        <p14:section name="The solution" id="{8b749583-1ecb-c199-d17f-e5fbc34d0503}">
           <p14:sldIdLst>
             <p14:sldId id="260"/>
             <p14:sldId id="261"/>
           </p14:sldIdLst>
         </p14:section>
-        <p14:section name="Trust" id="{d73f7d3b-49f4-dcd2-981e-8d139a9e8eed}">
+        <p14:section name="Trust" id="{c5273d3f-ba8a-c82c-6641-5051c959b8d4}">
           <p14:sldIdLst>
             <p14:sldId id="262"/>
             <p14:sldId id="263"/>
@@ -145,7 +145,7 @@
             <p14:sldId id="266"/>
           </p14:sldIdLst>
         </p14:section>
-        <p14:section name="Close" id="{3d452f66-6a8b-a3a9-4b66-78370108684d}">
+        <p14:section name="Close" id="{f7595872-fd63-80e3-af81-5bde7636cb20}">
           <p14:sldIdLst>
             <p14:sldId id="267"/>
           </p14:sldIdLst>
@@ -851,7 +851,7 @@
           <a:p>
             <a:r>
               <a:rPr lang="en-US" dirty="0"/>
-              <a:t>Good morning. We are team [Team name], and this is StudyRoute, our entry for Topic C, the cross-border and student finance assistant. StudyRoute is a sandbox AI agent that helps a parent in Bangladesh pay a student's tuition abroad. Everything you will see is synthetic and no real money moves. Our design rule is on the slide, and the rest of the talk shows how we make each of those four sentences true and testable: the engine calculates, the AI explains, the human approves, and every step is logged.</a:t>
+              <a:t>Good morning. We are team TeamEkxin, and this is StudyRoute, our entry for Topic C, the cross-border and student finance assistant. StudyRoute is a sandbox AI agent that helps a parent in Bangladesh pay a student's tuition abroad. Everything you will see is synthetic and no real money moves. Our design rule is on the slide, and the rest of the talk shows how we make each of those four sentences true and testable: the engine calculates, the AI explains, the human approves, and every step is logged.</a:t>
             </a:r>
             <a:endParaRPr lang="en-US" dirty="0"/>
           </a:p>
@@ -2589,7 +2589,7 @@
                   <a:schemeClr val="accent5"/>
                 </a:solidFill>
               </a:rPr>
-              <a:t>[Team name]  ·  Sandbox: synthetic data, no real money moves</a:t>
+              <a:t>TeamEkxin  ·  Sandbox: synthetic data, no real money moves</a:t>
             </a:r>
             <a:endParaRPr lang="en-US" sz="1200" dirty="0"/>
           </a:p>
@@ -4416,7 +4416,7 @@
                   <a:schemeClr val="accent5"/>
                 </a:solidFill>
               </a:rPr>
-              <a:t>[Team name]  ·  [repository link]  ·  Sandbox: no real money moves</a:t>
+              <a:t>TeamEkxin  ·  https://github.com/NoobCrow/StudyRoute  ·  Sandbox: no real money moves</a:t>
             </a:r>
             <a:endParaRPr lang="en-US" sz="1200" dirty="0"/>
           </a:p>

</xml_diff>

<commit_message>
docs+evidence: Docker run of 18 Oct 2026 (found the explainer problem), browser audit retries on 429
- submission/evidence/docker_2026-10-18/: raw output of the VM run (smoke, the 14-step demo before the
  fix with 3 failed checks kept on purpose and after it with 66 OK lines, the AI risk and bank review
  demo, real-Chrome audit 48 of 48, hardened overlay with read-only root and all capabilities dropped).
- docker_run.txt, docs/DOCKER.md, OPEN_QUESTIONS: what failed, why, the fix (c9d044b), and what was not
  repeated (packet capture, tours, in-container test suites).
- scripts/security/browser_audit.mjs: waits and retries on HTTP 429 when it plants test data against the
  real, rate-limited stack.
- TEST_CASES regenerated: 1678 backend tests, 1677 passed, 1 skipped. Deck rebuilt, manifest refreshed.
</commit_message>
<xml_diff>
--- a/submission/StudyRoute_Deck.pptx
+++ b/submission/StudyRoute_Deck.pptx
@@ -118,25 +118,25 @@
   <p:extLst>
     <p:ext uri="{521415D9-36F7-43E2-AB2F-B90AF26B5E84}">
       <p14:sectionLst xmlns:p14="http://schemas.microsoft.com/office/powerpoint/2010/main">
-        <p14:section name="Opening" id="{2af9f749-b477-203a-5500-b2c40577a772}">
+        <p14:section name="Opening" id="{6732bee5-cee3-b8f2-867c-9c4ff1af20e6}">
           <p14:sldIdLst>
             <p14:sldId id="256"/>
             <p14:sldId id="257"/>
           </p14:sldIdLst>
         </p14:section>
-        <p14:section name="The problem" id="{2b70e03a-70f9-5d5e-9f6a-7b68c3517d6e}">
+        <p14:section name="The problem" id="{50d6813c-c481-546b-5000-d3180ef06ff2}">
           <p14:sldIdLst>
             <p14:sldId id="258"/>
             <p14:sldId id="259"/>
           </p14:sldIdLst>
         </p14:section>
-        <p14:section name="The solution" id="{c06ecc50-86bd-3509-ec2f-d2fee9173dad}">
+        <p14:section name="The solution" id="{bc8f4b99-037e-9ac6-a6bb-efdffd373c79}">
           <p14:sldIdLst>
             <p14:sldId id="260"/>
             <p14:sldId id="261"/>
           </p14:sldIdLst>
         </p14:section>
-        <p14:section name="Trust" id="{6db940e4-a080-365f-d07c-928dff0b0a76}">
+        <p14:section name="Trust" id="{cb3f4872-503d-a353-e00b-2bc69b51d354}">
           <p14:sldIdLst>
             <p14:sldId id="262"/>
             <p14:sldId id="263"/>
@@ -145,7 +145,7 @@
             <p14:sldId id="266"/>
           </p14:sldIdLst>
         </p14:section>
-        <p14:section name="Close" id="{b115ae44-b577-669f-607b-6126ef7a6b1e}">
+        <p14:section name="Close" id="{7819aaed-7ec4-a109-b9c2-0e2ca5fd08d7}">
           <p14:sldIdLst>
             <p14:sldId id="267"/>
           </p14:sldIdLst>
@@ -939,7 +939,7 @@
           <a:p>
             <a:r>
               <a:rPr lang="en-US" dirty="0"/>
-              <a:t>Security and compliance is thirty percent of the score, so we made it checkable. On the left are the permission tiers, enforced in the domain layer, not just in the screens. Public, read, prepare, decide, and administer. Deciding, meaning approving a payment, is only for a human parent with a fresh MFA proof bound to that payment and to the hash of the summary they saw. The AI has no approve, cancel, limit or config permission at all. On the right, the numbers: 1677 backend and 463 frontend tests, all 24 blueprint scenarios mapped to tests, and 55 known risks that we list openly in the self-assessment. The audit log is hash-chained: Verify passes, we edit one row behind the application's back, and Verify fails at exactly that event.</a:t>
+              <a:t>Security and compliance is thirty percent of the score, so we made it checkable. On the left are the permission tiers, enforced in the domain layer, not just in the screens. Public, read, prepare, decide, and administer. Deciding, meaning approving a payment, is only for a human parent with a fresh MFA proof bound to that payment and to the hash of the summary they saw. The AI has no approve, cancel, limit or config permission at all. On the right, the numbers: 1678 backend and 463 frontend tests, all 24 blueprint scenarios mapped to tests, and 55 known risks that we list openly in the self-assessment. The audit log is hash-chained: Verify passes, we edit one row behind the application's back, and Verify fails at exactly that event.</a:t>
             </a:r>
             <a:endParaRPr lang="en-US" dirty="0"/>
           </a:p>
@@ -1643,7 +1643,7 @@
           <a:p>
             <a:r>
               <a:rPr lang="en-US" dirty="0"/>
-              <a:t>Before the details, here is what we have shown and what we have not. What we have shown: every number comes from one deterministic engine, with 1677 backend tests covering all 24 scenarios. Only a human with a fresh MFA code can approve, and the AI has no such permission. Change one audit row and Verify fails at that event. And the stack starts from the zipped archive with one command. What we have not shown: the rates, fees and city costs are invented, and we have not yet compared them with real quotes. No real parent has used it. A local review found trust-boundary limits; no external penetration test was run. The Bangladesh Bank limits are placeholders, marked Not verified. Both lists are in the repository, because we would rather you hear the limits from us.</a:t>
+              <a:t>Before the details, here is what we have shown and what we have not. What we have shown: every number comes from one deterministic engine, with 1678 backend tests covering all 24 scenarios. Only a human with a fresh MFA code can approve, and the AI has no such permission. Change one audit row and Verify fails at that event. And the stack starts from the zipped archive with one command. What we have not shown: the rates, fees and city costs are invented, and we have not yet compared them with real quotes. No real parent has used it. A local review found trust-boundary limits; no external penetration test was run. The Bangladesh Bank limits are placeholders, marked Not verified. Both lists are in the repository, because we would rather you hear the limits from us.</a:t>
             </a:r>
             <a:endParaRPr lang="en-US" dirty="0"/>
           </a:p>
@@ -3246,7 +3246,7 @@
                 <a:ea typeface="+mj-lt" pitchFamily="34" charset="-122"/>
                 <a:cs typeface="+mj-lt" pitchFamily="34" charset="-120"/>
               </a:rPr>
-              <a:t>1677</a:t>
+              <a:t>1678</a:t>
             </a:r>
             <a:endParaRPr lang="en-US" sz="3200" dirty="0"/>
           </a:p>
@@ -9229,7 +9229,7 @@
                   <a:schemeClr val="tx1"/>
                 </a:solidFill>
               </a:rPr>
-              <a:t>Every number comes from one engine, in integer money. 1677 backend tests cover all 24 scenarios.</a:t>
+              <a:t>Every number comes from one engine, in integer money. 1678 backend tests cover all 24 scenarios.</a:t>
             </a:r>
             <a:endParaRPr lang="en-US" sz="1200" dirty="0"/>
           </a:p>

</xml_diff>

<commit_message>
fix: put the team name and repository link back into the deck
The deck rebuilds in 8d91cc8 and a0f6365 used the builder's default placeholders, so the submitted
deck showed "[Team name]" and "[repository link]" (the version in 58750e5 was correct). Rebuilt with
TEAM_NAME=TeamEkxin and REPO_LINK=https://github.com/NoobCrow/StudyRoute; the manifest is refreshed.
</commit_message>
<xml_diff>
--- a/submission/StudyRoute_Deck.pptx
+++ b/submission/StudyRoute_Deck.pptx
@@ -118,25 +118,25 @@
   <p:extLst>
     <p:ext uri="{521415D9-36F7-43E2-AB2F-B90AF26B5E84}">
       <p14:sectionLst xmlns:p14="http://schemas.microsoft.com/office/powerpoint/2010/main">
-        <p14:section name="Opening" id="{6732bee5-cee3-b8f2-867c-9c4ff1af20e6}">
+        <p14:section name="Opening" id="{804e59c2-1446-1d45-66a2-7dc4ef9e2925}">
           <p14:sldIdLst>
             <p14:sldId id="256"/>
             <p14:sldId id="257"/>
           </p14:sldIdLst>
         </p14:section>
-        <p14:section name="The problem" id="{50d6813c-c481-546b-5000-d3180ef06ff2}">
+        <p14:section name="The problem" id="{b38da6c5-0e69-1de4-24b9-1f1b09672032}">
           <p14:sldIdLst>
             <p14:sldId id="258"/>
             <p14:sldId id="259"/>
           </p14:sldIdLst>
         </p14:section>
-        <p14:section name="The solution" id="{bc8f4b99-037e-9ac6-a6bb-efdffd373c79}">
+        <p14:section name="The solution" id="{2b16bc72-9a6d-a822-079e-35cb5d524a8b}">
           <p14:sldIdLst>
             <p14:sldId id="260"/>
             <p14:sldId id="261"/>
           </p14:sldIdLst>
         </p14:section>
-        <p14:section name="Trust" id="{cb3f4872-503d-a353-e00b-2bc69b51d354}">
+        <p14:section name="Trust" id="{70dc36d3-6473-6065-a844-8603613edd4d}">
           <p14:sldIdLst>
             <p14:sldId id="262"/>
             <p14:sldId id="263"/>
@@ -145,7 +145,7 @@
             <p14:sldId id="266"/>
           </p14:sldIdLst>
         </p14:section>
-        <p14:section name="Close" id="{7819aaed-7ec4-a109-b9c2-0e2ca5fd08d7}">
+        <p14:section name="Close" id="{7bd81ea4-c7ba-ff59-a383-f2f72e5e706c}">
           <p14:sldIdLst>
             <p14:sldId id="267"/>
           </p14:sldIdLst>
@@ -851,7 +851,7 @@
           <a:p>
             <a:r>
               <a:rPr lang="en-US" dirty="0"/>
-              <a:t>Good morning. We are team [Team name], and this is StudyRoute, our entry for Topic C, the cross-border and student finance assistant. StudyRoute is a sandbox AI agent that helps a parent in Bangladesh pay a student's tuition abroad. Everything you will see is synthetic and no real money moves. Our design rule is on the slide, and the rest of the talk shows how we make each of those four sentences true and testable: the engine calculates, the AI explains, the human approves, and every step is logged.</a:t>
+              <a:t>Good morning. We are team TeamEkxin, and this is StudyRoute, our entry for Topic C, the cross-border and student finance assistant. StudyRoute is a sandbox AI agent that helps a parent in Bangladesh pay a student's tuition abroad. Everything you will see is synthetic and no real money moves. Our design rule is on the slide, and the rest of the talk shows how we make each of those four sentences true and testable: the engine calculates, the AI explains, the human approves, and every step is logged.</a:t>
             </a:r>
             <a:endParaRPr lang="en-US" dirty="0"/>
           </a:p>
@@ -2589,7 +2589,7 @@
                   <a:schemeClr val="accent5"/>
                 </a:solidFill>
               </a:rPr>
-              <a:t>[Team name]  ·  Sandbox: synthetic data, no real money moves</a:t>
+              <a:t>TeamEkxin  ·  Sandbox: synthetic data, no real money moves</a:t>
             </a:r>
             <a:endParaRPr lang="en-US" sz="1200" dirty="0"/>
           </a:p>
@@ -4416,7 +4416,7 @@
                   <a:schemeClr val="accent5"/>
                 </a:solidFill>
               </a:rPr>
-              <a:t>[Team name]  ·  [repository link]  ·  Sandbox: no real money moves</a:t>
+              <a:t>TeamEkxin  ·  https://github.com/NoobCrow/StudyRoute  ·  Sandbox: no real money moves</a:t>
             </a:r>
             <a:endParaRPr lang="en-US" sz="1200" dirty="0"/>
           </a:p>

</xml_diff>

<commit_message>
docs: deck says the escrow runs on a simulated chain today (the next-steps card read as if a real chain already ran)
</commit_message>
<xml_diff>
--- a/submission/StudyRoute_Deck.pptx
+++ b/submission/StudyRoute_Deck.pptx
@@ -118,25 +118,25 @@
   <p:extLst>
     <p:ext uri="{521415D9-36F7-43E2-AB2F-B90AF26B5E84}">
       <p14:sectionLst xmlns:p14="http://schemas.microsoft.com/office/powerpoint/2010/main">
-        <p14:section name="Opening" id="{804e59c2-1446-1d45-66a2-7dc4ef9e2925}">
+        <p14:section name="Opening" id="{414fa2ab-2833-0a7a-8192-33738cc28b56}">
           <p14:sldIdLst>
             <p14:sldId id="256"/>
             <p14:sldId id="257"/>
           </p14:sldIdLst>
         </p14:section>
-        <p14:section name="The problem" id="{b38da6c5-0e69-1de4-24b9-1f1b09672032}">
+        <p14:section name="The problem" id="{6d50f98d-5687-44bc-51f6-5ee275047521}">
           <p14:sldIdLst>
             <p14:sldId id="258"/>
             <p14:sldId id="259"/>
           </p14:sldIdLst>
         </p14:section>
-        <p14:section name="The solution" id="{2b16bc72-9a6d-a822-079e-35cb5d524a8b}">
+        <p14:section name="The solution" id="{18b02456-c9d0-0521-c084-ab01a5b431e9}">
           <p14:sldIdLst>
             <p14:sldId id="260"/>
             <p14:sldId id="261"/>
           </p14:sldIdLst>
         </p14:section>
-        <p14:section name="Trust" id="{70dc36d3-6473-6065-a844-8603613edd4d}">
+        <p14:section name="Trust" id="{40373f78-e0ca-b5d5-3097-f09fc82c66cc}">
           <p14:sldIdLst>
             <p14:sldId id="262"/>
             <p14:sldId id="263"/>
@@ -145,7 +145,7 @@
             <p14:sldId id="266"/>
           </p14:sldIdLst>
         </p14:section>
-        <p14:section name="Close" id="{7bd81ea4-c7ba-ff59-a383-f2f72e5e706c}">
+        <p14:section name="Close" id="{b11ffb14-2419-bc2f-6b11-3b92356f51d2}">
           <p14:sldIdLst>
             <p14:sldId id="267"/>
           </p14:sldIdLst>
@@ -4341,7 +4341,7 @@
                   <a:schemeClr val="bg2"/>
                 </a:solidFill>
               </a:rPr>
-              <a:t>Escrow already runs in the sandbox. Next: a permissioned chain and a bank-issued token.</a:t>
+              <a:t>Today the escrow runs on a simulated chain inside the app, with no network. Next: a permissioned chain and a bank-issued token.</a:t>
             </a:r>
             <a:endParaRPr lang="en-US" sz="1400" dirty="0"/>
           </a:p>

</xml_diff>

<commit_message>
docs: remove the "What the brief asked" slide; the deck is 20 slides
- Slide removed from submission/deck/build_deck.js; "What comes next" is slide 20 again.
- Speaker notes 1,241 words (about 8.3 minutes at 150 wpm), regenerated.
- The slide-count guard in scripts/preflight.py and two document tests go from 21 to 20.
- Outline, checklist and rules table updated; release manifest regenerated.
</commit_message>
<xml_diff>
--- a/submission/StudyRoute_Deck.pptx
+++ b/submission/StudyRoute_Deck.pptx
@@ -25,10 +25,9 @@
     <p:sldId id="273" r:id="rId19"/>
     <p:sldId id="274" r:id="rId20"/>
     <p:sldId id="275" r:id="rId21"/>
-    <p:sldId id="276" r:id="rId22"/>
   </p:sldIdLst>
   <p:notesMasterIdLst>
-    <p:notesMasterId r:id="rId23"/>
+    <p:notesMasterId r:id="rId22"/>
   </p:notesMasterIdLst>
   <p:sldSz cx="9144000" cy="5143500"/>
   <p:notesSz cx="5143500" cy="9144000"/>
@@ -127,19 +126,19 @@
   <p:extLst>
     <p:ext uri="{521415D9-36F7-43E2-AB2F-B90AF26B5E84}">
       <p14:sectionLst xmlns:p14="http://schemas.microsoft.com/office/powerpoint/2010/main">
-        <p14:section name="Opening" id="{2c00df88-3e40-5746-fe8d-61f65578fd80}">
+        <p14:section name="Opening" id="{41d31ac0-0ea8-74ef-1832-d43a76621859}">
           <p14:sldIdLst>
             <p14:sldId id="256"/>
             <p14:sldId id="257"/>
           </p14:sldIdLst>
         </p14:section>
-        <p14:section name="The problem" id="{b357920c-b3c8-9236-4b8e-942ccf9fc092}">
+        <p14:section name="The problem" id="{0b5d19aa-4d38-e4fc-6440-f0434cbf518d}">
           <p14:sldIdLst>
             <p14:sldId id="258"/>
             <p14:sldId id="259"/>
           </p14:sldIdLst>
         </p14:section>
-        <p14:section name="The solution" id="{bc048424-a606-87ee-ca61-a6530e80ec7e}">
+        <p14:section name="The solution" id="{b19af7d6-6fd0-d0dc-7238-b5a5e06b72be}">
           <p14:sldIdLst>
             <p14:sldId id="260"/>
             <p14:sldId id="261"/>
@@ -147,7 +146,7 @@
             <p14:sldId id="263"/>
           </p14:sldIdLst>
         </p14:section>
-        <p14:section name="Trust" id="{a897a298-e607-8699-ff4e-7b2dcfae49a2}">
+        <p14:section name="Trust" id="{2b1ecca8-c892-cb9c-e2f7-196628c1fa99}">
           <p14:sldIdLst>
             <p14:sldId id="264"/>
             <p14:sldId id="265"/>
@@ -161,11 +160,10 @@
             <p14:sldId id="273"/>
           </p14:sldIdLst>
         </p14:section>
-        <p14:section name="Close" id="{7cffc45c-303b-d2af-3b70-3101f6c4ad0d}">
+        <p14:section name="Close" id="{07bc6671-a836-ecc0-4ea6-fbb768ef0779}">
           <p14:sldIdLst>
             <p14:sldId id="274"/>
             <p14:sldId id="275"/>
-            <p14:sldId id="276"/>
           </p14:sldIdLst>
         </p14:section>
       </p14:sectionLst>
@@ -1925,7 +1923,7 @@
           <a:p>
             <a:r>
               <a:rPr lang="en-US" dirty="0"/>
-              <a:t>Back to the brief. The technical documentation, this ten-minute deck, the source on a public repository with CI green, the security self-assessment and the execution evidence are all in. The narrated demo video is optional and still pending. Everything is a sandbox with synthetic data. And for the three scoring criteria, here are the slides that show each.</a:t>
+              <a:t>Next: replace placeholder rules with official Bangladesh Bank sources, partner with an authorised dealer bank for real quotes and KYC, and move the escrow from our simulated chain to a permissioned one. Credit building is in the brief and not built, and we would rather say so. To close: the engine calculates, the AI explains, the human approves, and every step is logged. Thank you.</a:t>
             </a:r>
             <a:endParaRPr lang="en-US" dirty="0"/>
           </a:p>
@@ -1949,94 +1947,6 @@
             <a:fld id="{F7021451-1387-4CA6-816F-3879F97B5CBC}" type="slidenum">
               <a:rPr lang="en-US"/>
               <a:t>20</a:t>
-            </a:fld>
-            <a:endParaRPr lang="en-US"/>
-          </a:p>
-        </p:txBody>
-      </p:sp>
-    </p:spTree>
-    <p:extLst>
-      <p:ext uri="{BB962C8B-B14F-4D97-AF65-F5344CB8AC3E}">
-        <p14:creationId xmlns:p14="http://schemas.microsoft.com/office/powerpoint/2010/main" val="1024086991"/>
-      </p:ext>
-    </p:extLst>
-  </p:cSld>
-  <p:clrMapOvr>
-    <a:masterClrMapping/>
-  </p:clrMapOvr>
-</p:notes>
-</file>
-
-<file path=ppt/notesSlides/notesSlide21.xml><?xml version="1.0" encoding="utf-8"?>
-<p:notes xmlns:a="http://schemas.openxmlformats.org/drawingml/2006/main" xmlns:r="http://schemas.openxmlformats.org/officeDocument/2006/relationships" xmlns:p="http://schemas.openxmlformats.org/presentationml/2006/main">
-  <p:cSld>
-    <p:spTree>
-      <p:nvGrpSpPr>
-        <p:cNvPr id="1" name=""/>
-        <p:cNvGrpSpPr/>
-        <p:nvPr/>
-      </p:nvGrpSpPr>
-      <p:grpSpPr>
-        <a:xfrm>
-          <a:off x="0" y="0"/>
-          <a:ext cx="0" cy="0"/>
-          <a:chOff x="0" y="0"/>
-          <a:chExt cx="0" cy="0"/>
-        </a:xfrm>
-      </p:grpSpPr>
-      <p:sp>
-        <p:nvSpPr>
-          <p:cNvPr id="2" name="Slide Image Placeholder 1"/>
-          <p:cNvSpPr>
-            <a:spLocks noGrp="1" noRot="1" noChangeAspect="1"/>
-          </p:cNvSpPr>
-          <p:nvPr>
-            <p:ph type="sldImg"/>
-          </p:nvPr>
-        </p:nvSpPr>
-        <p:spPr/>
-      </p:sp>
-      <p:sp>
-        <p:nvSpPr>
-          <p:cNvPr id="3" name="Notes Placeholder 2"/>
-          <p:cNvSpPr>
-            <a:spLocks noGrp="1"/>
-          </p:cNvSpPr>
-          <p:nvPr>
-            <p:ph type="body" idx="1"/>
-          </p:nvPr>
-        </p:nvSpPr>
-        <p:spPr/>
-        <p:txBody>
-          <a:bodyPr/>
-          <a:lstStyle/>
-          <a:p>
-            <a:r>
-              <a:rPr lang="en-US" dirty="0"/>
-              <a:t>Next: replace placeholder rules with official Bangladesh Bank sources, partner with an authorised dealer bank for real quotes and KYC, and move the escrow from our simulated chain to a permissioned one. Credit building is in the brief and not built, and we would rather say so. To close: the engine calculates, the AI explains, the human approves, and every step is logged. Thank you.</a:t>
-            </a:r>
-            <a:endParaRPr lang="en-US" dirty="0"/>
-          </a:p>
-        </p:txBody>
-      </p:sp>
-      <p:sp>
-        <p:nvSpPr>
-          <p:cNvPr id="4" name="Slide Number Placeholder 3"/>
-          <p:cNvSpPr>
-            <a:spLocks noGrp="1"/>
-          </p:cNvSpPr>
-          <p:nvPr>
-            <p:ph type="sldNum" sz="quarter" idx="10"/>
-          </p:nvPr>
-        </p:nvSpPr>
-        <p:spPr/>
-        <p:txBody>
-          <a:bodyPr/>
-          <a:lstStyle/>
-          <a:p>
-            <a:fld id="{F7021451-1387-4CA6-816F-3879F97B5CBC}" type="slidenum">
-              <a:rPr lang="en-US"/>
-              <a:t>21</a:t>
             </a:fld>
             <a:endParaRPr lang="en-US"/>
           </a:p>
@@ -13369,2006 +13279,21 @@
             <a:r>
               <a:rPr lang="en-US" sz="3600" b="1" dirty="0">
                 <a:solidFill>
-                  <a:schemeClr val="tx1"/>
+                  <a:schemeClr val="bg1"/>
                 </a:solidFill>
                 <a:latin typeface="+mj-lt" pitchFamily="34" charset="0"/>
                 <a:ea typeface="+mj-lt" pitchFamily="34" charset="-122"/>
                 <a:cs typeface="+mj-lt" pitchFamily="34" charset="-120"/>
               </a:rPr>
-              <a:t>What the brief asked</a:t>
+              <a:t>What comes next</a:t>
             </a:r>
             <a:endParaRPr lang="en-US" sz="3600" dirty="0"/>
           </a:p>
         </p:txBody>
       </p:sp>
-      <p:graphicFrame>
-        <p:nvGraphicFramePr>
-          <p:cNvPr id="21" name="content-20-table-1"/>
-          <p:cNvGraphicFramePr>
-            <a:graphicFrameLocks noGrp="1"/>
-          </p:cNvGraphicFramePr>
-          <p:nvPr>
-            <p:extLst>
-              <p:ext uri="{D42A27DB-BD31-4B8C-83A1-F6EECF244321}">
-                <p14:modId xmlns:p14="http://schemas.microsoft.com/office/powerpoint/2010/main" val="1579011935"/>
-              </p:ext>
-            </p:extLst>
-          </p:nvPr>
-        </p:nvGraphicFramePr>
-        <p:xfrm>
-          <a:off x="457200" y="1188720"/>
-          <a:ext cx="5760720" cy="914400"/>
-        </p:xfrm>
-        <a:graphic>
-          <a:graphicData uri="http://schemas.openxmlformats.org/drawingml/2006/table">
-            <a:tbl>
-              <a:tblPr/>
-              <a:tblGrid>
-                <a:gridCol w="2011680"/>
-                <a:gridCol w="3063240"/>
-                <a:gridCol w="685800"/>
-              </a:tblGrid>
-              <a:tr h="393192">
-                <a:tc>
-                  <a:txBody>
-                    <a:bodyPr/>
-                    <a:lstStyle/>
-                    <a:p>
-                      <a:pPr algn="l" indent="0" marL="0">
-                        <a:buNone/>
-                      </a:pPr>
-                      <a:r>
-                        <a:rPr lang="en-US" sz="1050" b="1" dirty="0">
-                          <a:solidFill>
-                            <a:schemeClr val="bg1"/>
-                          </a:solidFill>
-                        </a:rPr>
-                        <a:t>What the brief asked</a:t>
-                      </a:r>
-                      <a:endParaRPr lang="en-US" sz="1050" dirty="0"/>
-                    </a:p>
-                  </a:txBody>
-                  <a:tcPr marL="91440" marR="91440" marT="45720" marB="45720" anchor="ctr">
-                    <a:lnL w="9525" cap="flat" cmpd="sng" algn="ctr">
-                      <a:solidFill>
-                        <a:srgbClr val="C9D6E3"/>
-                      </a:solidFill>
-                      <a:prstDash val="solid"/>
-                      <a:round/>
-                      <a:headEnd type="none" w="med" len="med"/>
-                      <a:tailEnd type="none" w="med" len="med"/>
-                    </a:lnL>
-                    <a:lnR w="9525" cap="flat" cmpd="sng" algn="ctr">
-                      <a:solidFill>
-                        <a:srgbClr val="C9D6E3"/>
-                      </a:solidFill>
-                      <a:prstDash val="solid"/>
-                      <a:round/>
-                      <a:headEnd type="none" w="med" len="med"/>
-                      <a:tailEnd type="none" w="med" len="med"/>
-                    </a:lnR>
-                    <a:lnT w="9525" cap="flat" cmpd="sng" algn="ctr">
-                      <a:solidFill>
-                        <a:srgbClr val="C9D6E3"/>
-                      </a:solidFill>
-                      <a:prstDash val="solid"/>
-                      <a:round/>
-                      <a:headEnd type="none" w="med" len="med"/>
-                      <a:tailEnd type="none" w="med" len="med"/>
-                    </a:lnT>
-                    <a:lnB w="9525" cap="flat" cmpd="sng" algn="ctr">
-                      <a:solidFill>
-                        <a:srgbClr val="C9D6E3"/>
-                      </a:solidFill>
-                      <a:prstDash val="solid"/>
-                      <a:round/>
-                      <a:headEnd type="none" w="med" len="med"/>
-                      <a:tailEnd type="none" w="med" len="med"/>
-                    </a:lnB>
-                    <a:solidFill>
-                      <a:schemeClr val="tx1"/>
-                    </a:solidFill>
-                  </a:tcPr>
-                </a:tc>
-                <a:tc>
-                  <a:txBody>
-                    <a:bodyPr/>
-                    <a:lstStyle/>
-                    <a:p>
-                      <a:pPr algn="l" indent="0" marL="0">
-                        <a:buNone/>
-                      </a:pPr>
-                      <a:r>
-                        <a:rPr lang="en-US" sz="1050" b="1" dirty="0">
-                          <a:solidFill>
-                            <a:schemeClr val="bg1"/>
-                          </a:solidFill>
-                        </a:rPr>
-                        <a:t>Where it is</a:t>
-                      </a:r>
-                      <a:endParaRPr lang="en-US" sz="1050" dirty="0"/>
-                    </a:p>
-                  </a:txBody>
-                  <a:tcPr marL="91440" marR="91440" marT="45720" marB="45720" anchor="ctr">
-                    <a:lnL w="9525" cap="flat" cmpd="sng" algn="ctr">
-                      <a:solidFill>
-                        <a:srgbClr val="C9D6E3"/>
-                      </a:solidFill>
-                      <a:prstDash val="solid"/>
-                      <a:round/>
-                      <a:headEnd type="none" w="med" len="med"/>
-                      <a:tailEnd type="none" w="med" len="med"/>
-                    </a:lnL>
-                    <a:lnR w="9525" cap="flat" cmpd="sng" algn="ctr">
-                      <a:solidFill>
-                        <a:srgbClr val="C9D6E3"/>
-                      </a:solidFill>
-                      <a:prstDash val="solid"/>
-                      <a:round/>
-                      <a:headEnd type="none" w="med" len="med"/>
-                      <a:tailEnd type="none" w="med" len="med"/>
-                    </a:lnR>
-                    <a:lnT w="9525" cap="flat" cmpd="sng" algn="ctr">
-                      <a:solidFill>
-                        <a:srgbClr val="C9D6E3"/>
-                      </a:solidFill>
-                      <a:prstDash val="solid"/>
-                      <a:round/>
-                      <a:headEnd type="none" w="med" len="med"/>
-                      <a:tailEnd type="none" w="med" len="med"/>
-                    </a:lnT>
-                    <a:lnB w="9525" cap="flat" cmpd="sng" algn="ctr">
-                      <a:solidFill>
-                        <a:srgbClr val="C9D6E3"/>
-                      </a:solidFill>
-                      <a:prstDash val="solid"/>
-                      <a:round/>
-                      <a:headEnd type="none" w="med" len="med"/>
-                      <a:tailEnd type="none" w="med" len="med"/>
-                    </a:lnB>
-                    <a:solidFill>
-                      <a:schemeClr val="tx1"/>
-                    </a:solidFill>
-                  </a:tcPr>
-                </a:tc>
-                <a:tc>
-                  <a:txBody>
-                    <a:bodyPr/>
-                    <a:lstStyle/>
-                    <a:p>
-                      <a:pPr algn="l" indent="0" marL="0">
-                        <a:buNone/>
-                      </a:pPr>
-                      <a:r>
-                        <a:rPr lang="en-US" sz="1050" b="1" dirty="0">
-                          <a:solidFill>
-                            <a:schemeClr val="bg1"/>
-                          </a:solidFill>
-                        </a:rPr>
-                        <a:t>Status</a:t>
-                      </a:r>
-                      <a:endParaRPr lang="en-US" sz="1050" dirty="0"/>
-                    </a:p>
-                  </a:txBody>
-                  <a:tcPr marL="91440" marR="91440" marT="45720" marB="45720" anchor="ctr">
-                    <a:lnL w="9525" cap="flat" cmpd="sng" algn="ctr">
-                      <a:solidFill>
-                        <a:srgbClr val="C9D6E3"/>
-                      </a:solidFill>
-                      <a:prstDash val="solid"/>
-                      <a:round/>
-                      <a:headEnd type="none" w="med" len="med"/>
-                      <a:tailEnd type="none" w="med" len="med"/>
-                    </a:lnL>
-                    <a:lnR w="9525" cap="flat" cmpd="sng" algn="ctr">
-                      <a:solidFill>
-                        <a:srgbClr val="C9D6E3"/>
-                      </a:solidFill>
-                      <a:prstDash val="solid"/>
-                      <a:round/>
-                      <a:headEnd type="none" w="med" len="med"/>
-                      <a:tailEnd type="none" w="med" len="med"/>
-                    </a:lnR>
-                    <a:lnT w="9525" cap="flat" cmpd="sng" algn="ctr">
-                      <a:solidFill>
-                        <a:srgbClr val="C9D6E3"/>
-                      </a:solidFill>
-                      <a:prstDash val="solid"/>
-                      <a:round/>
-                      <a:headEnd type="none" w="med" len="med"/>
-                      <a:tailEnd type="none" w="med" len="med"/>
-                    </a:lnT>
-                    <a:lnB w="9525" cap="flat" cmpd="sng" algn="ctr">
-                      <a:solidFill>
-                        <a:srgbClr val="C9D6E3"/>
-                      </a:solidFill>
-                      <a:prstDash val="solid"/>
-                      <a:round/>
-                      <a:headEnd type="none" w="med" len="med"/>
-                      <a:tailEnd type="none" w="med" len="med"/>
-                    </a:lnB>
-                    <a:solidFill>
-                      <a:schemeClr val="tx1"/>
-                    </a:solidFill>
-                  </a:tcPr>
-                </a:tc>
-              </a:tr>
-              <a:tr h="393192">
-                <a:tc>
-                  <a:txBody>
-                    <a:bodyPr/>
-                    <a:lstStyle/>
-                    <a:p>
-                      <a:pPr algn="l" indent="0" marL="0">
-                        <a:buNone/>
-                      </a:pPr>
-                      <a:r>
-                        <a:rPr lang="en-US" sz="1050" b="1" dirty="0">
-                          <a:solidFill>
-                            <a:schemeClr val="tx1"/>
-                          </a:solidFill>
-                        </a:rPr>
-                        <a:t>Technical documentation</a:t>
-                      </a:r>
-                      <a:endParaRPr lang="en-US" sz="1050" dirty="0"/>
-                    </a:p>
-                  </a:txBody>
-                  <a:tcPr marL="91440" marR="91440" marT="45720" marB="45720" anchor="ctr">
-                    <a:lnL w="9525" cap="flat" cmpd="sng" algn="ctr">
-                      <a:solidFill>
-                        <a:srgbClr val="C9D6E3"/>
-                      </a:solidFill>
-                      <a:prstDash val="solid"/>
-                      <a:round/>
-                      <a:headEnd type="none" w="med" len="med"/>
-                      <a:tailEnd type="none" w="med" len="med"/>
-                    </a:lnL>
-                    <a:lnR w="9525" cap="flat" cmpd="sng" algn="ctr">
-                      <a:solidFill>
-                        <a:srgbClr val="C9D6E3"/>
-                      </a:solidFill>
-                      <a:prstDash val="solid"/>
-                      <a:round/>
-                      <a:headEnd type="none" w="med" len="med"/>
-                      <a:tailEnd type="none" w="med" len="med"/>
-                    </a:lnR>
-                    <a:lnT w="9525" cap="flat" cmpd="sng" algn="ctr">
-                      <a:solidFill>
-                        <a:srgbClr val="C9D6E3"/>
-                      </a:solidFill>
-                      <a:prstDash val="solid"/>
-                      <a:round/>
-                      <a:headEnd type="none" w="med" len="med"/>
-                      <a:tailEnd type="none" w="med" len="med"/>
-                    </a:lnT>
-                    <a:lnB w="9525" cap="flat" cmpd="sng" algn="ctr">
-                      <a:solidFill>
-                        <a:srgbClr val="C9D6E3"/>
-                      </a:solidFill>
-                      <a:prstDash val="solid"/>
-                      <a:round/>
-                      <a:headEnd type="none" w="med" len="med"/>
-                      <a:tailEnd type="none" w="med" len="med"/>
-                    </a:lnB>
-                    <a:solidFill>
-                      <a:schemeClr val="bg2"/>
-                    </a:solidFill>
-                  </a:tcPr>
-                </a:tc>
-                <a:tc>
-                  <a:txBody>
-                    <a:bodyPr/>
-                    <a:lstStyle/>
-                    <a:p>
-                      <a:pPr algn="l" indent="0" marL="0">
-                        <a:buNone/>
-                      </a:pPr>
-                      <a:r>
-                        <a:rPr lang="en-US" sz="1050" dirty="0">
-                          <a:solidFill>
-                            <a:schemeClr val="tx1"/>
-                          </a:solidFill>
-                        </a:rPr>
-                        <a:t>20-page PDF: architecture, algorithms, security design</a:t>
-                      </a:r>
-                      <a:endParaRPr lang="en-US" sz="1050" dirty="0"/>
-                    </a:p>
-                  </a:txBody>
-                  <a:tcPr marL="91440" marR="91440" marT="45720" marB="45720" anchor="ctr">
-                    <a:lnL w="9525" cap="flat" cmpd="sng" algn="ctr">
-                      <a:solidFill>
-                        <a:srgbClr val="C9D6E3"/>
-                      </a:solidFill>
-                      <a:prstDash val="solid"/>
-                      <a:round/>
-                      <a:headEnd type="none" w="med" len="med"/>
-                      <a:tailEnd type="none" w="med" len="med"/>
-                    </a:lnL>
-                    <a:lnR w="9525" cap="flat" cmpd="sng" algn="ctr">
-                      <a:solidFill>
-                        <a:srgbClr val="C9D6E3"/>
-                      </a:solidFill>
-                      <a:prstDash val="solid"/>
-                      <a:round/>
-                      <a:headEnd type="none" w="med" len="med"/>
-                      <a:tailEnd type="none" w="med" len="med"/>
-                    </a:lnR>
-                    <a:lnT w="9525" cap="flat" cmpd="sng" algn="ctr">
-                      <a:solidFill>
-                        <a:srgbClr val="C9D6E3"/>
-                      </a:solidFill>
-                      <a:prstDash val="solid"/>
-                      <a:round/>
-                      <a:headEnd type="none" w="med" len="med"/>
-                      <a:tailEnd type="none" w="med" len="med"/>
-                    </a:lnT>
-                    <a:lnB w="9525" cap="flat" cmpd="sng" algn="ctr">
-                      <a:solidFill>
-                        <a:srgbClr val="C9D6E3"/>
-                      </a:solidFill>
-                      <a:prstDash val="solid"/>
-                      <a:round/>
-                      <a:headEnd type="none" w="med" len="med"/>
-                      <a:tailEnd type="none" w="med" len="med"/>
-                    </a:lnB>
-                    <a:solidFill>
-                      <a:schemeClr val="bg2"/>
-                    </a:solidFill>
-                  </a:tcPr>
-                </a:tc>
-                <a:tc>
-                  <a:txBody>
-                    <a:bodyPr/>
-                    <a:lstStyle/>
-                    <a:p>
-                      <a:pPr algn="l" indent="0" marL="0">
-                        <a:buNone/>
-                      </a:pPr>
-                      <a:r>
-                        <a:rPr lang="en-US" sz="1050" b="1" dirty="0">
-                          <a:solidFill>
-                            <a:schemeClr val="accent6"/>
-                          </a:solidFill>
-                        </a:rPr>
-                        <a:t>Done</a:t>
-                      </a:r>
-                      <a:endParaRPr lang="en-US" sz="1050" dirty="0"/>
-                    </a:p>
-                  </a:txBody>
-                  <a:tcPr marL="91440" marR="91440" marT="45720" marB="45720" anchor="ctr">
-                    <a:lnL w="9525" cap="flat" cmpd="sng" algn="ctr">
-                      <a:solidFill>
-                        <a:srgbClr val="C9D6E3"/>
-                      </a:solidFill>
-                      <a:prstDash val="solid"/>
-                      <a:round/>
-                      <a:headEnd type="none" w="med" len="med"/>
-                      <a:tailEnd type="none" w="med" len="med"/>
-                    </a:lnL>
-                    <a:lnR w="9525" cap="flat" cmpd="sng" algn="ctr">
-                      <a:solidFill>
-                        <a:srgbClr val="C9D6E3"/>
-                      </a:solidFill>
-                      <a:prstDash val="solid"/>
-                      <a:round/>
-                      <a:headEnd type="none" w="med" len="med"/>
-                      <a:tailEnd type="none" w="med" len="med"/>
-                    </a:lnR>
-                    <a:lnT w="9525" cap="flat" cmpd="sng" algn="ctr">
-                      <a:solidFill>
-                        <a:srgbClr val="C9D6E3"/>
-                      </a:solidFill>
-                      <a:prstDash val="solid"/>
-                      <a:round/>
-                      <a:headEnd type="none" w="med" len="med"/>
-                      <a:tailEnd type="none" w="med" len="med"/>
-                    </a:lnT>
-                    <a:lnB w="9525" cap="flat" cmpd="sng" algn="ctr">
-                      <a:solidFill>
-                        <a:srgbClr val="C9D6E3"/>
-                      </a:solidFill>
-                      <a:prstDash val="solid"/>
-                      <a:round/>
-                      <a:headEnd type="none" w="med" len="med"/>
-                      <a:tailEnd type="none" w="med" len="med"/>
-                    </a:lnB>
-                    <a:solidFill>
-                      <a:schemeClr val="bg2"/>
-                    </a:solidFill>
-                  </a:tcPr>
-                </a:tc>
-              </a:tr>
-              <a:tr h="393192">
-                <a:tc>
-                  <a:txBody>
-                    <a:bodyPr/>
-                    <a:lstStyle/>
-                    <a:p>
-                      <a:pPr algn="l" indent="0" marL="0">
-                        <a:buNone/>
-                      </a:pPr>
-                      <a:r>
-                        <a:rPr lang="en-US" sz="1050" b="1" dirty="0">
-                          <a:solidFill>
-                            <a:schemeClr val="tx1"/>
-                          </a:solidFill>
-                        </a:rPr>
-                        <a:t>Deck of 10 minutes</a:t>
-                      </a:r>
-                      <a:endParaRPr lang="en-US" sz="1050" dirty="0"/>
-                    </a:p>
-                  </a:txBody>
-                  <a:tcPr marL="91440" marR="91440" marT="45720" marB="45720" anchor="ctr">
-                    <a:lnL w="9525" cap="flat" cmpd="sng" algn="ctr">
-                      <a:solidFill>
-                        <a:srgbClr val="C9D6E3"/>
-                      </a:solidFill>
-                      <a:prstDash val="solid"/>
-                      <a:round/>
-                      <a:headEnd type="none" w="med" len="med"/>
-                      <a:tailEnd type="none" w="med" len="med"/>
-                    </a:lnL>
-                    <a:lnR w="9525" cap="flat" cmpd="sng" algn="ctr">
-                      <a:solidFill>
-                        <a:srgbClr val="C9D6E3"/>
-                      </a:solidFill>
-                      <a:prstDash val="solid"/>
-                      <a:round/>
-                      <a:headEnd type="none" w="med" len="med"/>
-                      <a:tailEnd type="none" w="med" len="med"/>
-                    </a:lnR>
-                    <a:lnT w="9525" cap="flat" cmpd="sng" algn="ctr">
-                      <a:solidFill>
-                        <a:srgbClr val="C9D6E3"/>
-                      </a:solidFill>
-                      <a:prstDash val="solid"/>
-                      <a:round/>
-                      <a:headEnd type="none" w="med" len="med"/>
-                      <a:tailEnd type="none" w="med" len="med"/>
-                    </a:lnT>
-                    <a:lnB w="9525" cap="flat" cmpd="sng" algn="ctr">
-                      <a:solidFill>
-                        <a:srgbClr val="C9D6E3"/>
-                      </a:solidFill>
-                      <a:prstDash val="solid"/>
-                      <a:round/>
-                      <a:headEnd type="none" w="med" len="med"/>
-                      <a:tailEnd type="none" w="med" len="med"/>
-                    </a:lnB>
-                  </a:tcPr>
-                </a:tc>
-                <a:tc>
-                  <a:txBody>
-                    <a:bodyPr/>
-                    <a:lstStyle/>
-                    <a:p>
-                      <a:pPr algn="l" indent="0" marL="0">
-                        <a:buNone/>
-                      </a:pPr>
-                      <a:r>
-                        <a:rPr lang="en-US" sz="1050" dirty="0">
-                          <a:solidFill>
-                            <a:schemeClr val="tx1"/>
-                          </a:solidFill>
-                        </a:rPr>
-                        <a:t>This deck: 21 slides, speaker notes about 9 minutes</a:t>
-                      </a:r>
-                      <a:endParaRPr lang="en-US" sz="1050" dirty="0"/>
-                    </a:p>
-                  </a:txBody>
-                  <a:tcPr marL="91440" marR="91440" marT="45720" marB="45720" anchor="ctr">
-                    <a:lnL w="9525" cap="flat" cmpd="sng" algn="ctr">
-                      <a:solidFill>
-                        <a:srgbClr val="C9D6E3"/>
-                      </a:solidFill>
-                      <a:prstDash val="solid"/>
-                      <a:round/>
-                      <a:headEnd type="none" w="med" len="med"/>
-                      <a:tailEnd type="none" w="med" len="med"/>
-                    </a:lnL>
-                    <a:lnR w="9525" cap="flat" cmpd="sng" algn="ctr">
-                      <a:solidFill>
-                        <a:srgbClr val="C9D6E3"/>
-                      </a:solidFill>
-                      <a:prstDash val="solid"/>
-                      <a:round/>
-                      <a:headEnd type="none" w="med" len="med"/>
-                      <a:tailEnd type="none" w="med" len="med"/>
-                    </a:lnR>
-                    <a:lnT w="9525" cap="flat" cmpd="sng" algn="ctr">
-                      <a:solidFill>
-                        <a:srgbClr val="C9D6E3"/>
-                      </a:solidFill>
-                      <a:prstDash val="solid"/>
-                      <a:round/>
-                      <a:headEnd type="none" w="med" len="med"/>
-                      <a:tailEnd type="none" w="med" len="med"/>
-                    </a:lnT>
-                    <a:lnB w="9525" cap="flat" cmpd="sng" algn="ctr">
-                      <a:solidFill>
-                        <a:srgbClr val="C9D6E3"/>
-                      </a:solidFill>
-                      <a:prstDash val="solid"/>
-                      <a:round/>
-                      <a:headEnd type="none" w="med" len="med"/>
-                      <a:tailEnd type="none" w="med" len="med"/>
-                    </a:lnB>
-                  </a:tcPr>
-                </a:tc>
-                <a:tc>
-                  <a:txBody>
-                    <a:bodyPr/>
-                    <a:lstStyle/>
-                    <a:p>
-                      <a:pPr algn="l" indent="0" marL="0">
-                        <a:buNone/>
-                      </a:pPr>
-                      <a:r>
-                        <a:rPr lang="en-US" sz="1050" b="1" dirty="0">
-                          <a:solidFill>
-                            <a:schemeClr val="accent6"/>
-                          </a:solidFill>
-                        </a:rPr>
-                        <a:t>Done</a:t>
-                      </a:r>
-                      <a:endParaRPr lang="en-US" sz="1050" dirty="0"/>
-                    </a:p>
-                  </a:txBody>
-                  <a:tcPr marL="91440" marR="91440" marT="45720" marB="45720" anchor="ctr">
-                    <a:lnL w="9525" cap="flat" cmpd="sng" algn="ctr">
-                      <a:solidFill>
-                        <a:srgbClr val="C9D6E3"/>
-                      </a:solidFill>
-                      <a:prstDash val="solid"/>
-                      <a:round/>
-                      <a:headEnd type="none" w="med" len="med"/>
-                      <a:tailEnd type="none" w="med" len="med"/>
-                    </a:lnL>
-                    <a:lnR w="9525" cap="flat" cmpd="sng" algn="ctr">
-                      <a:solidFill>
-                        <a:srgbClr val="C9D6E3"/>
-                      </a:solidFill>
-                      <a:prstDash val="solid"/>
-                      <a:round/>
-                      <a:headEnd type="none" w="med" len="med"/>
-                      <a:tailEnd type="none" w="med" len="med"/>
-                    </a:lnR>
-                    <a:lnT w="9525" cap="flat" cmpd="sng" algn="ctr">
-                      <a:solidFill>
-                        <a:srgbClr val="C9D6E3"/>
-                      </a:solidFill>
-                      <a:prstDash val="solid"/>
-                      <a:round/>
-                      <a:headEnd type="none" w="med" len="med"/>
-                      <a:tailEnd type="none" w="med" len="med"/>
-                    </a:lnT>
-                    <a:lnB w="9525" cap="flat" cmpd="sng" algn="ctr">
-                      <a:solidFill>
-                        <a:srgbClr val="C9D6E3"/>
-                      </a:solidFill>
-                      <a:prstDash val="solid"/>
-                      <a:round/>
-                      <a:headEnd type="none" w="med" len="med"/>
-                      <a:tailEnd type="none" w="med" len="med"/>
-                    </a:lnB>
-                  </a:tcPr>
-                </a:tc>
-              </a:tr>
-              <a:tr h="393192">
-                <a:tc>
-                  <a:txBody>
-                    <a:bodyPr/>
-                    <a:lstStyle/>
-                    <a:p>
-                      <a:pPr algn="l" indent="0" marL="0">
-                        <a:buNone/>
-                      </a:pPr>
-                      <a:r>
-                        <a:rPr lang="en-US" sz="1050" b="1" dirty="0">
-                          <a:solidFill>
-                            <a:schemeClr val="tx1"/>
-                          </a:solidFill>
-                        </a:rPr>
-                        <a:t>Demo video, 5 minutes</a:t>
-                      </a:r>
-                      <a:endParaRPr lang="en-US" sz="1050" dirty="0"/>
-                    </a:p>
-                  </a:txBody>
-                  <a:tcPr marL="91440" marR="91440" marT="45720" marB="45720" anchor="ctr">
-                    <a:lnL w="9525" cap="flat" cmpd="sng" algn="ctr">
-                      <a:solidFill>
-                        <a:srgbClr val="C9D6E3"/>
-                      </a:solidFill>
-                      <a:prstDash val="solid"/>
-                      <a:round/>
-                      <a:headEnd type="none" w="med" len="med"/>
-                      <a:tailEnd type="none" w="med" len="med"/>
-                    </a:lnL>
-                    <a:lnR w="9525" cap="flat" cmpd="sng" algn="ctr">
-                      <a:solidFill>
-                        <a:srgbClr val="C9D6E3"/>
-                      </a:solidFill>
-                      <a:prstDash val="solid"/>
-                      <a:round/>
-                      <a:headEnd type="none" w="med" len="med"/>
-                      <a:tailEnd type="none" w="med" len="med"/>
-                    </a:lnR>
-                    <a:lnT w="9525" cap="flat" cmpd="sng" algn="ctr">
-                      <a:solidFill>
-                        <a:srgbClr val="C9D6E3"/>
-                      </a:solidFill>
-                      <a:prstDash val="solid"/>
-                      <a:round/>
-                      <a:headEnd type="none" w="med" len="med"/>
-                      <a:tailEnd type="none" w="med" len="med"/>
-                    </a:lnT>
-                    <a:lnB w="9525" cap="flat" cmpd="sng" algn="ctr">
-                      <a:solidFill>
-                        <a:srgbClr val="C9D6E3"/>
-                      </a:solidFill>
-                      <a:prstDash val="solid"/>
-                      <a:round/>
-                      <a:headEnd type="none" w="med" len="med"/>
-                      <a:tailEnd type="none" w="med" len="med"/>
-                    </a:lnB>
-                    <a:solidFill>
-                      <a:schemeClr val="bg2"/>
-                    </a:solidFill>
-                  </a:tcPr>
-                </a:tc>
-                <a:tc>
-                  <a:txBody>
-                    <a:bodyPr/>
-                    <a:lstStyle/>
-                    <a:p>
-                      <a:pPr algn="l" indent="0" marL="0">
-                        <a:buNone/>
-                      </a:pPr>
-                      <a:r>
-                        <a:rPr lang="en-US" sz="1050" dirty="0">
-                          <a:solidFill>
-                            <a:schemeClr val="tx1"/>
-                          </a:solidFill>
-                        </a:rPr>
-                        <a:t>Script and a silent recording; narrated video pending</a:t>
-                      </a:r>
-                      <a:endParaRPr lang="en-US" sz="1050" dirty="0"/>
-                    </a:p>
-                  </a:txBody>
-                  <a:tcPr marL="91440" marR="91440" marT="45720" marB="45720" anchor="ctr">
-                    <a:lnL w="9525" cap="flat" cmpd="sng" algn="ctr">
-                      <a:solidFill>
-                        <a:srgbClr val="C9D6E3"/>
-                      </a:solidFill>
-                      <a:prstDash val="solid"/>
-                      <a:round/>
-                      <a:headEnd type="none" w="med" len="med"/>
-                      <a:tailEnd type="none" w="med" len="med"/>
-                    </a:lnL>
-                    <a:lnR w="9525" cap="flat" cmpd="sng" algn="ctr">
-                      <a:solidFill>
-                        <a:srgbClr val="C9D6E3"/>
-                      </a:solidFill>
-                      <a:prstDash val="solid"/>
-                      <a:round/>
-                      <a:headEnd type="none" w="med" len="med"/>
-                      <a:tailEnd type="none" w="med" len="med"/>
-                    </a:lnR>
-                    <a:lnT w="9525" cap="flat" cmpd="sng" algn="ctr">
-                      <a:solidFill>
-                        <a:srgbClr val="C9D6E3"/>
-                      </a:solidFill>
-                      <a:prstDash val="solid"/>
-                      <a:round/>
-                      <a:headEnd type="none" w="med" len="med"/>
-                      <a:tailEnd type="none" w="med" len="med"/>
-                    </a:lnT>
-                    <a:lnB w="9525" cap="flat" cmpd="sng" algn="ctr">
-                      <a:solidFill>
-                        <a:srgbClr val="C9D6E3"/>
-                      </a:solidFill>
-                      <a:prstDash val="solid"/>
-                      <a:round/>
-                      <a:headEnd type="none" w="med" len="med"/>
-                      <a:tailEnd type="none" w="med" len="med"/>
-                    </a:lnB>
-                    <a:solidFill>
-                      <a:schemeClr val="bg2"/>
-                    </a:solidFill>
-                  </a:tcPr>
-                </a:tc>
-                <a:tc>
-                  <a:txBody>
-                    <a:bodyPr/>
-                    <a:lstStyle/>
-                    <a:p>
-                      <a:pPr algn="l" indent="0" marL="0">
-                        <a:buNone/>
-                      </a:pPr>
-                      <a:r>
-                        <a:rPr lang="en-US" sz="1050" b="1" dirty="0">
-                          <a:solidFill>
-                            <a:schemeClr val="accent3"/>
-                          </a:solidFill>
-                        </a:rPr>
-                        <a:t>Pending</a:t>
-                      </a:r>
-                      <a:endParaRPr lang="en-US" sz="1050" dirty="0"/>
-                    </a:p>
-                  </a:txBody>
-                  <a:tcPr marL="91440" marR="91440" marT="45720" marB="45720" anchor="ctr">
-                    <a:lnL w="9525" cap="flat" cmpd="sng" algn="ctr">
-                      <a:solidFill>
-                        <a:srgbClr val="C9D6E3"/>
-                      </a:solidFill>
-                      <a:prstDash val="solid"/>
-                      <a:round/>
-                      <a:headEnd type="none" w="med" len="med"/>
-                      <a:tailEnd type="none" w="med" len="med"/>
-                    </a:lnL>
-                    <a:lnR w="9525" cap="flat" cmpd="sng" algn="ctr">
-                      <a:solidFill>
-                        <a:srgbClr val="C9D6E3"/>
-                      </a:solidFill>
-                      <a:prstDash val="solid"/>
-                      <a:round/>
-                      <a:headEnd type="none" w="med" len="med"/>
-                      <a:tailEnd type="none" w="med" len="med"/>
-                    </a:lnR>
-                    <a:lnT w="9525" cap="flat" cmpd="sng" algn="ctr">
-                      <a:solidFill>
-                        <a:srgbClr val="C9D6E3"/>
-                      </a:solidFill>
-                      <a:prstDash val="solid"/>
-                      <a:round/>
-                      <a:headEnd type="none" w="med" len="med"/>
-                      <a:tailEnd type="none" w="med" len="med"/>
-                    </a:lnT>
-                    <a:lnB w="9525" cap="flat" cmpd="sng" algn="ctr">
-                      <a:solidFill>
-                        <a:srgbClr val="C9D6E3"/>
-                      </a:solidFill>
-                      <a:prstDash val="solid"/>
-                      <a:round/>
-                      <a:headEnd type="none" w="med" len="med"/>
-                      <a:tailEnd type="none" w="med" len="med"/>
-                    </a:lnB>
-                    <a:solidFill>
-                      <a:schemeClr val="bg2"/>
-                    </a:solidFill>
-                  </a:tcPr>
-                </a:tc>
-              </a:tr>
-              <a:tr h="393192">
-                <a:tc>
-                  <a:txBody>
-                    <a:bodyPr/>
-                    <a:lstStyle/>
-                    <a:p>
-                      <a:pPr algn="l" indent="0" marL="0">
-                        <a:buNone/>
-                      </a:pPr>
-                      <a:r>
-                        <a:rPr lang="en-US" sz="1050" b="1" dirty="0">
-                          <a:solidFill>
-                            <a:schemeClr val="tx1"/>
-                          </a:solidFill>
-                        </a:rPr>
-                        <a:t>Source, README, GitHub link</a:t>
-                      </a:r>
-                      <a:endParaRPr lang="en-US" sz="1050" dirty="0"/>
-                    </a:p>
-                  </a:txBody>
-                  <a:tcPr marL="91440" marR="91440" marT="45720" marB="45720" anchor="ctr">
-                    <a:lnL w="9525" cap="flat" cmpd="sng" algn="ctr">
-                      <a:solidFill>
-                        <a:srgbClr val="C9D6E3"/>
-                      </a:solidFill>
-                      <a:prstDash val="solid"/>
-                      <a:round/>
-                      <a:headEnd type="none" w="med" len="med"/>
-                      <a:tailEnd type="none" w="med" len="med"/>
-                    </a:lnL>
-                    <a:lnR w="9525" cap="flat" cmpd="sng" algn="ctr">
-                      <a:solidFill>
-                        <a:srgbClr val="C9D6E3"/>
-                      </a:solidFill>
-                      <a:prstDash val="solid"/>
-                      <a:round/>
-                      <a:headEnd type="none" w="med" len="med"/>
-                      <a:tailEnd type="none" w="med" len="med"/>
-                    </a:lnR>
-                    <a:lnT w="9525" cap="flat" cmpd="sng" algn="ctr">
-                      <a:solidFill>
-                        <a:srgbClr val="C9D6E3"/>
-                      </a:solidFill>
-                      <a:prstDash val="solid"/>
-                      <a:round/>
-                      <a:headEnd type="none" w="med" len="med"/>
-                      <a:tailEnd type="none" w="med" len="med"/>
-                    </a:lnT>
-                    <a:lnB w="9525" cap="flat" cmpd="sng" algn="ctr">
-                      <a:solidFill>
-                        <a:srgbClr val="C9D6E3"/>
-                      </a:solidFill>
-                      <a:prstDash val="solid"/>
-                      <a:round/>
-                      <a:headEnd type="none" w="med" len="med"/>
-                      <a:tailEnd type="none" w="med" len="med"/>
-                    </a:lnB>
-                  </a:tcPr>
-                </a:tc>
-                <a:tc>
-                  <a:txBody>
-                    <a:bodyPr/>
-                    <a:lstStyle/>
-                    <a:p>
-                      <a:pPr algn="l" indent="0" marL="0">
-                        <a:buNone/>
-                      </a:pPr>
-                      <a:r>
-                        <a:rPr lang="en-US" sz="1050" dirty="0">
-                          <a:solidFill>
-                            <a:schemeClr val="tx1"/>
-                          </a:solidFill>
-                        </a:rPr>
-                        <a:t>Public repository; docker compose up; CI green</a:t>
-                      </a:r>
-                      <a:endParaRPr lang="en-US" sz="1050" dirty="0"/>
-                    </a:p>
-                  </a:txBody>
-                  <a:tcPr marL="91440" marR="91440" marT="45720" marB="45720" anchor="ctr">
-                    <a:lnL w="9525" cap="flat" cmpd="sng" algn="ctr">
-                      <a:solidFill>
-                        <a:srgbClr val="C9D6E3"/>
-                      </a:solidFill>
-                      <a:prstDash val="solid"/>
-                      <a:round/>
-                      <a:headEnd type="none" w="med" len="med"/>
-                      <a:tailEnd type="none" w="med" len="med"/>
-                    </a:lnL>
-                    <a:lnR w="9525" cap="flat" cmpd="sng" algn="ctr">
-                      <a:solidFill>
-                        <a:srgbClr val="C9D6E3"/>
-                      </a:solidFill>
-                      <a:prstDash val="solid"/>
-                      <a:round/>
-                      <a:headEnd type="none" w="med" len="med"/>
-                      <a:tailEnd type="none" w="med" len="med"/>
-                    </a:lnR>
-                    <a:lnT w="9525" cap="flat" cmpd="sng" algn="ctr">
-                      <a:solidFill>
-                        <a:srgbClr val="C9D6E3"/>
-                      </a:solidFill>
-                      <a:prstDash val="solid"/>
-                      <a:round/>
-                      <a:headEnd type="none" w="med" len="med"/>
-                      <a:tailEnd type="none" w="med" len="med"/>
-                    </a:lnT>
-                    <a:lnB w="9525" cap="flat" cmpd="sng" algn="ctr">
-                      <a:solidFill>
-                        <a:srgbClr val="C9D6E3"/>
-                      </a:solidFill>
-                      <a:prstDash val="solid"/>
-                      <a:round/>
-                      <a:headEnd type="none" w="med" len="med"/>
-                      <a:tailEnd type="none" w="med" len="med"/>
-                    </a:lnB>
-                  </a:tcPr>
-                </a:tc>
-                <a:tc>
-                  <a:txBody>
-                    <a:bodyPr/>
-                    <a:lstStyle/>
-                    <a:p>
-                      <a:pPr algn="l" indent="0" marL="0">
-                        <a:buNone/>
-                      </a:pPr>
-                      <a:r>
-                        <a:rPr lang="en-US" sz="1050" b="1" dirty="0">
-                          <a:solidFill>
-                            <a:schemeClr val="accent6"/>
-                          </a:solidFill>
-                        </a:rPr>
-                        <a:t>Done</a:t>
-                      </a:r>
-                      <a:endParaRPr lang="en-US" sz="1050" dirty="0"/>
-                    </a:p>
-                  </a:txBody>
-                  <a:tcPr marL="91440" marR="91440" marT="45720" marB="45720" anchor="ctr">
-                    <a:lnL w="9525" cap="flat" cmpd="sng" algn="ctr">
-                      <a:solidFill>
-                        <a:srgbClr val="C9D6E3"/>
-                      </a:solidFill>
-                      <a:prstDash val="solid"/>
-                      <a:round/>
-                      <a:headEnd type="none" w="med" len="med"/>
-                      <a:tailEnd type="none" w="med" len="med"/>
-                    </a:lnL>
-                    <a:lnR w="9525" cap="flat" cmpd="sng" algn="ctr">
-                      <a:solidFill>
-                        <a:srgbClr val="C9D6E3"/>
-                      </a:solidFill>
-                      <a:prstDash val="solid"/>
-                      <a:round/>
-                      <a:headEnd type="none" w="med" len="med"/>
-                      <a:tailEnd type="none" w="med" len="med"/>
-                    </a:lnR>
-                    <a:lnT w="9525" cap="flat" cmpd="sng" algn="ctr">
-                      <a:solidFill>
-                        <a:srgbClr val="C9D6E3"/>
-                      </a:solidFill>
-                      <a:prstDash val="solid"/>
-                      <a:round/>
-                      <a:headEnd type="none" w="med" len="med"/>
-                      <a:tailEnd type="none" w="med" len="med"/>
-                    </a:lnT>
-                    <a:lnB w="9525" cap="flat" cmpd="sng" algn="ctr">
-                      <a:solidFill>
-                        <a:srgbClr val="C9D6E3"/>
-                      </a:solidFill>
-                      <a:prstDash val="solid"/>
-                      <a:round/>
-                      <a:headEnd type="none" w="med" len="med"/>
-                      <a:tailEnd type="none" w="med" len="med"/>
-                    </a:lnB>
-                  </a:tcPr>
-                </a:tc>
-              </a:tr>
-              <a:tr h="393192">
-                <a:tc>
-                  <a:txBody>
-                    <a:bodyPr/>
-                    <a:lstStyle/>
-                    <a:p>
-                      <a:pPr algn="l" indent="0" marL="0">
-                        <a:buNone/>
-                      </a:pPr>
-                      <a:r>
-                        <a:rPr lang="en-US" sz="1050" b="1" dirty="0">
-                          <a:solidFill>
-                            <a:schemeClr val="tx1"/>
-                          </a:solidFill>
-                        </a:rPr>
-                        <a:t>Security self-assessment</a:t>
-                      </a:r>
-                      <a:endParaRPr lang="en-US" sz="1050" dirty="0"/>
-                    </a:p>
-                  </a:txBody>
-                  <a:tcPr marL="91440" marR="91440" marT="45720" marB="45720" anchor="ctr">
-                    <a:lnL w="9525" cap="flat" cmpd="sng" algn="ctr">
-                      <a:solidFill>
-                        <a:srgbClr val="C9D6E3"/>
-                      </a:solidFill>
-                      <a:prstDash val="solid"/>
-                      <a:round/>
-                      <a:headEnd type="none" w="med" len="med"/>
-                      <a:tailEnd type="none" w="med" len="med"/>
-                    </a:lnL>
-                    <a:lnR w="9525" cap="flat" cmpd="sng" algn="ctr">
-                      <a:solidFill>
-                        <a:srgbClr val="C9D6E3"/>
-                      </a:solidFill>
-                      <a:prstDash val="solid"/>
-                      <a:round/>
-                      <a:headEnd type="none" w="med" len="med"/>
-                      <a:tailEnd type="none" w="med" len="med"/>
-                    </a:lnR>
-                    <a:lnT w="9525" cap="flat" cmpd="sng" algn="ctr">
-                      <a:solidFill>
-                        <a:srgbClr val="C9D6E3"/>
-                      </a:solidFill>
-                      <a:prstDash val="solid"/>
-                      <a:round/>
-                      <a:headEnd type="none" w="med" len="med"/>
-                      <a:tailEnd type="none" w="med" len="med"/>
-                    </a:lnT>
-                    <a:lnB w="9525" cap="flat" cmpd="sng" algn="ctr">
-                      <a:solidFill>
-                        <a:srgbClr val="C9D6E3"/>
-                      </a:solidFill>
-                      <a:prstDash val="solid"/>
-                      <a:round/>
-                      <a:headEnd type="none" w="med" len="med"/>
-                      <a:tailEnd type="none" w="med" len="med"/>
-                    </a:lnB>
-                    <a:solidFill>
-                      <a:schemeClr val="bg2"/>
-                    </a:solidFill>
-                  </a:tcPr>
-                </a:tc>
-                <a:tc>
-                  <a:txBody>
-                    <a:bodyPr/>
-                    <a:lstStyle/>
-                    <a:p>
-                      <a:pPr algn="l" indent="0" marL="0">
-                        <a:buNone/>
-                      </a:pPr>
-                      <a:r>
-                        <a:rPr lang="en-US" sz="1050" dirty="0">
-                          <a:solidFill>
-                            <a:schemeClr val="tx1"/>
-                          </a:solidFill>
-                        </a:rPr>
-                        <a:t>39 pages: 55 risks, 314 probe records, findings</a:t>
-                      </a:r>
-                      <a:endParaRPr lang="en-US" sz="1050" dirty="0"/>
-                    </a:p>
-                  </a:txBody>
-                  <a:tcPr marL="91440" marR="91440" marT="45720" marB="45720" anchor="ctr">
-                    <a:lnL w="9525" cap="flat" cmpd="sng" algn="ctr">
-                      <a:solidFill>
-                        <a:srgbClr val="C9D6E3"/>
-                      </a:solidFill>
-                      <a:prstDash val="solid"/>
-                      <a:round/>
-                      <a:headEnd type="none" w="med" len="med"/>
-                      <a:tailEnd type="none" w="med" len="med"/>
-                    </a:lnL>
-                    <a:lnR w="9525" cap="flat" cmpd="sng" algn="ctr">
-                      <a:solidFill>
-                        <a:srgbClr val="C9D6E3"/>
-                      </a:solidFill>
-                      <a:prstDash val="solid"/>
-                      <a:round/>
-                      <a:headEnd type="none" w="med" len="med"/>
-                      <a:tailEnd type="none" w="med" len="med"/>
-                    </a:lnR>
-                    <a:lnT w="9525" cap="flat" cmpd="sng" algn="ctr">
-                      <a:solidFill>
-                        <a:srgbClr val="C9D6E3"/>
-                      </a:solidFill>
-                      <a:prstDash val="solid"/>
-                      <a:round/>
-                      <a:headEnd type="none" w="med" len="med"/>
-                      <a:tailEnd type="none" w="med" len="med"/>
-                    </a:lnT>
-                    <a:lnB w="9525" cap="flat" cmpd="sng" algn="ctr">
-                      <a:solidFill>
-                        <a:srgbClr val="C9D6E3"/>
-                      </a:solidFill>
-                      <a:prstDash val="solid"/>
-                      <a:round/>
-                      <a:headEnd type="none" w="med" len="med"/>
-                      <a:tailEnd type="none" w="med" len="med"/>
-                    </a:lnB>
-                    <a:solidFill>
-                      <a:schemeClr val="bg2"/>
-                    </a:solidFill>
-                  </a:tcPr>
-                </a:tc>
-                <a:tc>
-                  <a:txBody>
-                    <a:bodyPr/>
-                    <a:lstStyle/>
-                    <a:p>
-                      <a:pPr algn="l" indent="0" marL="0">
-                        <a:buNone/>
-                      </a:pPr>
-                      <a:r>
-                        <a:rPr lang="en-US" sz="1050" b="1" dirty="0">
-                          <a:solidFill>
-                            <a:schemeClr val="accent6"/>
-                          </a:solidFill>
-                        </a:rPr>
-                        <a:t>Done</a:t>
-                      </a:r>
-                      <a:endParaRPr lang="en-US" sz="1050" dirty="0"/>
-                    </a:p>
-                  </a:txBody>
-                  <a:tcPr marL="91440" marR="91440" marT="45720" marB="45720" anchor="ctr">
-                    <a:lnL w="9525" cap="flat" cmpd="sng" algn="ctr">
-                      <a:solidFill>
-                        <a:srgbClr val="C9D6E3"/>
-                      </a:solidFill>
-                      <a:prstDash val="solid"/>
-                      <a:round/>
-                      <a:headEnd type="none" w="med" len="med"/>
-                      <a:tailEnd type="none" w="med" len="med"/>
-                    </a:lnL>
-                    <a:lnR w="9525" cap="flat" cmpd="sng" algn="ctr">
-                      <a:solidFill>
-                        <a:srgbClr val="C9D6E3"/>
-                      </a:solidFill>
-                      <a:prstDash val="solid"/>
-                      <a:round/>
-                      <a:headEnd type="none" w="med" len="med"/>
-                      <a:tailEnd type="none" w="med" len="med"/>
-                    </a:lnR>
-                    <a:lnT w="9525" cap="flat" cmpd="sng" algn="ctr">
-                      <a:solidFill>
-                        <a:srgbClr val="C9D6E3"/>
-                      </a:solidFill>
-                      <a:prstDash val="solid"/>
-                      <a:round/>
-                      <a:headEnd type="none" w="med" len="med"/>
-                      <a:tailEnd type="none" w="med" len="med"/>
-                    </a:lnT>
-                    <a:lnB w="9525" cap="flat" cmpd="sng" algn="ctr">
-                      <a:solidFill>
-                        <a:srgbClr val="C9D6E3"/>
-                      </a:solidFill>
-                      <a:prstDash val="solid"/>
-                      <a:round/>
-                      <a:headEnd type="none" w="med" len="med"/>
-                      <a:tailEnd type="none" w="med" len="med"/>
-                    </a:lnB>
-                    <a:solidFill>
-                      <a:schemeClr val="bg2"/>
-                    </a:solidFill>
-                  </a:tcPr>
-                </a:tc>
-              </a:tr>
-              <a:tr h="393192">
-                <a:tc>
-                  <a:txBody>
-                    <a:bodyPr/>
-                    <a:lstStyle/>
-                    <a:p>
-                      <a:pPr algn="l" indent="0" marL="0">
-                        <a:buNone/>
-                      </a:pPr>
-                      <a:r>
-                        <a:rPr lang="en-US" sz="1050" b="1" dirty="0">
-                          <a:solidFill>
-                            <a:schemeClr val="tx1"/>
-                          </a:solidFill>
-                        </a:rPr>
-                        <a:t>Execution evidence</a:t>
-                      </a:r>
-                      <a:endParaRPr lang="en-US" sz="1050" dirty="0"/>
-                    </a:p>
-                  </a:txBody>
-                  <a:tcPr marL="91440" marR="91440" marT="45720" marB="45720" anchor="ctr">
-                    <a:lnL w="9525" cap="flat" cmpd="sng" algn="ctr">
-                      <a:solidFill>
-                        <a:srgbClr val="C9D6E3"/>
-                      </a:solidFill>
-                      <a:prstDash val="solid"/>
-                      <a:round/>
-                      <a:headEnd type="none" w="med" len="med"/>
-                      <a:tailEnd type="none" w="med" len="med"/>
-                    </a:lnL>
-                    <a:lnR w="9525" cap="flat" cmpd="sng" algn="ctr">
-                      <a:solidFill>
-                        <a:srgbClr val="C9D6E3"/>
-                      </a:solidFill>
-                      <a:prstDash val="solid"/>
-                      <a:round/>
-                      <a:headEnd type="none" w="med" len="med"/>
-                      <a:tailEnd type="none" w="med" len="med"/>
-                    </a:lnR>
-                    <a:lnT w="9525" cap="flat" cmpd="sng" algn="ctr">
-                      <a:solidFill>
-                        <a:srgbClr val="C9D6E3"/>
-                      </a:solidFill>
-                      <a:prstDash val="solid"/>
-                      <a:round/>
-                      <a:headEnd type="none" w="med" len="med"/>
-                      <a:tailEnd type="none" w="med" len="med"/>
-                    </a:lnT>
-                    <a:lnB w="9525" cap="flat" cmpd="sng" algn="ctr">
-                      <a:solidFill>
-                        <a:srgbClr val="C9D6E3"/>
-                      </a:solidFill>
-                      <a:prstDash val="solid"/>
-                      <a:round/>
-                      <a:headEnd type="none" w="med" len="med"/>
-                      <a:tailEnd type="none" w="med" len="med"/>
-                    </a:lnB>
-                  </a:tcPr>
-                </a:tc>
-                <a:tc>
-                  <a:txBody>
-                    <a:bodyPr/>
-                    <a:lstStyle/>
-                    <a:p>
-                      <a:pPr algn="l" indent="0" marL="0">
-                        <a:buNone/>
-                      </a:pPr>
-                      <a:r>
-                        <a:rPr lang="en-US" sz="1050" dirty="0">
-                          <a:solidFill>
-                            <a:schemeClr val="tx1"/>
-                          </a:solidFill>
-                        </a:rPr>
-                        <a:t>Operation logs, audit verify, tamper and restore</a:t>
-                      </a:r>
-                      <a:endParaRPr lang="en-US" sz="1050" dirty="0"/>
-                    </a:p>
-                  </a:txBody>
-                  <a:tcPr marL="91440" marR="91440" marT="45720" marB="45720" anchor="ctr">
-                    <a:lnL w="9525" cap="flat" cmpd="sng" algn="ctr">
-                      <a:solidFill>
-                        <a:srgbClr val="C9D6E3"/>
-                      </a:solidFill>
-                      <a:prstDash val="solid"/>
-                      <a:round/>
-                      <a:headEnd type="none" w="med" len="med"/>
-                      <a:tailEnd type="none" w="med" len="med"/>
-                    </a:lnL>
-                    <a:lnR w="9525" cap="flat" cmpd="sng" algn="ctr">
-                      <a:solidFill>
-                        <a:srgbClr val="C9D6E3"/>
-                      </a:solidFill>
-                      <a:prstDash val="solid"/>
-                      <a:round/>
-                      <a:headEnd type="none" w="med" len="med"/>
-                      <a:tailEnd type="none" w="med" len="med"/>
-                    </a:lnR>
-                    <a:lnT w="9525" cap="flat" cmpd="sng" algn="ctr">
-                      <a:solidFill>
-                        <a:srgbClr val="C9D6E3"/>
-                      </a:solidFill>
-                      <a:prstDash val="solid"/>
-                      <a:round/>
-                      <a:headEnd type="none" w="med" len="med"/>
-                      <a:tailEnd type="none" w="med" len="med"/>
-                    </a:lnT>
-                    <a:lnB w="9525" cap="flat" cmpd="sng" algn="ctr">
-                      <a:solidFill>
-                        <a:srgbClr val="C9D6E3"/>
-                      </a:solidFill>
-                      <a:prstDash val="solid"/>
-                      <a:round/>
-                      <a:headEnd type="none" w="med" len="med"/>
-                      <a:tailEnd type="none" w="med" len="med"/>
-                    </a:lnB>
-                  </a:tcPr>
-                </a:tc>
-                <a:tc>
-                  <a:txBody>
-                    <a:bodyPr/>
-                    <a:lstStyle/>
-                    <a:p>
-                      <a:pPr algn="l" indent="0" marL="0">
-                        <a:buNone/>
-                      </a:pPr>
-                      <a:r>
-                        <a:rPr lang="en-US" sz="1050" b="1" dirty="0">
-                          <a:solidFill>
-                            <a:schemeClr val="accent6"/>
-                          </a:solidFill>
-                        </a:rPr>
-                        <a:t>Done</a:t>
-                      </a:r>
-                      <a:endParaRPr lang="en-US" sz="1050" dirty="0"/>
-                    </a:p>
-                  </a:txBody>
-                  <a:tcPr marL="91440" marR="91440" marT="45720" marB="45720" anchor="ctr">
-                    <a:lnL w="9525" cap="flat" cmpd="sng" algn="ctr">
-                      <a:solidFill>
-                        <a:srgbClr val="C9D6E3"/>
-                      </a:solidFill>
-                      <a:prstDash val="solid"/>
-                      <a:round/>
-                      <a:headEnd type="none" w="med" len="med"/>
-                      <a:tailEnd type="none" w="med" len="med"/>
-                    </a:lnL>
-                    <a:lnR w="9525" cap="flat" cmpd="sng" algn="ctr">
-                      <a:solidFill>
-                        <a:srgbClr val="C9D6E3"/>
-                      </a:solidFill>
-                      <a:prstDash val="solid"/>
-                      <a:round/>
-                      <a:headEnd type="none" w="med" len="med"/>
-                      <a:tailEnd type="none" w="med" len="med"/>
-                    </a:lnR>
-                    <a:lnT w="9525" cap="flat" cmpd="sng" algn="ctr">
-                      <a:solidFill>
-                        <a:srgbClr val="C9D6E3"/>
-                      </a:solidFill>
-                      <a:prstDash val="solid"/>
-                      <a:round/>
-                      <a:headEnd type="none" w="med" len="med"/>
-                      <a:tailEnd type="none" w="med" len="med"/>
-                    </a:lnT>
-                    <a:lnB w="9525" cap="flat" cmpd="sng" algn="ctr">
-                      <a:solidFill>
-                        <a:srgbClr val="C9D6E3"/>
-                      </a:solidFill>
-                      <a:prstDash val="solid"/>
-                      <a:round/>
-                      <a:headEnd type="none" w="med" len="med"/>
-                      <a:tailEnd type="none" w="med" len="med"/>
-                    </a:lnB>
-                  </a:tcPr>
-                </a:tc>
-              </a:tr>
-              <a:tr h="393192">
-                <a:tc>
-                  <a:txBody>
-                    <a:bodyPr/>
-                    <a:lstStyle/>
-                    <a:p>
-                      <a:pPr algn="l" indent="0" marL="0">
-                        <a:buNone/>
-                      </a:pPr>
-                      <a:r>
-                        <a:rPr lang="en-US" sz="1050" b="1" dirty="0">
-                          <a:solidFill>
-                            <a:schemeClr val="tx1"/>
-                          </a:solidFill>
-                        </a:rPr>
-                        <a:t>Sandbox, synthetic data, English</a:t>
-                      </a:r>
-                      <a:endParaRPr lang="en-US" sz="1050" dirty="0"/>
-                    </a:p>
-                  </a:txBody>
-                  <a:tcPr marL="91440" marR="91440" marT="45720" marB="45720" anchor="ctr">
-                    <a:lnL w="9525" cap="flat" cmpd="sng" algn="ctr">
-                      <a:solidFill>
-                        <a:srgbClr val="C9D6E3"/>
-                      </a:solidFill>
-                      <a:prstDash val="solid"/>
-                      <a:round/>
-                      <a:headEnd type="none" w="med" len="med"/>
-                      <a:tailEnd type="none" w="med" len="med"/>
-                    </a:lnL>
-                    <a:lnR w="9525" cap="flat" cmpd="sng" algn="ctr">
-                      <a:solidFill>
-                        <a:srgbClr val="C9D6E3"/>
-                      </a:solidFill>
-                      <a:prstDash val="solid"/>
-                      <a:round/>
-                      <a:headEnd type="none" w="med" len="med"/>
-                      <a:tailEnd type="none" w="med" len="med"/>
-                    </a:lnR>
-                    <a:lnT w="9525" cap="flat" cmpd="sng" algn="ctr">
-                      <a:solidFill>
-                        <a:srgbClr val="C9D6E3"/>
-                      </a:solidFill>
-                      <a:prstDash val="solid"/>
-                      <a:round/>
-                      <a:headEnd type="none" w="med" len="med"/>
-                      <a:tailEnd type="none" w="med" len="med"/>
-                    </a:lnT>
-                    <a:lnB w="9525" cap="flat" cmpd="sng" algn="ctr">
-                      <a:solidFill>
-                        <a:srgbClr val="C9D6E3"/>
-                      </a:solidFill>
-                      <a:prstDash val="solid"/>
-                      <a:round/>
-                      <a:headEnd type="none" w="med" len="med"/>
-                      <a:tailEnd type="none" w="med" len="med"/>
-                    </a:lnB>
-                    <a:solidFill>
-                      <a:schemeClr val="bg2"/>
-                    </a:solidFill>
-                  </a:tcPr>
-                </a:tc>
-                <a:tc>
-                  <a:txBody>
-                    <a:bodyPr/>
-                    <a:lstStyle/>
-                    <a:p>
-                      <a:pPr algn="l" indent="0" marL="0">
-                        <a:buNone/>
-                      </a:pPr>
-                      <a:r>
-                        <a:rPr lang="en-US" sz="1050" dirty="0">
-                          <a:solidFill>
-                            <a:schemeClr val="tx1"/>
-                          </a:solidFill>
-                        </a:rPr>
-                        <a:t>Banner on every screen; no real money moves</a:t>
-                      </a:r>
-                      <a:endParaRPr lang="en-US" sz="1050" dirty="0"/>
-                    </a:p>
-                  </a:txBody>
-                  <a:tcPr marL="91440" marR="91440" marT="45720" marB="45720" anchor="ctr">
-                    <a:lnL w="9525" cap="flat" cmpd="sng" algn="ctr">
-                      <a:solidFill>
-                        <a:srgbClr val="C9D6E3"/>
-                      </a:solidFill>
-                      <a:prstDash val="solid"/>
-                      <a:round/>
-                      <a:headEnd type="none" w="med" len="med"/>
-                      <a:tailEnd type="none" w="med" len="med"/>
-                    </a:lnL>
-                    <a:lnR w="9525" cap="flat" cmpd="sng" algn="ctr">
-                      <a:solidFill>
-                        <a:srgbClr val="C9D6E3"/>
-                      </a:solidFill>
-                      <a:prstDash val="solid"/>
-                      <a:round/>
-                      <a:headEnd type="none" w="med" len="med"/>
-                      <a:tailEnd type="none" w="med" len="med"/>
-                    </a:lnR>
-                    <a:lnT w="9525" cap="flat" cmpd="sng" algn="ctr">
-                      <a:solidFill>
-                        <a:srgbClr val="C9D6E3"/>
-                      </a:solidFill>
-                      <a:prstDash val="solid"/>
-                      <a:round/>
-                      <a:headEnd type="none" w="med" len="med"/>
-                      <a:tailEnd type="none" w="med" len="med"/>
-                    </a:lnT>
-                    <a:lnB w="9525" cap="flat" cmpd="sng" algn="ctr">
-                      <a:solidFill>
-                        <a:srgbClr val="C9D6E3"/>
-                      </a:solidFill>
-                      <a:prstDash val="solid"/>
-                      <a:round/>
-                      <a:headEnd type="none" w="med" len="med"/>
-                      <a:tailEnd type="none" w="med" len="med"/>
-                    </a:lnB>
-                    <a:solidFill>
-                      <a:schemeClr val="bg2"/>
-                    </a:solidFill>
-                  </a:tcPr>
-                </a:tc>
-                <a:tc>
-                  <a:txBody>
-                    <a:bodyPr/>
-                    <a:lstStyle/>
-                    <a:p>
-                      <a:pPr algn="l" indent="0" marL="0">
-                        <a:buNone/>
-                      </a:pPr>
-                      <a:r>
-                        <a:rPr lang="en-US" sz="1050" b="1" dirty="0">
-                          <a:solidFill>
-                            <a:schemeClr val="accent6"/>
-                          </a:solidFill>
-                        </a:rPr>
-                        <a:t>Done</a:t>
-                      </a:r>
-                      <a:endParaRPr lang="en-US" sz="1050" dirty="0"/>
-                    </a:p>
-                  </a:txBody>
-                  <a:tcPr marL="91440" marR="91440" marT="45720" marB="45720" anchor="ctr">
-                    <a:lnL w="9525" cap="flat" cmpd="sng" algn="ctr">
-                      <a:solidFill>
-                        <a:srgbClr val="C9D6E3"/>
-                      </a:solidFill>
-                      <a:prstDash val="solid"/>
-                      <a:round/>
-                      <a:headEnd type="none" w="med" len="med"/>
-                      <a:tailEnd type="none" w="med" len="med"/>
-                    </a:lnL>
-                    <a:lnR w="9525" cap="flat" cmpd="sng" algn="ctr">
-                      <a:solidFill>
-                        <a:srgbClr val="C9D6E3"/>
-                      </a:solidFill>
-                      <a:prstDash val="solid"/>
-                      <a:round/>
-                      <a:headEnd type="none" w="med" len="med"/>
-                      <a:tailEnd type="none" w="med" len="med"/>
-                    </a:lnR>
-                    <a:lnT w="9525" cap="flat" cmpd="sng" algn="ctr">
-                      <a:solidFill>
-                        <a:srgbClr val="C9D6E3"/>
-                      </a:solidFill>
-                      <a:prstDash val="solid"/>
-                      <a:round/>
-                      <a:headEnd type="none" w="med" len="med"/>
-                      <a:tailEnd type="none" w="med" len="med"/>
-                    </a:lnT>
-                    <a:lnB w="9525" cap="flat" cmpd="sng" algn="ctr">
-                      <a:solidFill>
-                        <a:srgbClr val="C9D6E3"/>
-                      </a:solidFill>
-                      <a:prstDash val="solid"/>
-                      <a:round/>
-                      <a:headEnd type="none" w="med" len="med"/>
-                      <a:tailEnd type="none" w="med" len="med"/>
-                    </a:lnB>
-                    <a:solidFill>
-                      <a:schemeClr val="bg2"/>
-                    </a:solidFill>
-                  </a:tcPr>
-                </a:tc>
-              </a:tr>
-            </a:tbl>
-          </a:graphicData>
-        </a:graphic>
-      </p:graphicFrame>
-      <p:sp>
-        <p:nvSpPr>
-          <p:cNvPr id="4" name="content-20-rect-2"/>
-          <p:cNvSpPr/>
-          <p:nvPr/>
-        </p:nvSpPr>
-        <p:spPr>
-          <a:xfrm>
-            <a:off x="6446520" y="1188720"/>
-            <a:ext cx="2240280" cy="1024128"/>
-          </a:xfrm>
-          <a:prstGeom prst="roundRect">
-            <a:avLst>
-              <a:gd name="adj" fmla="val 7143"/>
-            </a:avLst>
-          </a:prstGeom>
-          <a:solidFill>
-            <a:schemeClr val="bg2"/>
-          </a:solidFill>
-          <a:ln/>
-        </p:spPr>
-      </p:sp>
-      <p:sp>
-        <p:nvSpPr>
-          <p:cNvPr id="5" name="content-20-text-3"/>
-          <p:cNvSpPr txBox="1"/>
-          <p:nvPr/>
-        </p:nvSpPr>
-        <p:spPr>
-          <a:xfrm>
-            <a:off x="6583680" y="1234440"/>
-            <a:ext cx="1097280" cy="457200"/>
-          </a:xfrm>
-          <a:prstGeom prst="rect">
-            <a:avLst/>
-          </a:prstGeom>
-          <a:noFill/>
-          <a:ln/>
-        </p:spPr>
-        <p:txBody>
-          <a:bodyPr wrap="square" lIns="0" tIns="0" rIns="0" bIns="0" rtlCol="0" anchor="ctr"/>
-          <a:lstStyle/>
-          <a:p>
-            <a:pPr algn="l" indent="0" marL="0">
-              <a:buNone/>
-            </a:pPr>
-            <a:r>
-              <a:rPr lang="en-US" sz="2600" b="1" dirty="0">
-                <a:solidFill>
-                  <a:schemeClr val="accent1"/>
-                </a:solidFill>
-                <a:latin typeface="+mj-lt" pitchFamily="34" charset="0"/>
-                <a:ea typeface="+mj-lt" pitchFamily="34" charset="-122"/>
-                <a:cs typeface="+mj-lt" pitchFamily="34" charset="-120"/>
-              </a:rPr>
-              <a:t>40%</a:t>
-            </a:r>
-            <a:endParaRPr lang="en-US" sz="2600" dirty="0"/>
-          </a:p>
-        </p:txBody>
-      </p:sp>
-      <p:sp>
-        <p:nvSpPr>
-          <p:cNvPr id="6" name="content-20-text-4"/>
-          <p:cNvSpPr txBox="1"/>
-          <p:nvPr/>
-        </p:nvSpPr>
-        <p:spPr>
-          <a:xfrm>
-            <a:off x="6583680" y="1691640"/>
-            <a:ext cx="2011680" cy="256032"/>
-          </a:xfrm>
-          <a:prstGeom prst="rect">
-            <a:avLst/>
-          </a:prstGeom>
-          <a:noFill/>
-          <a:ln/>
-        </p:spPr>
-        <p:txBody>
-          <a:bodyPr wrap="square" lIns="0" tIns="0" rIns="0" bIns="0" rtlCol="0" anchor="t"/>
-          <a:lstStyle/>
-          <a:p>
-            <a:pPr algn="l" indent="0" marL="0">
-              <a:buNone/>
-            </a:pPr>
-            <a:r>
-              <a:rPr lang="en-US" sz="1100" b="1" dirty="0">
-                <a:solidFill>
-                  <a:schemeClr val="tx1"/>
-                </a:solidFill>
-              </a:rPr>
-              <a:t>Task completion</a:t>
-            </a:r>
-            <a:endParaRPr lang="en-US" sz="1100" dirty="0"/>
-          </a:p>
-        </p:txBody>
-      </p:sp>
-      <p:sp>
-        <p:nvSpPr>
-          <p:cNvPr id="7" name="content-20-text-5"/>
-          <p:cNvSpPr txBox="1"/>
-          <p:nvPr/>
-        </p:nvSpPr>
-        <p:spPr>
-          <a:xfrm>
-            <a:off x="6583680" y="1920240"/>
-            <a:ext cx="2011680" cy="256032"/>
-          </a:xfrm>
-          <a:prstGeom prst="rect">
-            <a:avLst/>
-          </a:prstGeom>
-          <a:noFill/>
-          <a:ln/>
-        </p:spPr>
-        <p:txBody>
-          <a:bodyPr wrap="square" lIns="0" tIns="0" rIns="0" bIns="0" rtlCol="0" anchor="t"/>
-          <a:lstStyle/>
-          <a:p>
-            <a:pPr algn="l" indent="0" marL="0">
-              <a:buNone/>
-            </a:pPr>
-            <a:r>
-              <a:rPr lang="en-US" sz="1000" dirty="0">
-                <a:solidFill>
-                  <a:schemeClr val="tx2"/>
-                </a:solidFill>
-              </a:rPr>
-              <a:t>Slides 5 to 8 and 14</a:t>
-            </a:r>
-            <a:endParaRPr lang="en-US" sz="1000" dirty="0"/>
-          </a:p>
-        </p:txBody>
-      </p:sp>
-      <p:sp>
-        <p:nvSpPr>
-          <p:cNvPr id="8" name="content-20-rect-6"/>
-          <p:cNvSpPr/>
-          <p:nvPr/>
-        </p:nvSpPr>
-        <p:spPr>
-          <a:xfrm>
-            <a:off x="6446520" y="2304288"/>
-            <a:ext cx="2240280" cy="1024128"/>
-          </a:xfrm>
-          <a:prstGeom prst="roundRect">
-            <a:avLst>
-              <a:gd name="adj" fmla="val 7143"/>
-            </a:avLst>
-          </a:prstGeom>
-          <a:solidFill>
-            <a:schemeClr val="bg2"/>
-          </a:solidFill>
-          <a:ln/>
-        </p:spPr>
-      </p:sp>
-      <p:sp>
-        <p:nvSpPr>
-          <p:cNvPr id="9" name="content-20-text-7"/>
-          <p:cNvSpPr txBox="1"/>
-          <p:nvPr/>
-        </p:nvSpPr>
-        <p:spPr>
-          <a:xfrm>
-            <a:off x="6583680" y="2350008"/>
-            <a:ext cx="1097280" cy="457200"/>
-          </a:xfrm>
-          <a:prstGeom prst="rect">
-            <a:avLst/>
-          </a:prstGeom>
-          <a:noFill/>
-          <a:ln/>
-        </p:spPr>
-        <p:txBody>
-          <a:bodyPr wrap="square" lIns="0" tIns="0" rIns="0" bIns="0" rtlCol="0" anchor="ctr"/>
-          <a:lstStyle/>
-          <a:p>
-            <a:pPr algn="l" indent="0" marL="0">
-              <a:buNone/>
-            </a:pPr>
-            <a:r>
-              <a:rPr lang="en-US" sz="2600" b="1" dirty="0">
-                <a:solidFill>
-                  <a:schemeClr val="accent1"/>
-                </a:solidFill>
-                <a:latin typeface="+mj-lt" pitchFamily="34" charset="0"/>
-                <a:ea typeface="+mj-lt" pitchFamily="34" charset="-122"/>
-                <a:cs typeface="+mj-lt" pitchFamily="34" charset="-120"/>
-              </a:rPr>
-              <a:t>30%</a:t>
-            </a:r>
-            <a:endParaRPr lang="en-US" sz="2600" dirty="0"/>
-          </a:p>
-        </p:txBody>
-      </p:sp>
-      <p:sp>
-        <p:nvSpPr>
-          <p:cNvPr id="10" name="content-20-text-8"/>
-          <p:cNvSpPr txBox="1"/>
-          <p:nvPr/>
-        </p:nvSpPr>
-        <p:spPr>
-          <a:xfrm>
-            <a:off x="6583680" y="2807208"/>
-            <a:ext cx="2011680" cy="256032"/>
-          </a:xfrm>
-          <a:prstGeom prst="rect">
-            <a:avLst/>
-          </a:prstGeom>
-          <a:noFill/>
-          <a:ln/>
-        </p:spPr>
-        <p:txBody>
-          <a:bodyPr wrap="square" lIns="0" tIns="0" rIns="0" bIns="0" rtlCol="0" anchor="t"/>
-          <a:lstStyle/>
-          <a:p>
-            <a:pPr algn="l" indent="0" marL="0">
-              <a:buNone/>
-            </a:pPr>
-            <a:r>
-              <a:rPr lang="en-US" sz="1100" b="1" dirty="0">
-                <a:solidFill>
-                  <a:schemeClr val="tx1"/>
-                </a:solidFill>
-              </a:rPr>
-              <a:t>Security and compliance</a:t>
-            </a:r>
-            <a:endParaRPr lang="en-US" sz="1100" dirty="0"/>
-          </a:p>
-        </p:txBody>
-      </p:sp>
-      <p:sp>
-        <p:nvSpPr>
-          <p:cNvPr id="11" name="content-20-text-9"/>
-          <p:cNvSpPr txBox="1"/>
-          <p:nvPr/>
-        </p:nvSpPr>
-        <p:spPr>
-          <a:xfrm>
-            <a:off x="6583680" y="3035808"/>
-            <a:ext cx="2011680" cy="256032"/>
-          </a:xfrm>
-          <a:prstGeom prst="rect">
-            <a:avLst/>
-          </a:prstGeom>
-          <a:noFill/>
-          <a:ln/>
-        </p:spPr>
-        <p:txBody>
-          <a:bodyPr wrap="square" lIns="0" tIns="0" rIns="0" bIns="0" rtlCol="0" anchor="t"/>
-          <a:lstStyle/>
-          <a:p>
-            <a:pPr algn="l" indent="0" marL="0">
-              <a:buNone/>
-            </a:pPr>
-            <a:r>
-              <a:rPr lang="en-US" sz="1000" dirty="0">
-                <a:solidFill>
-                  <a:schemeClr val="tx2"/>
-                </a:solidFill>
-              </a:rPr>
-              <a:t>Slides 9 and 15 to 18</a:t>
-            </a:r>
-            <a:endParaRPr lang="en-US" sz="1000" dirty="0"/>
-          </a:p>
-        </p:txBody>
-      </p:sp>
-      <p:sp>
-        <p:nvSpPr>
-          <p:cNvPr id="12" name="content-20-rect-10"/>
-          <p:cNvSpPr/>
-          <p:nvPr/>
-        </p:nvSpPr>
-        <p:spPr>
-          <a:xfrm>
-            <a:off x="6446520" y="3419856"/>
-            <a:ext cx="2240280" cy="1024128"/>
-          </a:xfrm>
-          <a:prstGeom prst="roundRect">
-            <a:avLst>
-              <a:gd name="adj" fmla="val 7143"/>
-            </a:avLst>
-          </a:prstGeom>
-          <a:solidFill>
-            <a:schemeClr val="bg2"/>
-          </a:solidFill>
-          <a:ln/>
-        </p:spPr>
-      </p:sp>
-      <p:sp>
-        <p:nvSpPr>
-          <p:cNvPr id="13" name="content-20-text-11"/>
-          <p:cNvSpPr txBox="1"/>
-          <p:nvPr/>
-        </p:nvSpPr>
-        <p:spPr>
-          <a:xfrm>
-            <a:off x="6583680" y="3465576"/>
-            <a:ext cx="1097280" cy="457200"/>
-          </a:xfrm>
-          <a:prstGeom prst="rect">
-            <a:avLst/>
-          </a:prstGeom>
-          <a:noFill/>
-          <a:ln/>
-        </p:spPr>
-        <p:txBody>
-          <a:bodyPr wrap="square" lIns="0" tIns="0" rIns="0" bIns="0" rtlCol="0" anchor="ctr"/>
-          <a:lstStyle/>
-          <a:p>
-            <a:pPr algn="l" indent="0" marL="0">
-              <a:buNone/>
-            </a:pPr>
-            <a:r>
-              <a:rPr lang="en-US" sz="2600" b="1" dirty="0">
-                <a:solidFill>
-                  <a:schemeClr val="accent1"/>
-                </a:solidFill>
-                <a:latin typeface="+mj-lt" pitchFamily="34" charset="0"/>
-                <a:ea typeface="+mj-lt" pitchFamily="34" charset="-122"/>
-                <a:cs typeface="+mj-lt" pitchFamily="34" charset="-120"/>
-              </a:rPr>
-              <a:t>30%</a:t>
-            </a:r>
-            <a:endParaRPr lang="en-US" sz="2600" dirty="0"/>
-          </a:p>
-        </p:txBody>
-      </p:sp>
-      <p:sp>
-        <p:nvSpPr>
-          <p:cNvPr id="14" name="content-20-text-12"/>
-          <p:cNvSpPr txBox="1"/>
-          <p:nvPr/>
-        </p:nvSpPr>
-        <p:spPr>
-          <a:xfrm>
-            <a:off x="6583680" y="3922776"/>
-            <a:ext cx="2011680" cy="256032"/>
-          </a:xfrm>
-          <a:prstGeom prst="rect">
-            <a:avLst/>
-          </a:prstGeom>
-          <a:noFill/>
-          <a:ln/>
-        </p:spPr>
-        <p:txBody>
-          <a:bodyPr wrap="square" lIns="0" tIns="0" rIns="0" bIns="0" rtlCol="0" anchor="t"/>
-          <a:lstStyle/>
-          <a:p>
-            <a:pPr algn="l" indent="0" marL="0">
-              <a:buNone/>
-            </a:pPr>
-            <a:r>
-              <a:rPr lang="en-US" sz="1100" b="1" dirty="0">
-                <a:solidFill>
-                  <a:schemeClr val="tx1"/>
-                </a:solidFill>
-              </a:rPr>
-              <a:t>Innovation and interaction</a:t>
-            </a:r>
-            <a:endParaRPr lang="en-US" sz="1100" dirty="0"/>
-          </a:p>
-        </p:txBody>
-      </p:sp>
-      <p:sp>
-        <p:nvSpPr>
-          <p:cNvPr id="15" name="content-20-text-13"/>
-          <p:cNvSpPr txBox="1"/>
-          <p:nvPr/>
-        </p:nvSpPr>
-        <p:spPr>
-          <a:xfrm>
-            <a:off x="6583680" y="4151376"/>
-            <a:ext cx="2011680" cy="256032"/>
-          </a:xfrm>
-          <a:prstGeom prst="rect">
-            <a:avLst/>
-          </a:prstGeom>
-          <a:noFill/>
-          <a:ln/>
-        </p:spPr>
-        <p:txBody>
-          <a:bodyPr wrap="square" lIns="0" tIns="0" rIns="0" bIns="0" rtlCol="0" anchor="t"/>
-          <a:lstStyle/>
-          <a:p>
-            <a:pPr algn="l" indent="0" marL="0">
-              <a:buNone/>
-            </a:pPr>
-            <a:r>
-              <a:rPr lang="en-US" sz="1000" dirty="0">
-                <a:solidFill>
-                  <a:schemeClr val="tx2"/>
-                </a:solidFill>
-              </a:rPr>
-              <a:t>Slides 8 to 12 and 19</a:t>
-            </a:r>
-            <a:endParaRPr lang="en-US" sz="1000" dirty="0"/>
-          </a:p>
-        </p:txBody>
-      </p:sp>
-      <p:sp>
-        <p:nvSpPr>
-          <p:cNvPr id="16" name="content-20-text-14"/>
-          <p:cNvSpPr txBox="1"/>
-          <p:nvPr/>
-        </p:nvSpPr>
-        <p:spPr>
-          <a:xfrm>
-            <a:off x="457200" y="4681728"/>
-            <a:ext cx="8229600" cy="274320"/>
-          </a:xfrm>
-          <a:prstGeom prst="rect">
-            <a:avLst/>
-          </a:prstGeom>
-          <a:noFill/>
-          <a:ln/>
-        </p:spPr>
-        <p:txBody>
-          <a:bodyPr wrap="square" lIns="0" tIns="0" rIns="0" bIns="0" rtlCol="0" anchor="t"/>
-          <a:lstStyle/>
-          <a:p>
-            <a:pPr algn="l" indent="0" marL="0">
-              <a:buNone/>
-            </a:pPr>
-            <a:r>
-              <a:rPr lang="en-US" sz="1000" dirty="0">
-                <a:solidFill>
-                  <a:schemeClr val="tx2"/>
-                </a:solidFill>
-              </a:rPr>
-              <a:t>Eligibility and registration are the team's to confirm with the organiser; nothing here certifies them.</a:t>
-            </a:r>
-            <a:endParaRPr lang="en-US" sz="1000" dirty="0"/>
-          </a:p>
-        </p:txBody>
-      </p:sp>
-    </p:spTree>
-  </p:cSld>
-  <p:clrMapOvr>
-    <a:masterClrMapping/>
-  </p:clrMapOvr>
-</p:sld>
-</file>
-
-<file path=ppt/slides/slide21.xml><?xml version="1.0" encoding="utf-8"?>
-<p:sld xmlns:a="http://schemas.openxmlformats.org/drawingml/2006/main" xmlns:r="http://schemas.openxmlformats.org/officeDocument/2006/relationships" xmlns:p="http://schemas.openxmlformats.org/presentationml/2006/main">
-  <p:cSld name="Slide 21">
-    <p:spTree>
-      <p:nvGrpSpPr>
-        <p:cNvPr id="1" name=""/>
-        <p:cNvGrpSpPr/>
-        <p:nvPr/>
-      </p:nvGrpSpPr>
-      <p:grpSpPr>
-        <a:xfrm>
-          <a:off x="0" y="0"/>
-          <a:ext cx="0" cy="0"/>
-          <a:chOff x="0" y="0"/>
-          <a:chExt cx="0" cy="0"/>
-        </a:xfrm>
-      </p:grpSpPr>
-      <p:sp>
-        <p:nvSpPr>
-          <p:cNvPr id="2" name="Text 0"/>
-          <p:cNvSpPr/>
-          <p:nvPr>
-            <p:ph idx="100" type="title" hasCustomPrompt="1"/>
-          </p:nvPr>
-        </p:nvSpPr>
-        <p:spPr>
-          <a:xfrm>
-            <a:off x="457200" y="274320"/>
-            <a:ext cx="8229600" cy="777240"/>
-          </a:xfrm>
-          <a:prstGeom prst="rect">
-            <a:avLst/>
-          </a:prstGeom>
-          <a:noFill/>
-          <a:ln/>
-        </p:spPr>
-        <p:txBody>
-          <a:bodyPr wrap="square" lIns="0" tIns="0" rIns="0" bIns="0" rtlCol="0" anchor="ctr"/>
-          <a:lstStyle/>
-          <a:p>
-            <a:pPr algn="l" indent="0" marL="0">
-              <a:buNone/>
-            </a:pPr>
-            <a:r>
-              <a:rPr lang="en-US" sz="3600" b="1" dirty="0">
-                <a:solidFill>
-                  <a:schemeClr val="bg1"/>
-                </a:solidFill>
-                <a:latin typeface="+mj-lt" pitchFamily="34" charset="0"/>
-                <a:ea typeface="+mj-lt" pitchFamily="34" charset="-122"/>
-                <a:cs typeface="+mj-lt" pitchFamily="34" charset="-120"/>
-              </a:rPr>
-              <a:t>What comes next</a:t>
-            </a:r>
-            <a:endParaRPr lang="en-US" sz="3600" dirty="0"/>
-          </a:p>
-        </p:txBody>
-      </p:sp>
-      <p:sp>
-        <p:nvSpPr>
-          <p:cNvPr id="3" name="closing-21-rect-1"/>
+      <p:sp>
+        <p:nvSpPr>
+          <p:cNvPr id="3" name="closing-20-rect-1"/>
           <p:cNvSpPr/>
           <p:nvPr/>
         </p:nvSpPr>
@@ -15390,7 +13315,7 @@
       </p:sp>
       <p:sp>
         <p:nvSpPr>
-          <p:cNvPr id="4" name="closing-21-text-2"/>
+          <p:cNvPr id="4" name="closing-20-text-2"/>
           <p:cNvSpPr txBox="1"/>
           <p:nvPr/>
         </p:nvSpPr>
@@ -15426,7 +13351,7 @@
       </p:sp>
       <p:sp>
         <p:nvSpPr>
-          <p:cNvPr id="5" name="closing-21-text-3"/>
+          <p:cNvPr id="5" name="closing-20-text-3"/>
           <p:cNvSpPr txBox="1"/>
           <p:nvPr/>
         </p:nvSpPr>
@@ -15462,7 +13387,7 @@
       </p:sp>
       <p:sp>
         <p:nvSpPr>
-          <p:cNvPr id="6" name="closing-21-rect-4"/>
+          <p:cNvPr id="6" name="closing-20-rect-4"/>
           <p:cNvSpPr/>
           <p:nvPr/>
         </p:nvSpPr>
@@ -15484,7 +13409,7 @@
       </p:sp>
       <p:sp>
         <p:nvSpPr>
-          <p:cNvPr id="7" name="closing-21-text-5"/>
+          <p:cNvPr id="7" name="closing-20-text-5"/>
           <p:cNvSpPr txBox="1"/>
           <p:nvPr/>
         </p:nvSpPr>
@@ -15520,7 +13445,7 @@
       </p:sp>
       <p:sp>
         <p:nvSpPr>
-          <p:cNvPr id="8" name="closing-21-text-6"/>
+          <p:cNvPr id="8" name="closing-20-text-6"/>
           <p:cNvSpPr txBox="1"/>
           <p:nvPr/>
         </p:nvSpPr>
@@ -15556,7 +13481,7 @@
       </p:sp>
       <p:sp>
         <p:nvSpPr>
-          <p:cNvPr id="9" name="closing-21-rect-7"/>
+          <p:cNvPr id="9" name="closing-20-rect-7"/>
           <p:cNvSpPr/>
           <p:nvPr/>
         </p:nvSpPr>
@@ -15578,7 +13503,7 @@
       </p:sp>
       <p:sp>
         <p:nvSpPr>
-          <p:cNvPr id="10" name="closing-21-text-8"/>
+          <p:cNvPr id="10" name="closing-20-text-8"/>
           <p:cNvSpPr txBox="1"/>
           <p:nvPr/>
         </p:nvSpPr>
@@ -15614,7 +13539,7 @@
       </p:sp>
       <p:sp>
         <p:nvSpPr>
-          <p:cNvPr id="11" name="closing-21-text-9"/>
+          <p:cNvPr id="11" name="closing-20-text-9"/>
           <p:cNvSpPr txBox="1"/>
           <p:nvPr/>
         </p:nvSpPr>
@@ -15650,7 +13575,7 @@
       </p:sp>
       <p:sp>
         <p:nvSpPr>
-          <p:cNvPr id="12" name="closing-21-rect-10"/>
+          <p:cNvPr id="12" name="closing-20-rect-10"/>
           <p:cNvSpPr/>
           <p:nvPr/>
         </p:nvSpPr>
@@ -15672,7 +13597,7 @@
       </p:sp>
       <p:sp>
         <p:nvSpPr>
-          <p:cNvPr id="13" name="closing-21-text-11"/>
+          <p:cNvPr id="13" name="closing-20-text-11"/>
           <p:cNvSpPr txBox="1"/>
           <p:nvPr/>
         </p:nvSpPr>
@@ -15708,7 +13633,7 @@
       </p:sp>
       <p:sp>
         <p:nvSpPr>
-          <p:cNvPr id="14" name="closing-21-text-12"/>
+          <p:cNvPr id="14" name="closing-20-text-12"/>
           <p:cNvSpPr txBox="1"/>
           <p:nvPr/>
         </p:nvSpPr>
@@ -15744,7 +13669,7 @@
       </p:sp>
       <p:sp>
         <p:nvSpPr>
-          <p:cNvPr id="15" name="closing-21-text-13"/>
+          <p:cNvPr id="15" name="closing-20-text-13"/>
           <p:cNvSpPr txBox="1"/>
           <p:nvPr/>
         </p:nvSpPr>
@@ -15783,7 +13708,7 @@
       </p:sp>
       <p:sp>
         <p:nvSpPr>
-          <p:cNvPr id="16" name="closing-21-text-14"/>
+          <p:cNvPr id="16" name="closing-20-text-14"/>
           <p:cNvSpPr txBox="1"/>
           <p:nvPr/>
         </p:nvSpPr>

</xml_diff>

<commit_message>
docs: remove edition and version labels from the reports, the report covers, the package notes and the deck caption
</commit_message>
<xml_diff>
--- a/submission/StudyRoute_Deck.pptx
+++ b/submission/StudyRoute_Deck.pptx
@@ -126,19 +126,19 @@
   <p:extLst>
     <p:ext uri="{521415D9-36F7-43E2-AB2F-B90AF26B5E84}">
       <p14:sectionLst xmlns:p14="http://schemas.microsoft.com/office/powerpoint/2010/main">
-        <p14:section name="Opening" id="{41d31ac0-0ea8-74ef-1832-d43a76621859}">
+        <p14:section name="Opening" id="{1500082e-aa91-477a-1105-2faebb79e682}">
           <p14:sldIdLst>
             <p14:sldId id="256"/>
             <p14:sldId id="257"/>
           </p14:sldIdLst>
         </p14:section>
-        <p14:section name="The problem" id="{0b5d19aa-4d38-e4fc-6440-f0434cbf518d}">
+        <p14:section name="The problem" id="{3e353e3a-efd3-941e-d542-86a6d28bbbe1}">
           <p14:sldIdLst>
             <p14:sldId id="258"/>
             <p14:sldId id="259"/>
           </p14:sldIdLst>
         </p14:section>
-        <p14:section name="The solution" id="{b19af7d6-6fd0-d0dc-7238-b5a5e06b72be}">
+        <p14:section name="The solution" id="{adef3268-bf21-da0a-7a43-54b44675b2e4}">
           <p14:sldIdLst>
             <p14:sldId id="260"/>
             <p14:sldId id="261"/>
@@ -146,7 +146,7 @@
             <p14:sldId id="263"/>
           </p14:sldIdLst>
         </p14:section>
-        <p14:section name="Trust" id="{2b1ecca8-c892-cb9c-e2f7-196628c1fa99}">
+        <p14:section name="Trust" id="{e8d10c3c-43f0-c76b-6cfa-08e0f6505429}">
           <p14:sldIdLst>
             <p14:sldId id="264"/>
             <p14:sldId id="265"/>
@@ -160,7 +160,7 @@
             <p14:sldId id="273"/>
           </p14:sldIdLst>
         </p14:section>
-        <p14:section name="Close" id="{07bc6671-a836-ecc0-4ea6-fbb768ef0779}">
+        <p14:section name="Close" id="{255e8ab2-79e4-b54e-a733-355c2b457e2a}">
           <p14:sldIdLst>
             <p14:sldId id="274"/>
             <p14:sldId id="275"/>
@@ -11515,7 +11515,7 @@
                   <a:schemeClr val="tx2"/>
                 </a:solidFill>
               </a:rPr>
-              <a:t>Source: security self-assessment, edition 1.2, sections 13 and 14: every record, the raw-log hashes and what each fix did and did not show.</a:t>
+              <a:t>Source: security self-assessment, sections 13 and 14: every record, the raw-log hashes and what each fix did and did not show.</a:t>
             </a:r>
             <a:endParaRPr lang="en-US" sz="1000" dirty="0"/>
           </a:p>

</xml_diff>

<commit_message>
docs+tests: close the fixture gap, add a 25-prompt assistant suite, and fix the report's open points
- Track backend/tests/data/explainer_cases.json (narrow .gitignore exception), so a fresh clone runs every test;
  the "reproducibility gap" paragraph is gone and all counts read 1,705 (1,704 pass, 1 symlink skip on Windows).
- New backend/tests/test_prompt_suite.py: 25 prompts with the intent, tool proposal and safety outcome each must
  produce (6 attacks blocked); 25 of 25 pass, reported in the summary and in section 5.
- Technical documentation: Bangla/Banglish support stated as it is; the plan's tool names mapped to the shipped
  tools; the five extra risk inputs named (all payment history, none of the removed artifact inputs); one line on
  who owned what; dated 19 October 2026.
- Deck, outline, TEST_CASES and the start page carry the same counts. Release manifest regenerated.
</commit_message>
<xml_diff>
--- a/submission/StudyRoute_Deck.pptx
+++ b/submission/StudyRoute_Deck.pptx
@@ -126,19 +126,19 @@
   <p:extLst>
     <p:ext uri="{521415D9-36F7-43E2-AB2F-B90AF26B5E84}">
       <p14:sectionLst xmlns:p14="http://schemas.microsoft.com/office/powerpoint/2010/main">
-        <p14:section name="Opening" id="{1500082e-aa91-477a-1105-2faebb79e682}">
+        <p14:section name="Opening" id="{ab999c93-b502-8248-7518-5b49044415a1}">
           <p14:sldIdLst>
             <p14:sldId id="256"/>
             <p14:sldId id="257"/>
           </p14:sldIdLst>
         </p14:section>
-        <p14:section name="The problem" id="{3e353e3a-efd3-941e-d542-86a6d28bbbe1}">
+        <p14:section name="The problem" id="{7133b365-cac8-0e5d-e4b5-99baad3264dc}">
           <p14:sldIdLst>
             <p14:sldId id="258"/>
             <p14:sldId id="259"/>
           </p14:sldIdLst>
         </p14:section>
-        <p14:section name="The solution" id="{adef3268-bf21-da0a-7a43-54b44675b2e4}">
+        <p14:section name="The solution" id="{3212477e-8994-b27f-a8d4-a97733ce9d5b}">
           <p14:sldIdLst>
             <p14:sldId id="260"/>
             <p14:sldId id="261"/>
@@ -146,7 +146,7 @@
             <p14:sldId id="263"/>
           </p14:sldIdLst>
         </p14:section>
-        <p14:section name="Trust" id="{e8d10c3c-43f0-c76b-6cfa-08e0f6505429}">
+        <p14:section name="Trust" id="{ae9ddbdf-d48b-db66-39d3-e5adfd7bb4ab}">
           <p14:sldIdLst>
             <p14:sldId id="264"/>
             <p14:sldId id="265"/>
@@ -160,7 +160,7 @@
             <p14:sldId id="273"/>
           </p14:sldIdLst>
         </p14:section>
-        <p14:section name="Close" id="{255e8ab2-79e4-b54e-a733-355c2b457e2a}">
+        <p14:section name="Close" id="{e6810f57-d3df-f06c-4c72-ced27b6697b1}">
           <p14:sldIdLst>
             <p14:sldId id="274"/>
             <p14:sldId id="275"/>
@@ -1307,7 +1307,7 @@
           <a:p>
             <a:r>
               <a:rPr lang="en-US" dirty="0"/>
-              <a:t>Everything we ran: 1,679 backend tests, one skipped on Windows; 463 web tests; 24 browser tests; all 24 scenarios mapped; 314 security probe records. On the right is GitHub's own page for our latest commit: all six CI jobs green. These are our own tests; a fresh clone runs 1,672 of 1,673, and no outside party has tested it.</a:t>
+              <a:t>Everything we ran: 1,705 backend tests, one skipped on Windows, including 25 assistant prompts that all give the expected tool and safety outcome; 463 web tests; 24 browser tests; all 24 scenarios pass; 314 security probe records. On the right is GitHub's own page for our latest commit: all six CI jobs green. These are our own tests, and no outside party has tested it yet.</a:t>
             </a:r>
             <a:endParaRPr lang="en-US" dirty="0"/>
           </a:p>
@@ -7488,7 +7488,7 @@
                 <a:ea typeface="+mj-lt" pitchFamily="34" charset="-122"/>
                 <a:cs typeface="+mj-lt" pitchFamily="34" charset="-120"/>
               </a:rPr>
-              <a:t>1,679</a:t>
+              <a:t>1,705</a:t>
             </a:r>
             <a:endParaRPr lang="en-US" sz="2400" dirty="0"/>
           </a:p>
@@ -7524,7 +7524,7 @@
                   <a:schemeClr val="tx2"/>
                 </a:solidFill>
               </a:rPr>
-              <a:t>backend tests (1,678 pass, 1 skipped)</a:t>
+              <a:t>backend tests, incl. 25 assistant prompts (25 of 25 pass)</a:t>
             </a:r>
             <a:endParaRPr lang="en-US" sz="1050" dirty="0"/>
           </a:p>
@@ -8139,7 +8139,7 @@
                   <a:schemeClr val="tx2"/>
                 </a:solidFill>
               </a:rPr>
-              <a:t>Our own tests. A fresh clone runs 1,672 of 1,673 (one module needs an excluded fixture). No independent test yet.</a:t>
+              <a:t>Our own tests: a fresh clone runs the same 1,705. No independent test yet.</a:t>
             </a:r>
             <a:endParaRPr lang="en-US" sz="1100" dirty="0"/>
           </a:p>

</xml_diff>